<commit_message>
Deck slide 2 spacing; README tool run order
Co-Authored-By: Claude Fable 5.1 <noreply@anthropic.com>
</commit_message>
<xml_diff>
--- a/deck/LoadSafetyGate_deck.pptx
+++ b/deck/LoadSafetyGate_deck.pptx
@@ -116,22 +116,22 @@
   <p:extLst>
     <p:ext uri="{521415D9-36F7-43E2-AB2F-B90AF26B5E84}">
       <p14:sectionLst xmlns:p14="http://schemas.microsoft.com/office/powerpoint/2010/main">
-        <p14:section name="Opening" id="{461830f6-5461-7774-e9f7-a3a47cf028f3}">
+        <p14:section name="Opening" id="{4b9664ef-1652-0021-7b42-c0eabd1cadc2}">
           <p14:sldIdLst>
             <p14:sldId id="256"/>
           </p14:sldIdLst>
         </p14:section>
-        <p14:section name="Problem" id="{785eceb3-248b-507b-e059-a9ad7662396d}">
+        <p14:section name="Problem" id="{58fcf6f1-f144-cf50-a82c-322fdf7b25c8}">
           <p14:sldIdLst>
             <p14:sldId id="257"/>
           </p14:sldIdLst>
         </p14:section>
-        <p14:section name="Demo" id="{69a112ac-d9ae-5d0e-245a-b3a15c3d4a16}">
+        <p14:section name="Demo" id="{6ac8a48e-4955-d5e4-d2d6-b833af056570}">
           <p14:sldIdLst>
             <p14:sldId id="258"/>
           </p14:sldIdLst>
         </p14:section>
-        <p14:section name="Technology" id="{f2874550-efa5-bdc4-06f7-980ce216d654}">
+        <p14:section name="Technology" id="{f1edc702-0062-2583-9dea-6b44c75908bb}">
           <p14:sldIdLst>
             <p14:sldId id="259"/>
             <p14:sldId id="260"/>
@@ -140,7 +140,7 @@
             <p14:sldId id="263"/>
           </p14:sldIdLst>
         </p14:section>
-        <p14:section name="Business" id="{41723876-39d2-74b6-c97b-ef348caec78e}">
+        <p14:section name="Business" id="{8fe93c09-8342-6237-d983-5859bc25c6ee}">
           <p14:sldIdLst>
             <p14:sldId id="264"/>
             <p14:sldId id="265"/>
@@ -2909,7 +2909,7 @@
         <p:spPr>
           <a:xfrm>
             <a:off x="457200" y="1188720"/>
-            <a:ext cx="5486400" cy="1143000"/>
+            <a:ext cx="5486400" cy="1188720"/>
           </a:xfrm>
           <a:prstGeom prst="rect">
             <a:avLst/>
@@ -2994,8 +2994,8 @@
         </p:nvSpPr>
         <p:spPr>
           <a:xfrm>
-            <a:off x="640080" y="1874520"/>
-            <a:ext cx="5120640" cy="320040"/>
+            <a:off x="640080" y="1810512"/>
+            <a:ext cx="5120640" cy="475488"/>
           </a:xfrm>
           <a:prstGeom prst="rect">
             <a:avLst/>
@@ -3011,14 +3011,14 @@
               <a:buNone/>
             </a:pPr>
             <a:r>
-              <a:rPr lang="en-US" sz="1300" dirty="0">
+              <a:rPr lang="en-US" sz="1200" dirty="0">
                 <a:solidFill>
                   <a:schemeClr val="tx2"/>
                 </a:solidFill>
               </a:rPr>
-              <a:t>The gate operator or dispatcher at a freight terminal, a fleet depot, or a dealer receiving yard. One photo, one answer, before the truck leaves.</a:t>
+              <a:t>Gate operator or dispatcher at a terminal, fleet depot or dealer receiving yard. One photo, one answer, before the truck leaves.</a:t>
             </a:r>
-            <a:endParaRPr lang="en-US" sz="1300" dirty="0"/>
+            <a:endParaRPr lang="en-US" sz="1200" dirty="0"/>
           </a:p>
         </p:txBody>
       </p:sp>
@@ -3030,8 +3030,8 @@
         </p:nvSpPr>
         <p:spPr>
           <a:xfrm>
-            <a:off x="457200" y="2441448"/>
-            <a:ext cx="5486400" cy="1143000"/>
+            <a:off x="457200" y="2487168"/>
+            <a:ext cx="5486400" cy="1188720"/>
           </a:xfrm>
           <a:prstGeom prst="rect">
             <a:avLst/>
@@ -3055,7 +3055,7 @@
         </p:nvSpPr>
         <p:spPr>
           <a:xfrm>
-            <a:off x="640080" y="2624328"/>
+            <a:off x="640080" y="2670048"/>
             <a:ext cx="384048" cy="384048"/>
           </a:xfrm>
           <a:prstGeom prst="ellipse">
@@ -3080,7 +3080,7 @@
         </p:nvSpPr>
         <p:spPr>
           <a:xfrm>
-            <a:off x="1143000" y="2578608"/>
+            <a:off x="1143000" y="2624328"/>
             <a:ext cx="4617720" cy="457200"/>
           </a:xfrm>
           <a:prstGeom prst="rect">
@@ -3116,8 +3116,8 @@
         </p:nvSpPr>
         <p:spPr>
           <a:xfrm>
-            <a:off x="640080" y="3127248"/>
-            <a:ext cx="5120640" cy="320040"/>
+            <a:off x="640080" y="3108960"/>
+            <a:ext cx="5120640" cy="475488"/>
           </a:xfrm>
           <a:prstGeom prst="rect">
             <a:avLst/>
@@ -3133,14 +3133,14 @@
               <a:buNone/>
             </a:pPr>
             <a:r>
-              <a:rPr lang="en-US" sz="1300" dirty="0">
+              <a:rPr lang="en-US" sz="1200" dirty="0">
                 <a:solidFill>
                   <a:schemeClr val="tx2"/>
                 </a:solidFill>
               </a:rPr>
-              <a:t>Shifted or one-sided loads roll over. Overhanging cargo hits bridges, signs and other vehicles. Oversized loads draw fines and stop the truck at the first police post.</a:t>
+              <a:t>One-sided loads roll over. Overhanging cargo hits bridges and other vehicles. Oversized loads draw fines and stop the truck at the first police post.</a:t>
             </a:r>
-            <a:endParaRPr lang="en-US" sz="1300" dirty="0"/>
+            <a:endParaRPr lang="en-US" sz="1200" dirty="0"/>
           </a:p>
         </p:txBody>
       </p:sp>
@@ -3152,8 +3152,8 @@
         </p:nvSpPr>
         <p:spPr>
           <a:xfrm>
-            <a:off x="457200" y="3694176"/>
-            <a:ext cx="5486400" cy="1234440"/>
+            <a:off x="457200" y="3785616"/>
+            <a:ext cx="5486400" cy="1188720"/>
           </a:xfrm>
           <a:prstGeom prst="rect">
             <a:avLst/>
@@ -3177,7 +3177,7 @@
         </p:nvSpPr>
         <p:spPr>
           <a:xfrm>
-            <a:off x="640080" y="3877056"/>
+            <a:off x="640080" y="3968496"/>
             <a:ext cx="384048" cy="384048"/>
           </a:xfrm>
           <a:prstGeom prst="ellipse">
@@ -3202,7 +3202,7 @@
         </p:nvSpPr>
         <p:spPr>
           <a:xfrm>
-            <a:off x="1143000" y="3831336"/>
+            <a:off x="1143000" y="3922776"/>
             <a:ext cx="4617720" cy="457200"/>
           </a:xfrm>
           <a:prstGeom prst="rect">
@@ -3238,8 +3238,8 @@
         </p:nvSpPr>
         <p:spPr>
           <a:xfrm>
-            <a:off x="640080" y="4379976"/>
-            <a:ext cx="5120640" cy="411480"/>
+            <a:off x="640080" y="4407408"/>
+            <a:ext cx="5120640" cy="475488"/>
           </a:xfrm>
           <a:prstGeom prst="rect">
             <a:avLst/>
@@ -3255,14 +3255,14 @@
               <a:buNone/>
             </a:pPr>
             <a:r>
-              <a:rPr lang="en-US" sz="1300" dirty="0">
+              <a:rPr lang="en-US" sz="1200" dirty="0">
                 <a:solidFill>
                   <a:schemeClr val="tx2"/>
                 </a:solidFill>
               </a:rPr>
-              <a:t>The fleet owner or terminal, per gate. Partner angle: every Toyota and BYD arrives on a car carrier into a Royal Motors yard. Car carriers are the classic over-height and rear-overhang offenders.</a:t>
+              <a:t>Fleet owner or terminal, per gate. Every Toyota and BYD arrives on a car carrier into a Royal Motors yard, and car carriers are the classic over-height and rear-overhang offenders.</a:t>
             </a:r>
-            <a:endParaRPr lang="en-US" sz="1300" dirty="0"/>
+            <a:endParaRPr lang="en-US" sz="1200" dirty="0"/>
           </a:p>
         </p:txBody>
       </p:sp>
@@ -3274,8 +3274,8 @@
         </p:nvSpPr>
         <p:spPr>
           <a:xfrm>
-            <a:off x="457200" y="5038344"/>
-            <a:ext cx="5486400" cy="1143000"/>
+            <a:off x="457200" y="5084064"/>
+            <a:ext cx="5486400" cy="1188720"/>
           </a:xfrm>
           <a:prstGeom prst="rect">
             <a:avLst/>
@@ -3299,7 +3299,7 @@
         </p:nvSpPr>
         <p:spPr>
           <a:xfrm>
-            <a:off x="640080" y="5221224"/>
+            <a:off x="640080" y="5266944"/>
             <a:ext cx="384048" cy="384048"/>
           </a:xfrm>
           <a:prstGeom prst="ellipse">
@@ -3324,7 +3324,7 @@
         </p:nvSpPr>
         <p:spPr>
           <a:xfrm>
-            <a:off x="1143000" y="5175504"/>
+            <a:off x="1143000" y="5221224"/>
             <a:ext cx="4617720" cy="457200"/>
           </a:xfrm>
           <a:prstGeom prst="rect">
@@ -3360,8 +3360,8 @@
         </p:nvSpPr>
         <p:spPr>
           <a:xfrm>
-            <a:off x="640080" y="5724144"/>
-            <a:ext cx="5120640" cy="320040"/>
+            <a:off x="640080" y="5705856"/>
+            <a:ext cx="5120640" cy="475488"/>
           </a:xfrm>
           <a:prstGeom prst="rect">
             <a:avLst/>
@@ -3377,14 +3377,14 @@
               <a:buNone/>
             </a:pPr>
             <a:r>
-              <a:rPr lang="en-US" sz="1300" dirty="0">
+              <a:rPr lang="en-US" sz="1200" dirty="0">
                 <a:solidFill>
                   <a:schemeClr val="tx2"/>
                 </a:solidFill>
               </a:rPr>
               <a:t>Uzbekistan Decree 342, Annex 2: height 4.0 m, width 2.55 m, rear protrusion 2 m. Nobody measures it at the gate.</a:t>
             </a:r>
-            <a:endParaRPr lang="en-US" sz="1300" dirty="0"/>
+            <a:endParaRPr lang="en-US" sz="1200" dirty="0"/>
           </a:p>
         </p:txBody>
       </p:sp>
@@ -5041,8 +5041,8 @@
         </p:nvSpPr>
         <p:spPr>
           <a:xfrm>
-            <a:off x="640080" y="5440680"/>
-            <a:ext cx="5120640" cy="640080"/>
+            <a:off x="640080" y="5376672"/>
+            <a:ext cx="5120640" cy="749808"/>
           </a:xfrm>
           <a:prstGeom prst="rect">
             <a:avLst/>
@@ -5058,14 +5058,14 @@
               <a:buNone/>
             </a:pPr>
             <a:r>
-              <a:rPr lang="en-US" sz="1300" dirty="0">
+              <a:rPr lang="en-US" sz="1200" dirty="0">
                 <a:solidFill>
                   <a:schemeClr val="tx2"/>
                 </a:solidFill>
               </a:rPr>
               <a:t>Privacy stage, wheel finder, geometry, decision rules, the 301-image licensed set, the 120-image labelled evaluation, the app and the deployment.</a:t>
             </a:r>
-            <a:endParaRPr lang="en-US" sz="1300" dirty="0"/>
+            <a:endParaRPr lang="en-US" sz="1200" dirty="0"/>
           </a:p>
         </p:txBody>
       </p:sp>
@@ -5163,8 +5163,8 @@
         </p:nvSpPr>
         <p:spPr>
           <a:xfrm>
-            <a:off x="6400800" y="5440680"/>
-            <a:ext cx="5120640" cy="640080"/>
+            <a:off x="6400800" y="5376672"/>
+            <a:ext cx="5120640" cy="749808"/>
           </a:xfrm>
           <a:prstGeom prst="rect">
             <a:avLst/>
@@ -5180,14 +5180,14 @@
               <a:buNone/>
             </a:pPr>
             <a:r>
-              <a:rPr lang="en-US" sz="1300" dirty="0">
+              <a:rPr lang="en-US" sz="1200" dirty="0">
                 <a:solidFill>
                   <a:schemeClr val="tx2"/>
                 </a:solidFill>
               </a:rPr>
               <a:t>Two pretrained Ultralytics models (AGPL-3.0). Open-vocabulary prompts, no fine-tuning needed for the demo. Runs on CPU in 0.19 s per image.</a:t>
             </a:r>
-            <a:endParaRPr lang="en-US" sz="1300" dirty="0"/>
+            <a:endParaRPr lang="en-US" sz="1200" dirty="0"/>
           </a:p>
         </p:txBody>
       </p:sp>
@@ -5393,8 +5393,8 @@
         </p:nvSpPr>
         <p:spPr>
           <a:xfrm>
-            <a:off x="640080" y="2057400"/>
-            <a:ext cx="3291840" cy="2468880"/>
+            <a:off x="640080" y="1993392"/>
+            <a:ext cx="3291840" cy="2578608"/>
           </a:xfrm>
           <a:prstGeom prst="rect">
             <a:avLst/>
@@ -5410,14 +5410,14 @@
               <a:buNone/>
             </a:pPr>
             <a:r>
-              <a:rPr lang="en-US" sz="1300" dirty="0">
+              <a:rPr lang="en-US" sz="1200" dirty="0">
                 <a:solidFill>
                   <a:schemeClr val="tx2"/>
                 </a:solidFill>
               </a:rPr>
               <a:t>Horizontal edges converge under perspective, so a level truck looks tilted if you compare top and bottom edges. We use the body's vertical edges instead: left and right halves converge in opposite directions and their mean cancels perspective. Reference: vertical lines in the scene (poles, walls), else the camera vertical at lower confidence.</a:t>
             </a:r>
-            <a:endParaRPr lang="en-US" sz="1300" dirty="0"/>
+            <a:endParaRPr lang="en-US" sz="1200" dirty="0"/>
           </a:p>
         </p:txBody>
       </p:sp>
@@ -5515,8 +5515,8 @@
         </p:nvSpPr>
         <p:spPr>
           <a:xfrm>
-            <a:off x="4434840" y="2057400"/>
-            <a:ext cx="3291840" cy="2468880"/>
+            <a:off x="4434840" y="1993392"/>
+            <a:ext cx="3291840" cy="2578608"/>
           </a:xfrm>
           <a:prstGeom prst="rect">
             <a:avLst/>
@@ -5532,14 +5532,14 @@
               <a:buNone/>
             </a:pPr>
             <a:r>
-              <a:rPr lang="en-US" sz="1300" dirty="0">
+              <a:rPr lang="en-US" sz="1200" dirty="0">
                 <a:solidFill>
                   <a:schemeClr val="tx2"/>
                 </a:solidFill>
               </a:rPr>
               <a:t>Cargo extent beyond the body edge at cargo height. Rear overhang in a side view, side overhang in a rear view. Converted to centimetres with a known object in the same image: body width 2.55 m or wheel diameter 1.05 m.</a:t>
             </a:r>
-            <a:endParaRPr lang="en-US" sz="1300" dirty="0"/>
+            <a:endParaRPr lang="en-US" sz="1200" dirty="0"/>
           </a:p>
         </p:txBody>
       </p:sp>
@@ -5637,8 +5637,8 @@
         </p:nvSpPr>
         <p:spPr>
           <a:xfrm>
-            <a:off x="8229600" y="2057400"/>
-            <a:ext cx="3291840" cy="2468880"/>
+            <a:off x="8229600" y="1993392"/>
+            <a:ext cx="3291840" cy="2578608"/>
           </a:xfrm>
           <a:prstGeom prst="rect">
             <a:avLst/>
@@ -5654,14 +5654,14 @@
               <a:buNone/>
             </a:pPr>
             <a:r>
-              <a:rPr lang="en-US" sz="1300" dirty="0">
+              <a:rPr lang="en-US" sz="1200" dirty="0">
                 <a:solidFill>
                   <a:schemeClr val="tx2"/>
                 </a:solidFill>
               </a:rPr>
               <a:t>Ground line through the tyre contact points to the top of cargo or body, same scale. Compared with the 4.0 m legal limit.</a:t>
             </a:r>
-            <a:endParaRPr lang="en-US" sz="1300" dirty="0"/>
+            <a:endParaRPr lang="en-US" sz="1200" dirty="0"/>
           </a:p>
         </p:txBody>
       </p:sp>
@@ -5759,8 +5759,8 @@
         </p:nvSpPr>
         <p:spPr>
           <a:xfrm>
-            <a:off x="640080" y="5532120"/>
-            <a:ext cx="10881360" cy="457200"/>
+            <a:off x="640080" y="5468112"/>
+            <a:ext cx="10881360" cy="566928"/>
           </a:xfrm>
           <a:prstGeom prst="rect">
             <a:avLst/>
@@ -5776,14 +5776,14 @@
               <a:buNone/>
             </a:pPr>
             <a:r>
-              <a:rPr lang="en-US" sz="1300" dirty="0">
+              <a:rPr lang="en-US" sz="1200" dirty="0">
                 <a:solidFill>
                   <a:schemeClr val="tx2"/>
                 </a:solidFill>
               </a:rPr>
               <a:t>A fixed gate camera with known position and a reference marker removes the remaining ambiguity. The phone mode you see today is the degraded fallback, and it says CANNOT ASSESS when the view does not support a measurement.</a:t>
             </a:r>
-            <a:endParaRPr lang="en-US" sz="1300" dirty="0"/>
+            <a:endParaRPr lang="en-US" sz="1200" dirty="0"/>
           </a:p>
         </p:txBody>
       </p:sp>
@@ -10139,8 +10139,8 @@
         </p:nvSpPr>
         <p:spPr>
           <a:xfrm>
-            <a:off x="640080" y="6080760"/>
-            <a:ext cx="10881360" cy="45720"/>
+            <a:off x="640080" y="6016752"/>
+            <a:ext cx="10881360" cy="155448"/>
           </a:xfrm>
           <a:prstGeom prst="rect">
             <a:avLst/>
@@ -10156,14 +10156,14 @@
               <a:buNone/>
             </a:pPr>
             <a:r>
-              <a:rPr lang="en-US" sz="1300" dirty="0">
+              <a:rPr lang="en-US" sz="1200" dirty="0">
                 <a:solidFill>
                   <a:schemeClr val="tx2"/>
                 </a:solidFill>
               </a:rPr>
               <a:t>Every check reports a confidence and is skipped below a floor. A skipped check is shown as such, never as a pass.</a:t>
             </a:r>
-            <a:endParaRPr lang="en-US" sz="1300" dirty="0"/>
+            <a:endParaRPr lang="en-US" sz="1200" dirty="0"/>
           </a:p>
         </p:txBody>
       </p:sp>
@@ -12754,8 +12754,8 @@
         </p:nvSpPr>
         <p:spPr>
           <a:xfrm>
-            <a:off x="640080" y="4892040"/>
-            <a:ext cx="5394960" cy="1188720"/>
+            <a:off x="640080" y="4828032"/>
+            <a:ext cx="5394960" cy="1298448"/>
           </a:xfrm>
           <a:prstGeom prst="rect">
             <a:avLst/>
@@ -12771,14 +12771,14 @@
               <a:buNone/>
             </a:pPr>
             <a:r>
-              <a:rPr lang="en-US" sz="1300" dirty="0">
+              <a:rPr lang="en-US" sz="1200" dirty="0">
                 <a:solidFill>
                   <a:schemeClr val="tx2"/>
                 </a:solidFill>
               </a:rPr>
               <a:t>Price per gate per month, software only. Compute per inspection is below $0.001, so margin is in the subscription, not the inference. One server serves dozens of gates.</a:t>
             </a:r>
-            <a:endParaRPr lang="en-US" sz="1300" dirty="0"/>
+            <a:endParaRPr lang="en-US" sz="1200" dirty="0"/>
           </a:p>
         </p:txBody>
       </p:sp>
@@ -12876,8 +12876,8 @@
         </p:nvSpPr>
         <p:spPr>
           <a:xfrm>
-            <a:off x="6583680" y="4892040"/>
-            <a:ext cx="4937760" cy="1188720"/>
+            <a:off x="6583680" y="4828032"/>
+            <a:ext cx="4937760" cy="1298448"/>
           </a:xfrm>
           <a:prstGeom prst="rect">
             <a:avLst/>
@@ -12893,14 +12893,14 @@
               <a:buNone/>
             </a:pPr>
             <a:r>
-              <a:rPr lang="en-US" sz="1300" dirty="0">
+              <a:rPr lang="en-US" sz="1200" dirty="0">
                 <a:solidFill>
                   <a:schemeClr val="tx2"/>
                 </a:solidFill>
               </a:rPr>
               <a:t>Payback months = pilot cost / (avoided loss per month). Fill the [confirm] cells with the fleet's own figures and the formula gives the answer on the spot.</a:t>
             </a:r>
-            <a:endParaRPr lang="en-US" sz="1300" dirty="0"/>
+            <a:endParaRPr lang="en-US" sz="1200" dirty="0"/>
           </a:p>
         </p:txBody>
       </p:sp>

</xml_diff>

<commit_message>
Eval on 43 team labels: honest metrics in README and deck; conservative height/overhang gating; car wheels excluded from scale
Co-Authored-By: Claude Fable 5.1 <noreply@anthropic.com>
</commit_message>
<xml_diff>
--- a/deck/LoadSafetyGate_deck.pptx
+++ b/deck/LoadSafetyGate_deck.pptx
@@ -116,22 +116,22 @@
   <p:extLst>
     <p:ext uri="{521415D9-36F7-43E2-AB2F-B90AF26B5E84}">
       <p14:sectionLst xmlns:p14="http://schemas.microsoft.com/office/powerpoint/2010/main">
-        <p14:section name="Opening" id="{4b9664ef-1652-0021-7b42-c0eabd1cadc2}">
+        <p14:section name="Opening" id="{7898120b-7601-4eba-66bb-7c30c9dd3aed}">
           <p14:sldIdLst>
             <p14:sldId id="256"/>
           </p14:sldIdLst>
         </p14:section>
-        <p14:section name="Problem" id="{58fcf6f1-f144-cf50-a82c-322fdf7b25c8}">
+        <p14:section name="Problem" id="{76c343fc-2d07-c836-bde4-f7c661bb092e}">
           <p14:sldIdLst>
             <p14:sldId id="257"/>
           </p14:sldIdLst>
         </p14:section>
-        <p14:section name="Demo" id="{6ac8a48e-4955-d5e4-d2d6-b833af056570}">
+        <p14:section name="Demo" id="{86447430-332e-e288-174a-aec50e92b09d}">
           <p14:sldIdLst>
             <p14:sldId id="258"/>
           </p14:sldIdLst>
         </p14:section>
-        <p14:section name="Technology" id="{f1edc702-0062-2583-9dea-6b44c75908bb}">
+        <p14:section name="Technology" id="{d40d84de-30f5-8a51-1918-580ee362a529}">
           <p14:sldIdLst>
             <p14:sldId id="259"/>
             <p14:sldId id="260"/>
@@ -140,7 +140,7 @@
             <p14:sldId id="263"/>
           </p14:sldIdLst>
         </p14:section>
-        <p14:section name="Business" id="{8fe93c09-8342-6237-d983-5859bc25c6ee}">
+        <p14:section name="Business" id="{c1e48c74-3182-7d2a-89a2-70bc4b38ec29}">
           <p14:sldIdLst>
             <p14:sldId id="264"/>
             <p14:sldId id="265"/>
@@ -5889,7 +5889,7 @@
                   <a:srgbClr val="1B1F23"/>
                 </a:solidFill>
               </a:rPr>
-              <a:t>Measured on a test set we built</a:t>
+              <a:t>Measured on a test set we built, including the bad news</a:t>
             </a:r>
             <a:endParaRPr lang="en-US" sz="3200" dirty="0"/>
           </a:p>
@@ -8309,7 +8309,7 @@
                             <a:schemeClr val="bg1"/>
                           </a:solidFill>
                         </a:rPr>
-                        <a:t>n</a:t>
+                        <a:t>tp/fp/fn</a:t>
                       </a:r>
                       <a:endParaRPr lang="en-US" sz="1200" dirty="0"/>
                     </a:p>
@@ -8430,7 +8430,7 @@
                             <a:schemeClr val="tx1"/>
                           </a:solidFill>
                         </a:rPr>
-                        <a:t>pending</a:t>
+                        <a:t>0.00</a:t>
                       </a:r>
                       <a:endParaRPr lang="en-US" sz="1200" dirty="0"/>
                     </a:p>
@@ -8488,7 +8488,7 @@
                             <a:schemeClr val="tx1"/>
                           </a:solidFill>
                         </a:rPr>
-                        <a:t>pending</a:t>
+                        <a:t>0.00</a:t>
                       </a:r>
                       <a:endParaRPr lang="en-US" sz="1200" dirty="0"/>
                     </a:p>
@@ -8540,6 +8540,14 @@
                       <a:pPr indent="0" marL="0">
                         <a:buNone/>
                       </a:pPr>
+                      <a:r>
+                        <a:rPr lang="en-US" sz="1200" dirty="0">
+                          <a:solidFill>
+                            <a:schemeClr val="tx1"/>
+                          </a:solidFill>
+                        </a:rPr>
+                        <a:t>0/2/2</a:t>
+                      </a:r>
                       <a:endParaRPr lang="en-US" sz="1200" dirty="0"/>
                     </a:p>
                   </a:txBody>
@@ -8656,7 +8664,7 @@
                             <a:schemeClr val="tx1"/>
                           </a:solidFill>
                         </a:rPr>
-                        <a:t>pending</a:t>
+                        <a:t>0.00</a:t>
                       </a:r>
                       <a:endParaRPr lang="en-US" sz="1200" dirty="0"/>
                     </a:p>
@@ -8714,7 +8722,7 @@
                             <a:schemeClr val="tx1"/>
                           </a:solidFill>
                         </a:rPr>
-                        <a:t>pending</a:t>
+                        <a:t>0.00</a:t>
                       </a:r>
                       <a:endParaRPr lang="en-US" sz="1200" dirty="0"/>
                     </a:p>
@@ -8766,6 +8774,14 @@
                       <a:pPr indent="0" marL="0">
                         <a:buNone/>
                       </a:pPr>
+                      <a:r>
+                        <a:rPr lang="en-US" sz="1200" dirty="0">
+                          <a:solidFill>
+                            <a:schemeClr val="tx1"/>
+                          </a:solidFill>
+                        </a:rPr>
+                        <a:t>0/1/4</a:t>
+                      </a:r>
                       <a:endParaRPr lang="en-US" sz="1200" dirty="0"/>
                     </a:p>
                   </a:txBody>
@@ -8882,7 +8898,7 @@
                             <a:schemeClr val="tx1"/>
                           </a:solidFill>
                         </a:rPr>
-                        <a:t>pending</a:t>
+                        <a:t>n/a</a:t>
                       </a:r>
                       <a:endParaRPr lang="en-US" sz="1200" dirty="0"/>
                     </a:p>
@@ -8940,7 +8956,7 @@
                             <a:schemeClr val="tx1"/>
                           </a:solidFill>
                         </a:rPr>
-                        <a:t>pending</a:t>
+                        <a:t>0.00</a:t>
                       </a:r>
                       <a:endParaRPr lang="en-US" sz="1200" dirty="0"/>
                     </a:p>
@@ -8992,6 +9008,14 @@
                       <a:pPr indent="0" marL="0">
                         <a:buNone/>
                       </a:pPr>
+                      <a:r>
+                        <a:rPr lang="en-US" sz="1200" dirty="0">
+                          <a:solidFill>
+                            <a:schemeClr val="tx1"/>
+                          </a:solidFill>
+                        </a:rPr>
+                        <a:t>0/0/1</a:t>
+                      </a:r>
                       <a:endParaRPr lang="en-US" sz="1200" dirty="0"/>
                     </a:p>
                   </a:txBody>
@@ -9108,7 +9132,7 @@
                             <a:schemeClr val="tx1"/>
                           </a:solidFill>
                         </a:rPr>
-                        <a:t>pending</a:t>
+                        <a:t>0.00</a:t>
                       </a:r>
                       <a:endParaRPr lang="en-US" sz="1200" dirty="0"/>
                     </a:p>
@@ -9166,7 +9190,7 @@
                             <a:schemeClr val="tx1"/>
                           </a:solidFill>
                         </a:rPr>
-                        <a:t>pending</a:t>
+                        <a:t>0.00</a:t>
                       </a:r>
                       <a:endParaRPr lang="en-US" sz="1200" dirty="0"/>
                     </a:p>
@@ -9218,6 +9242,14 @@
                       <a:pPr indent="0" marL="0">
                         <a:buNone/>
                       </a:pPr>
+                      <a:r>
+                        <a:rPr lang="en-US" sz="1200" dirty="0">
+                          <a:solidFill>
+                            <a:schemeClr val="tx1"/>
+                          </a:solidFill>
+                        </a:rPr>
+                        <a:t>0/1/4</a:t>
+                      </a:r>
                       <a:endParaRPr lang="en-US" sz="1200" dirty="0"/>
                     </a:p>
                   </a:txBody>
@@ -9276,7 +9308,7 @@
                             <a:schemeClr val="tx1"/>
                           </a:solidFill>
                         </a:rPr>
-                        <a:t>Night / rain subset</a:t>
+                        <a:t>Clean images, no false alarm</a:t>
                       </a:r>
                       <a:endParaRPr lang="en-US" sz="1200" dirty="0"/>
                     </a:p>
@@ -9334,8 +9366,58 @@
                             <a:schemeClr val="tx1"/>
                           </a:solidFill>
                         </a:rPr>
-                        <a:t>pending</a:t>
+                        <a:t>18 of 20</a:t>
                       </a:r>
+                      <a:endParaRPr lang="en-US" sz="1200" dirty="0"/>
+                    </a:p>
+                  </a:txBody>
+                  <a:tcPr marL="91440" marR="91440" marT="45720" marB="45720">
+                    <a:lnL w="12700" cap="flat" cmpd="sng" algn="ctr">
+                      <a:solidFill>
+                        <a:srgbClr val="EEF0EC"/>
+                      </a:solidFill>
+                      <a:prstDash val="solid"/>
+                      <a:round/>
+                      <a:headEnd type="none" w="med" len="med"/>
+                      <a:tailEnd type="none" w="med" len="med"/>
+                    </a:lnL>
+                    <a:lnR w="12700" cap="flat" cmpd="sng" algn="ctr">
+                      <a:solidFill>
+                        <a:srgbClr val="EEF0EC"/>
+                      </a:solidFill>
+                      <a:prstDash val="solid"/>
+                      <a:round/>
+                      <a:headEnd type="none" w="med" len="med"/>
+                      <a:tailEnd type="none" w="med" len="med"/>
+                    </a:lnR>
+                    <a:lnT w="12700" cap="flat" cmpd="sng" algn="ctr">
+                      <a:solidFill>
+                        <a:srgbClr val="EEF0EC"/>
+                      </a:solidFill>
+                      <a:prstDash val="solid"/>
+                      <a:round/>
+                      <a:headEnd type="none" w="med" len="med"/>
+                      <a:tailEnd type="none" w="med" len="med"/>
+                    </a:lnT>
+                    <a:lnB w="12700" cap="flat" cmpd="sng" algn="ctr">
+                      <a:solidFill>
+                        <a:srgbClr val="EEF0EC"/>
+                      </a:solidFill>
+                      <a:prstDash val="solid"/>
+                      <a:round/>
+                      <a:headEnd type="none" w="med" len="med"/>
+                      <a:tailEnd type="none" w="med" len="med"/>
+                    </a:lnB>
+                  </a:tcPr>
+                </a:tc>
+                <a:tc>
+                  <a:txBody>
+                    <a:bodyPr/>
+                    <a:lstStyle/>
+                    <a:p>
+                      <a:pPr indent="0" marL="0">
+                        <a:buNone/>
+                      </a:pPr>
                       <a:endParaRPr lang="en-US" sz="1200" dirty="0"/>
                     </a:p>
                   </a:txBody>
@@ -9392,65 +9474,7 @@
                             <a:schemeClr val="tx1"/>
                           </a:solidFill>
                         </a:rPr>
-                        <a:t>pending</a:t>
-                      </a:r>
-                      <a:endParaRPr lang="en-US" sz="1200" dirty="0"/>
-                    </a:p>
-                  </a:txBody>
-                  <a:tcPr marL="91440" marR="91440" marT="45720" marB="45720">
-                    <a:lnL w="12700" cap="flat" cmpd="sng" algn="ctr">
-                      <a:solidFill>
-                        <a:srgbClr val="EEF0EC"/>
-                      </a:solidFill>
-                      <a:prstDash val="solid"/>
-                      <a:round/>
-                      <a:headEnd type="none" w="med" len="med"/>
-                      <a:tailEnd type="none" w="med" len="med"/>
-                    </a:lnL>
-                    <a:lnR w="12700" cap="flat" cmpd="sng" algn="ctr">
-                      <a:solidFill>
-                        <a:srgbClr val="EEF0EC"/>
-                      </a:solidFill>
-                      <a:prstDash val="solid"/>
-                      <a:round/>
-                      <a:headEnd type="none" w="med" len="med"/>
-                      <a:tailEnd type="none" w="med" len="med"/>
-                    </a:lnR>
-                    <a:lnT w="12700" cap="flat" cmpd="sng" algn="ctr">
-                      <a:solidFill>
-                        <a:srgbClr val="EEF0EC"/>
-                      </a:solidFill>
-                      <a:prstDash val="solid"/>
-                      <a:round/>
-                      <a:headEnd type="none" w="med" len="med"/>
-                      <a:tailEnd type="none" w="med" len="med"/>
-                    </a:lnT>
-                    <a:lnB w="12700" cap="flat" cmpd="sng" algn="ctr">
-                      <a:solidFill>
-                        <a:srgbClr val="EEF0EC"/>
-                      </a:solidFill>
-                      <a:prstDash val="solid"/>
-                      <a:round/>
-                      <a:headEnd type="none" w="med" len="med"/>
-                      <a:tailEnd type="none" w="med" len="med"/>
-                    </a:lnB>
-                  </a:tcPr>
-                </a:tc>
-                <a:tc>
-                  <a:txBody>
-                    <a:bodyPr/>
-                    <a:lstStyle/>
-                    <a:p>
-                      <a:pPr indent="0" marL="0">
-                        <a:buNone/>
-                      </a:pPr>
-                      <a:r>
-                        <a:rPr lang="en-US" sz="1200" dirty="0">
-                          <a:solidFill>
-                            <a:schemeClr val="tx1"/>
-                          </a:solidFill>
-                        </a:rPr>
-                        <a:t>25</a:t>
+                        <a:t>90% specificity</a:t>
                       </a:r>
                       <a:endParaRPr lang="en-US" sz="1200" dirty="0"/>
                     </a:p>
@@ -9529,7 +9553,7 @@
                   <a:schemeClr val="tx2"/>
                 </a:solidFill>
               </a:rPr>
-              <a:t>Against 120 hand-labelled images (95 day, 25 night). Numbers come from eval/run_eval.py and are filled in once labelling is complete.</a:t>
+              <a:t>Against the 43 images labelled so far by the team (of 120). Honest result: the phone mode is conservative. It raises few false alarms on clean trucks but missed the 11 positives, which were mostly three-quarter views and car tails over an enclosed deck. This is the gap the calibrated gate camera closes.</a:t>
             </a:r>
             <a:endParaRPr lang="en-US" sz="1100" dirty="0"/>
           </a:p>

</xml_diff>

<commit_message>
Deck: slide 6 caption spacing
Co-Authored-By: Claude Fable 5.1 <noreply@anthropic.com>
</commit_message>
<xml_diff>
--- a/deck/LoadSafetyGate_deck.pptx
+++ b/deck/LoadSafetyGate_deck.pptx
@@ -116,22 +116,22 @@
   <p:extLst>
     <p:ext uri="{521415D9-36F7-43E2-AB2F-B90AF26B5E84}">
       <p14:sectionLst xmlns:p14="http://schemas.microsoft.com/office/powerpoint/2010/main">
-        <p14:section name="Opening" id="{7898120b-7601-4eba-66bb-7c30c9dd3aed}">
+        <p14:section name="Opening" id="{ba4c25ab-ba8d-33b6-3fff-cb932a6dd59f}">
           <p14:sldIdLst>
             <p14:sldId id="256"/>
           </p14:sldIdLst>
         </p14:section>
-        <p14:section name="Problem" id="{76c343fc-2d07-c836-bde4-f7c661bb092e}">
+        <p14:section name="Problem" id="{7a809403-7262-9db4-a4ec-f97e0036b81e}">
           <p14:sldIdLst>
             <p14:sldId id="257"/>
           </p14:sldIdLst>
         </p14:section>
-        <p14:section name="Demo" id="{86447430-332e-e288-174a-aec50e92b09d}">
+        <p14:section name="Demo" id="{8c5faee2-a77d-a7b9-ce88-c301648487fd}">
           <p14:sldIdLst>
             <p14:sldId id="258"/>
           </p14:sldIdLst>
         </p14:section>
-        <p14:section name="Technology" id="{d40d84de-30f5-8a51-1918-580ee362a529}">
+        <p14:section name="Technology" id="{de1227e4-0a69-a48d-20fc-8ea3cb5ac4d0}">
           <p14:sldIdLst>
             <p14:sldId id="259"/>
             <p14:sldId id="260"/>
@@ -140,7 +140,7 @@
             <p14:sldId id="263"/>
           </p14:sldIdLst>
         </p14:section>
-        <p14:section name="Business" id="{c1e48c74-3182-7d2a-89a2-70bc4b38ec29}">
+        <p14:section name="Business" id="{e72eff42-b2a3-ce31-83d9-6b6c0dd83540}">
           <p14:sldIdLst>
             <p14:sldId id="264"/>
             <p14:sldId id="265"/>
@@ -9531,7 +9531,7 @@
         </p:nvSpPr>
         <p:spPr>
           <a:xfrm>
-            <a:off x="6400800" y="3383280"/>
+            <a:off x="6400800" y="3657600"/>
             <a:ext cx="5303520" cy="640080"/>
           </a:xfrm>
           <a:prstGeom prst="rect">
@@ -9548,14 +9548,14 @@
               <a:buNone/>
             </a:pPr>
             <a:r>
-              <a:rPr lang="en-US" sz="1100" dirty="0">
+              <a:rPr lang="en-US" sz="1000" dirty="0">
                 <a:solidFill>
                   <a:schemeClr val="tx2"/>
                 </a:solidFill>
               </a:rPr>
               <a:t>Against the 43 images labelled so far by the team (of 120). Honest result: the phone mode is conservative. It raises few false alarms on clean trucks but missed the 11 positives, which were mostly three-quarter views and car tails over an enclosed deck. This is the gap the calibrated gate camera closes.</a:t>
             </a:r>
-            <a:endParaRPr lang="en-US" sz="1100" dirty="0"/>
+            <a:endParaRPr lang="en-US" sz="1000" dirty="0"/>
           </a:p>
         </p:txBody>
       </p:sp>

</xml_diff>

<commit_message>
Final team labels (101 images): metrics in README and deck
Co-Authored-By: Claude Fable 5.1 <noreply@anthropic.com>
</commit_message>
<xml_diff>
--- a/deck/LoadSafetyGate_deck.pptx
+++ b/deck/LoadSafetyGate_deck.pptx
@@ -116,22 +116,22 @@
   <p:extLst>
     <p:ext uri="{521415D9-36F7-43E2-AB2F-B90AF26B5E84}">
       <p14:sectionLst xmlns:p14="http://schemas.microsoft.com/office/powerpoint/2010/main">
-        <p14:section name="Opening" id="{ba4c25ab-ba8d-33b6-3fff-cb932a6dd59f}">
+        <p14:section name="Opening" id="{2bc36b70-40f4-1d3d-24a8-f776ce1f1c81}">
           <p14:sldIdLst>
             <p14:sldId id="256"/>
           </p14:sldIdLst>
         </p14:section>
-        <p14:section name="Problem" id="{7a809403-7262-9db4-a4ec-f97e0036b81e}">
+        <p14:section name="Problem" id="{a92ac35d-6e16-86ce-422c-f4466faa7453}">
           <p14:sldIdLst>
             <p14:sldId id="257"/>
           </p14:sldIdLst>
         </p14:section>
-        <p14:section name="Demo" id="{8c5faee2-a77d-a7b9-ce88-c301648487fd}">
+        <p14:section name="Demo" id="{61453c10-8df7-ffc9-8709-0b1942c7b962}">
           <p14:sldIdLst>
             <p14:sldId id="258"/>
           </p14:sldIdLst>
         </p14:section>
-        <p14:section name="Technology" id="{de1227e4-0a69-a48d-20fc-8ea3cb5ac4d0}">
+        <p14:section name="Technology" id="{cf931ad3-29e3-6a3c-8b24-0a83a7d1dc9f}">
           <p14:sldIdLst>
             <p14:sldId id="259"/>
             <p14:sldId id="260"/>
@@ -140,7 +140,7 @@
             <p14:sldId id="263"/>
           </p14:sldIdLst>
         </p14:section>
-        <p14:section name="Business" id="{e72eff42-b2a3-ce31-83d9-6b6c0dd83540}">
+        <p14:section name="Business" id="{05d4e511-72b2-6bbc-58f9-aaef8cbb9f0f}">
           <p14:sldIdLst>
             <p14:sldId id="264"/>
             <p14:sldId id="265"/>
@@ -8430,7 +8430,7 @@
                             <a:schemeClr val="tx1"/>
                           </a:solidFill>
                         </a:rPr>
-                        <a:t>0.00</a:t>
+                        <a:t>0.33</a:t>
                       </a:r>
                       <a:endParaRPr lang="en-US" sz="1200" dirty="0"/>
                     </a:p>
@@ -8488,7 +8488,7 @@
                             <a:schemeClr val="tx1"/>
                           </a:solidFill>
                         </a:rPr>
-                        <a:t>0.00</a:t>
+                        <a:t>0.09</a:t>
                       </a:r>
                       <a:endParaRPr lang="en-US" sz="1200" dirty="0"/>
                     </a:p>
@@ -8546,7 +8546,7 @@
                             <a:schemeClr val="tx1"/>
                           </a:solidFill>
                         </a:rPr>
-                        <a:t>0/2/2</a:t>
+                        <a:t>1/2/10</a:t>
                       </a:r>
                       <a:endParaRPr lang="en-US" sz="1200" dirty="0"/>
                     </a:p>
@@ -8780,7 +8780,7 @@
                             <a:schemeClr val="tx1"/>
                           </a:solidFill>
                         </a:rPr>
-                        <a:t>0/1/4</a:t>
+                        <a:t>0/1/7</a:t>
                       </a:r>
                       <a:endParaRPr lang="en-US" sz="1200" dirty="0"/>
                     </a:p>
@@ -9014,7 +9014,7 @@
                             <a:schemeClr val="tx1"/>
                           </a:solidFill>
                         </a:rPr>
-                        <a:t>0/0/1</a:t>
+                        <a:t>0/0/6</a:t>
                       </a:r>
                       <a:endParaRPr lang="en-US" sz="1200" dirty="0"/>
                     </a:p>
@@ -9132,7 +9132,7 @@
                             <a:schemeClr val="tx1"/>
                           </a:solidFill>
                         </a:rPr>
-                        <a:t>0.00</a:t>
+                        <a:t>0.33</a:t>
                       </a:r>
                       <a:endParaRPr lang="en-US" sz="1200" dirty="0"/>
                     </a:p>
@@ -9190,7 +9190,7 @@
                             <a:schemeClr val="tx1"/>
                           </a:solidFill>
                         </a:rPr>
-                        <a:t>0.00</a:t>
+                        <a:t>0.06</a:t>
                       </a:r>
                       <a:endParaRPr lang="en-US" sz="1200" dirty="0"/>
                     </a:p>
@@ -9248,7 +9248,7 @@
                             <a:schemeClr val="tx1"/>
                           </a:solidFill>
                         </a:rPr>
-                        <a:t>0/1/4</a:t>
+                        <a:t>1/2/16</a:t>
                       </a:r>
                       <a:endParaRPr lang="en-US" sz="1200" dirty="0"/>
                     </a:p>
@@ -9308,7 +9308,7 @@
                             <a:schemeClr val="tx1"/>
                           </a:solidFill>
                         </a:rPr>
-                        <a:t>Clean images, no false alarm</a:t>
+                        <a:t>Clean trucks, no false alarm</a:t>
                       </a:r>
                       <a:endParaRPr lang="en-US" sz="1200" dirty="0"/>
                     </a:p>
@@ -9366,7 +9366,7 @@
                             <a:schemeClr val="tx1"/>
                           </a:solidFill>
                         </a:rPr>
-                        <a:t>18 of 20</a:t>
+                        <a:t>41 of 44</a:t>
                       </a:r>
                       <a:endParaRPr lang="en-US" sz="1200" dirty="0"/>
                     </a:p>
@@ -9474,7 +9474,7 @@
                             <a:schemeClr val="tx1"/>
                           </a:solidFill>
                         </a:rPr>
-                        <a:t>90% specificity</a:t>
+                        <a:t>93% specificity</a:t>
                       </a:r>
                       <a:endParaRPr lang="en-US" sz="1200" dirty="0"/>
                     </a:p>
@@ -9553,7 +9553,7 @@
                   <a:schemeClr val="tx2"/>
                 </a:solidFill>
               </a:rPr>
-              <a:t>Against the 43 images labelled so far by the team (of 120). Honest result: the phone mode is conservative. It raises few false alarms on clean trucks but missed the 11 positives, which were mostly three-quarter views and car tails over an enclosed deck. This is the gap the calibrated gate camera closes.</a:t>
+              <a:t>Against 101 team-labelled images, 61 of them three-quarter views. Honest result: the phone mode is conservative. 93% of clean trucks pass without a false alarm, but it caught only 2 of 41 labelled positives, mostly three-quarter and rear views where no scale object is visible. The calibrated gate camera is the fix, not a bigger model.</a:t>
             </a:r>
             <a:endParaRPr lang="en-US" sz="1000" dirty="0"/>
           </a:p>

</xml_diff>

<commit_message>
README and deck: controlled roll accuracy (MAE 1.63 deg), journal/ticket, ROI assumptions, cargo experiment recorded
Co-Authored-By: Claude Fable 5.1 <noreply@anthropic.com>
</commit_message>
<xml_diff>
--- a/deck/LoadSafetyGate_deck.pptx
+++ b/deck/LoadSafetyGate_deck.pptx
@@ -116,22 +116,22 @@
   <p:extLst>
     <p:ext uri="{521415D9-36F7-43E2-AB2F-B90AF26B5E84}">
       <p14:sectionLst xmlns:p14="http://schemas.microsoft.com/office/powerpoint/2010/main">
-        <p14:section name="Opening" id="{2bc36b70-40f4-1d3d-24a8-f776ce1f1c81}">
+        <p14:section name="Opening" id="{5f42e744-498b-bf00-345c-29f116906796}">
           <p14:sldIdLst>
             <p14:sldId id="256"/>
           </p14:sldIdLst>
         </p14:section>
-        <p14:section name="Problem" id="{a92ac35d-6e16-86ce-422c-f4466faa7453}">
+        <p14:section name="Problem" id="{dda031ee-4496-dc46-f2bc-e17d73be9193}">
           <p14:sldIdLst>
             <p14:sldId id="257"/>
           </p14:sldIdLst>
         </p14:section>
-        <p14:section name="Demo" id="{61453c10-8df7-ffc9-8709-0b1942c7b962}">
+        <p14:section name="Demo" id="{19625522-b377-b3e0-4c21-6b84727b7779}">
           <p14:sldIdLst>
             <p14:sldId id="258"/>
           </p14:sldIdLst>
         </p14:section>
-        <p14:section name="Technology" id="{cf931ad3-29e3-6a3c-8b24-0a83a7d1dc9f}">
+        <p14:section name="Technology" id="{5c24f565-db23-8aab-3934-3862e3df833e}">
           <p14:sldIdLst>
             <p14:sldId id="259"/>
             <p14:sldId id="260"/>
@@ -140,7 +140,7 @@
             <p14:sldId id="263"/>
           </p14:sldIdLst>
         </p14:section>
-        <p14:section name="Business" id="{05d4e511-72b2-6bbc-58f9-aaef8cbb9f0f}">
+        <p14:section name="Business" id="{873417aa-4a84-ee7c-63b0-48acc3e83537}">
           <p14:sldIdLst>
             <p14:sldId id="264"/>
             <p14:sldId id="265"/>
@@ -3737,6 +3737,24 @@
                   <a:schemeClr val="bg1"/>
                 </a:solidFill>
               </a:rPr>
+              <a:t>Every run gets an inspection ticket and lands in the shift journal: counts of GO, WARN, NO-GO for the day. Numbers only, the photo is discarded.</a:t>
+            </a:r>
+            <a:endParaRPr lang="en-US" sz="1500" dirty="0"/>
+          </a:p>
+          <a:p>
+            <a:pPr marL="342900" indent="-342900">
+              <a:spcAft>
+                <a:spcPts val="600"/>
+              </a:spcAft>
+              <a:buSzPct val="100000"/>
+              <a:buChar char="•"/>
+            </a:pPr>
+            <a:r>
+              <a:rPr lang="en-US" sz="1500" dirty="0">
+                <a:solidFill>
+                  <a:schemeClr val="bg1"/>
+                </a:solidFill>
+              </a:rPr>
               <a:t>When the photo does not allow a measurement the check says so. No guess, ever.</a:t>
             </a:r>
             <a:endParaRPr lang="en-US" sz="1500" dirty="0"/>
@@ -9568,7 +9586,7 @@
         <p:spPr>
           <a:xfrm>
             <a:off x="457200" y="4297680"/>
-            <a:ext cx="3566160" cy="822960"/>
+            <a:ext cx="2651760" cy="822960"/>
           </a:xfrm>
           <a:prstGeom prst="rect">
             <a:avLst/>
@@ -9584,7 +9602,82 @@
               <a:buNone/>
             </a:pPr>
             <a:r>
-              <a:rPr lang="en-US" sz="4000" b="1" dirty="0">
+              <a:rPr lang="en-US" sz="3600" b="1" dirty="0">
+                <a:solidFill>
+                  <a:srgbClr val="1F5F8B"/>
+                </a:solidFill>
+                <a:latin typeface="Cambria" pitchFamily="34" charset="0"/>
+                <a:ea typeface="Cambria" pitchFamily="34" charset="-122"/>
+                <a:cs typeface="Cambria" pitchFamily="34" charset="-120"/>
+              </a:rPr>
+              <a:t>1.63°</a:t>
+            </a:r>
+            <a:endParaRPr lang="en-US" sz="3600" dirty="0"/>
+          </a:p>
+        </p:txBody>
+      </p:sp>
+      <p:sp>
+        <p:nvSpPr>
+          <p:cNvPr id="8" name="Text 4"/>
+          <p:cNvSpPr txBox="1"/>
+          <p:nvPr/>
+        </p:nvSpPr>
+        <p:spPr>
+          <a:xfrm>
+            <a:off x="457200" y="5120640"/>
+            <a:ext cx="2651760" cy="914400"/>
+          </a:xfrm>
+          <a:prstGeom prst="rect">
+            <a:avLst/>
+          </a:prstGeom>
+          <a:noFill/>
+          <a:ln/>
+        </p:spPr>
+        <p:txBody>
+          <a:bodyPr wrap="square" lIns="0" tIns="0" rIns="0" bIns="0" rtlCol="0" anchor="ctr"/>
+          <a:lstStyle/>
+          <a:p>
+            <a:pPr indent="0" marL="0">
+              <a:buNone/>
+            </a:pPr>
+            <a:r>
+              <a:rPr lang="en-US" sz="1100" dirty="0">
+                <a:solidFill>
+                  <a:schemeClr val="tx2"/>
+                </a:solidFill>
+              </a:rPr>
+              <a:t>roll instrument error, 56 rotated level photos at known angles, sign right 93% of the time</a:t>
+            </a:r>
+            <a:endParaRPr lang="en-US" sz="1100" dirty="0"/>
+          </a:p>
+        </p:txBody>
+      </p:sp>
+      <p:sp>
+        <p:nvSpPr>
+          <p:cNvPr id="9" name="Text 5"/>
+          <p:cNvSpPr txBox="1"/>
+          <p:nvPr/>
+        </p:nvSpPr>
+        <p:spPr>
+          <a:xfrm>
+            <a:off x="3291840" y="4297680"/>
+            <a:ext cx="2651760" cy="822960"/>
+          </a:xfrm>
+          <a:prstGeom prst="rect">
+            <a:avLst/>
+          </a:prstGeom>
+          <a:noFill/>
+          <a:ln/>
+        </p:spPr>
+        <p:txBody>
+          <a:bodyPr wrap="square" lIns="0" tIns="0" rIns="0" bIns="0" rtlCol="0" anchor="ctr"/>
+          <a:lstStyle/>
+          <a:p>
+            <a:pPr indent="0" marL="0">
+              <a:buNone/>
+            </a:pPr>
+            <a:r>
+              <a:rPr lang="en-US" sz="3600" b="1" dirty="0">
                 <a:solidFill>
                   <a:srgbClr val="1F5F8B"/>
                 </a:solidFill>
@@ -9594,20 +9687,20 @@
               </a:rPr>
               <a:t>0.19 s</a:t>
             </a:r>
-            <a:endParaRPr lang="en-US" sz="4000" dirty="0"/>
+            <a:endParaRPr lang="en-US" sz="3600" dirty="0"/>
           </a:p>
         </p:txBody>
       </p:sp>
       <p:sp>
         <p:nvSpPr>
-          <p:cNvPr id="8" name="Text 4"/>
+          <p:cNvPr id="10" name="Text 6"/>
           <p:cNvSpPr txBox="1"/>
           <p:nvPr/>
         </p:nvSpPr>
         <p:spPr>
           <a:xfrm>
-            <a:off x="457200" y="5120640"/>
-            <a:ext cx="3566160" cy="731520"/>
+            <a:off x="3291840" y="5120640"/>
+            <a:ext cx="2651760" cy="914400"/>
           </a:xfrm>
           <a:prstGeom prst="rect">
             <a:avLst/>
@@ -9623,27 +9716,27 @@
               <a:buNone/>
             </a:pPr>
             <a:r>
-              <a:rPr lang="en-US" sz="1200" dirty="0">
+              <a:rPr lang="en-US" sz="1100" dirty="0">
                 <a:solidFill>
                   <a:schemeClr val="tx2"/>
                 </a:solidFill>
               </a:rPr>
               <a:t>per image on 2 CPU cores, measured on the deployed server</a:t>
             </a:r>
-            <a:endParaRPr lang="en-US" sz="1200" dirty="0"/>
+            <a:endParaRPr lang="en-US" sz="1100" dirty="0"/>
           </a:p>
         </p:txBody>
       </p:sp>
       <p:sp>
         <p:nvSpPr>
-          <p:cNvPr id="9" name="Text 5"/>
+          <p:cNvPr id="11" name="Text 7"/>
           <p:cNvSpPr txBox="1"/>
           <p:nvPr/>
         </p:nvSpPr>
         <p:spPr>
           <a:xfrm>
-            <a:off x="4297680" y="4297680"/>
-            <a:ext cx="3566160" cy="822960"/>
+            <a:off x="6126480" y="4297680"/>
+            <a:ext cx="2651760" cy="822960"/>
           </a:xfrm>
           <a:prstGeom prst="rect">
             <a:avLst/>
@@ -9659,7 +9752,7 @@
               <a:buNone/>
             </a:pPr>
             <a:r>
-              <a:rPr lang="en-US" sz="4000" b="1" dirty="0">
+              <a:rPr lang="en-US" sz="3600" b="1" dirty="0">
                 <a:solidFill>
                   <a:srgbClr val="1F5F8B"/>
                 </a:solidFill>
@@ -9669,20 +9762,20 @@
               </a:rPr>
               <a:t>&lt; $0.001</a:t>
             </a:r>
-            <a:endParaRPr lang="en-US" sz="4000" dirty="0"/>
+            <a:endParaRPr lang="en-US" sz="3600" dirty="0"/>
           </a:p>
         </p:txBody>
       </p:sp>
       <p:sp>
         <p:nvSpPr>
-          <p:cNvPr id="10" name="Text 6"/>
+          <p:cNvPr id="12" name="Text 8"/>
           <p:cNvSpPr txBox="1"/>
           <p:nvPr/>
         </p:nvSpPr>
         <p:spPr>
           <a:xfrm>
-            <a:off x="4297680" y="5120640"/>
-            <a:ext cx="3566160" cy="731520"/>
+            <a:off x="6126480" y="5120640"/>
+            <a:ext cx="2651760" cy="914400"/>
           </a:xfrm>
           <a:prstGeom prst="rect">
             <a:avLst/>
@@ -9698,27 +9791,27 @@
               <a:buNone/>
             </a:pPr>
             <a:r>
-              <a:rPr lang="en-US" sz="1200" dirty="0">
+              <a:rPr lang="en-US" sz="1100" dirty="0">
                 <a:solidFill>
                   <a:schemeClr val="tx2"/>
                 </a:solidFill>
               </a:rPr>
               <a:t>compute per inspection; one warm server about $90 per month</a:t>
             </a:r>
-            <a:endParaRPr lang="en-US" sz="1200" dirty="0"/>
+            <a:endParaRPr lang="en-US" sz="1100" dirty="0"/>
           </a:p>
         </p:txBody>
       </p:sp>
       <p:sp>
         <p:nvSpPr>
-          <p:cNvPr id="11" name="Text 7"/>
+          <p:cNvPr id="13" name="Text 9"/>
           <p:cNvSpPr txBox="1"/>
           <p:nvPr/>
         </p:nvSpPr>
         <p:spPr>
           <a:xfrm>
-            <a:off x="8138160" y="4297680"/>
-            <a:ext cx="3566160" cy="822960"/>
+            <a:off x="8961120" y="4297680"/>
+            <a:ext cx="2651760" cy="822960"/>
           </a:xfrm>
           <a:prstGeom prst="rect">
             <a:avLst/>
@@ -9734,7 +9827,7 @@
               <a:buNone/>
             </a:pPr>
             <a:r>
-              <a:rPr lang="en-US" sz="4000" b="1" dirty="0">
+              <a:rPr lang="en-US" sz="3600" b="1" dirty="0">
                 <a:solidFill>
                   <a:srgbClr val="1F5F8B"/>
                 </a:solidFill>
@@ -9744,20 +9837,20 @@
               </a:rPr>
               <a:t>0 faces</a:t>
             </a:r>
-            <a:endParaRPr lang="en-US" sz="4000" dirty="0"/>
+            <a:endParaRPr lang="en-US" sz="3600" dirty="0"/>
           </a:p>
         </p:txBody>
       </p:sp>
       <p:sp>
         <p:nvSpPr>
-          <p:cNvPr id="12" name="Text 8"/>
+          <p:cNvPr id="14" name="Text 10"/>
           <p:cNvSpPr txBox="1"/>
           <p:nvPr/>
         </p:nvSpPr>
         <p:spPr>
           <a:xfrm>
-            <a:off x="8138160" y="5120640"/>
-            <a:ext cx="3566160" cy="731520"/>
+            <a:off x="8961120" y="5120640"/>
+            <a:ext cx="2651760" cy="914400"/>
           </a:xfrm>
           <a:prstGeom prst="rect">
             <a:avLst/>
@@ -9773,14 +9866,14 @@
               <a:buNone/>
             </a:pPr>
             <a:r>
-              <a:rPr lang="en-US" sz="1200" dirty="0">
+              <a:rPr lang="en-US" sz="1100" dirty="0">
                 <a:solidFill>
                   <a:schemeClr val="tx2"/>
                 </a:solidFill>
               </a:rPr>
               <a:t>stored. Plates and people pixelated before anything is kept</a:t>
             </a:r>
-            <a:endParaRPr lang="en-US" sz="1200" dirty="0"/>
+            <a:endParaRPr lang="en-US" sz="1100" dirty="0"/>
           </a:p>
         </p:txBody>
       </p:sp>
@@ -11806,7 +11899,7 @@
                             <a:schemeClr val="bg1"/>
                           </a:solidFill>
                         </a:rPr>
-                        <a:t>Avoided loss per year, one fleet</a:t>
+                        <a:t>Avoided loss, one fleet</a:t>
                       </a:r>
                       <a:endParaRPr lang="en-US" sz="1200" dirty="0"/>
                     </a:p>
@@ -11928,7 +12021,7 @@
                             <a:schemeClr val="bg1"/>
                           </a:solidFill>
                         </a:rPr>
-                        <a:t>Assumption</a:t>
+                        <a:t>Assumption, calibrated in the pilot</a:t>
                       </a:r>
                       <a:endParaRPr lang="en-US" sz="1200" dirty="0"/>
                     </a:p>
@@ -11991,7 +12084,7 @@
                             <a:schemeClr val="tx1"/>
                           </a:solidFill>
                         </a:rPr>
-                        <a:t>Rollovers prevented</a:t>
+                        <a:t>Departures screened</a:t>
                       </a:r>
                       <a:endParaRPr lang="en-US" sz="1200" dirty="0"/>
                     </a:p>
@@ -12049,7 +12142,7 @@
                             <a:schemeClr val="tx1"/>
                           </a:solidFill>
                         </a:rPr>
-                        <a:t>[confirm]</a:t>
+                        <a:t>200 per day</a:t>
                       </a:r>
                       <a:endParaRPr lang="en-US" sz="1200" dirty="0"/>
                     </a:p>
@@ -12107,7 +12200,7 @@
                             <a:schemeClr val="tx1"/>
                           </a:solidFill>
                         </a:rPr>
-                        <a:t>cost of one rollover x events avoided</a:t>
+                        <a:t>mid-size fleet, one gate camera</a:t>
                       </a:r>
                       <a:endParaRPr lang="en-US" sz="1200" dirty="0"/>
                     </a:p>
@@ -12167,7 +12260,7 @@
                             <a:schemeClr val="tx1"/>
                           </a:solidFill>
                         </a:rPr>
-                        <a:t>Oversize fines avoided</a:t>
+                        <a:t>Dangerous departures caught</a:t>
                       </a:r>
                       <a:endParaRPr lang="en-US" sz="1200" dirty="0"/>
                     </a:p>
@@ -12225,7 +12318,7 @@
                             <a:schemeClr val="tx1"/>
                           </a:solidFill>
                         </a:rPr>
-                        <a:t>[confirm]</a:t>
+                        <a:t>1 per month</a:t>
                       </a:r>
                       <a:endParaRPr lang="en-US" sz="1200" dirty="0"/>
                     </a:p>
@@ -12283,7 +12376,7 @@
                             <a:schemeClr val="tx1"/>
                           </a:solidFill>
                         </a:rPr>
-                        <a:t>fine x stops per month</a:t>
+                        <a:t>conservative: 1 in ~6,000 departures</a:t>
                       </a:r>
                       <a:endParaRPr lang="en-US" sz="1200" dirty="0"/>
                     </a:p>
@@ -12343,7 +12436,7 @@
                             <a:schemeClr val="tx1"/>
                           </a:solidFill>
                         </a:rPr>
-                        <a:t>Cargo damage claims</a:t>
+                        <a:t>Cost of one load incident</a:t>
                       </a:r>
                       <a:endParaRPr lang="en-US" sz="1200" dirty="0"/>
                     </a:p>
@@ -12401,7 +12494,7 @@
                             <a:schemeClr val="tx1"/>
                           </a:solidFill>
                         </a:rPr>
-                        <a:t>[confirm]</a:t>
+                        <a:t>$5,000</a:t>
                       </a:r>
                       <a:endParaRPr lang="en-US" sz="1200" dirty="0"/>
                     </a:p>
@@ -12459,7 +12552,7 @@
                             <a:schemeClr val="tx1"/>
                           </a:solidFill>
                         </a:rPr>
-                        <a:t>claims per year x share caught at gate</a:t>
+                        <a:t>cargo loss + downtime + fine + claim handling; wide range</a:t>
                       </a:r>
                       <a:endParaRPr lang="en-US" sz="1200" dirty="0"/>
                     </a:p>
@@ -12519,7 +12612,7 @@
                             <a:schemeClr val="tx1"/>
                           </a:solidFill>
                         </a:rPr>
-                        <a:t>Operator time</a:t>
+                        <a:t>Avoided loss per year</a:t>
                       </a:r>
                       <a:endParaRPr lang="en-US" sz="1200" dirty="0"/>
                     </a:p>
@@ -12577,7 +12670,7 @@
                             <a:schemeClr val="tx1"/>
                           </a:solidFill>
                         </a:rPr>
-                        <a:t>[confirm]</a:t>
+                        <a:t>$60,000</a:t>
                       </a:r>
                       <a:endParaRPr lang="en-US" sz="1200" dirty="0"/>
                     </a:p>
@@ -12635,7 +12728,7 @@
                             <a:schemeClr val="tx1"/>
                           </a:solidFill>
                         </a:rPr>
-                        <a:t>minutes per manual walkaround x trucks per day</a:t>
+                        <a:t>12 incidents x $5,000</a:t>
                       </a:r>
                       <a:endParaRPr lang="en-US" sz="1200" dirty="0"/>
                     </a:p>
@@ -12922,7 +13015,7 @@
                   <a:schemeClr val="tx2"/>
                 </a:solidFill>
               </a:rPr>
-              <a:t>Payback months = pilot cost / (avoided loss per month). Fill the [confirm] cells with the fleet's own figures and the formula gives the answer on the spot.</a:t>
+              <a:t>Payback months = pilot cost / avoided loss per month. At one caught incident a month the avoided loss is $5,000 per month against $90 per month of hosting, so the one-off pilot cost is recovered within its first months. The fleet's own incident rate replaces the assumption after month one.</a:t>
             </a:r>
             <a:endParaRPr lang="en-US" sz="1200" dirty="0"/>
           </a:p>

</xml_diff>

<commit_message>
Deck slide 9: team cost 3 x $800 x 3 months
Co-Authored-By: Claude Fable 5.1 <noreply@anthropic.com>
</commit_message>
<xml_diff>
--- a/deck/LoadSafetyGate_deck.pptx
+++ b/deck/LoadSafetyGate_deck.pptx
@@ -116,22 +116,22 @@
   <p:extLst>
     <p:ext uri="{521415D9-36F7-43E2-AB2F-B90AF26B5E84}">
       <p14:sectionLst xmlns:p14="http://schemas.microsoft.com/office/powerpoint/2010/main">
-        <p14:section name="Opening" id="{5f42e744-498b-bf00-345c-29f116906796}">
+        <p14:section name="Opening" id="{dbca44a1-ffa7-6a3c-2211-6a417f5a2eb8}">
           <p14:sldIdLst>
             <p14:sldId id="256"/>
           </p14:sldIdLst>
         </p14:section>
-        <p14:section name="Problem" id="{dda031ee-4496-dc46-f2bc-e17d73be9193}">
+        <p14:section name="Problem" id="{61a824a1-a491-adaf-b0ff-ca586a356a2d}">
           <p14:sldIdLst>
             <p14:sldId id="257"/>
           </p14:sldIdLst>
         </p14:section>
-        <p14:section name="Demo" id="{19625522-b377-b3e0-4c21-6b84727b7779}">
+        <p14:section name="Demo" id="{c133a62f-8c72-89e6-84ec-55b2dabcee50}">
           <p14:sldIdLst>
             <p14:sldId id="258"/>
           </p14:sldIdLst>
         </p14:section>
-        <p14:section name="Technology" id="{5c24f565-db23-8aab-3934-3862e3df833e}">
+        <p14:section name="Technology" id="{e27c5309-b94e-e49c-c1f8-d8f000a58858}">
           <p14:sldIdLst>
             <p14:sldId id="259"/>
             <p14:sldId id="260"/>
@@ -140,7 +140,7 @@
             <p14:sldId id="263"/>
           </p14:sldIdLst>
         </p14:section>
-        <p14:section name="Business" id="{873417aa-4a84-ee7c-63b0-48acc3e83537}">
+        <p14:section name="Business" id="{87d7448b-2156-8e56-4f93-07eafb41db3c}">
           <p14:sldIdLst>
             <p14:sldId id="264"/>
             <p14:sldId id="265"/>
@@ -10988,7 +10988,7 @@
                             <a:schemeClr val="tx1"/>
                           </a:solidFill>
                         </a:rPr>
-                        <a:t>Team: 2 engineers + 1 ops, part time</a:t>
+                        <a:t>Team: 3 people, 3 months</a:t>
                       </a:r>
                       <a:endParaRPr lang="en-US" sz="1200" dirty="0"/>
                     </a:p>
@@ -11046,7 +11046,7 @@
                             <a:schemeClr val="tx1"/>
                           </a:solidFill>
                         </a:rPr>
-                        <a:t>[confirm]</a:t>
+                        <a:t>$7,200</a:t>
                       </a:r>
                       <a:endParaRPr lang="en-US" sz="1200" dirty="0"/>
                     </a:p>
@@ -11104,7 +11104,7 @@
                             <a:schemeClr val="tx1"/>
                           </a:solidFill>
                         </a:rPr>
-                        <a:t>local salaries, 3 months</a:t>
+                        <a:t>$800 per person per month</a:t>
                       </a:r>
                       <a:endParaRPr lang="en-US" sz="1200" dirty="0"/>
                     </a:p>

</xml_diff>

<commit_message>
Deck slide 9: legal review folded into team time, no placeholder cells left
Co-Authored-By: Claude Fable 5.1 <noreply@anthropic.com>
</commit_message>
<xml_diff>
--- a/deck/LoadSafetyGate_deck.pptx
+++ b/deck/LoadSafetyGate_deck.pptx
@@ -116,22 +116,22 @@
   <p:extLst>
     <p:ext uri="{521415D9-36F7-43E2-AB2F-B90AF26B5E84}">
       <p14:sectionLst xmlns:p14="http://schemas.microsoft.com/office/powerpoint/2010/main">
-        <p14:section name="Opening" id="{dbca44a1-ffa7-6a3c-2211-6a417f5a2eb8}">
+        <p14:section name="Opening" id="{54ed7cc2-a06b-4f50-2d28-28297c2132e6}">
           <p14:sldIdLst>
             <p14:sldId id="256"/>
           </p14:sldIdLst>
         </p14:section>
-        <p14:section name="Problem" id="{61a824a1-a491-adaf-b0ff-ca586a356a2d}">
+        <p14:section name="Problem" id="{24543613-b2d6-1648-9fac-ba145114e62a}">
           <p14:sldIdLst>
             <p14:sldId id="257"/>
           </p14:sldIdLst>
         </p14:section>
-        <p14:section name="Demo" id="{c133a62f-8c72-89e6-84ec-55b2dabcee50}">
+        <p14:section name="Demo" id="{183bf132-d018-e1b5-1714-03df444c1bd7}">
           <p14:sldIdLst>
             <p14:sldId id="258"/>
           </p14:sldIdLst>
         </p14:section>
-        <p14:section name="Technology" id="{e27c5309-b94e-e49c-c1f8-d8f000a58858}">
+        <p14:section name="Technology" id="{c64a42ed-1b4d-f85f-83f7-e315ac3c8a4a}">
           <p14:sldIdLst>
             <p14:sldId id="259"/>
             <p14:sldId id="260"/>
@@ -140,7 +140,7 @@
             <p14:sldId id="263"/>
           </p14:sldIdLst>
         </p14:section>
-        <p14:section name="Business" id="{87d7448b-2156-8e56-4f93-07eafb41db3c}">
+        <p14:section name="Business" id="{40a08154-11eb-d0a3-18a9-5fc0f0c31e3e}">
           <p14:sldIdLst>
             <p14:sldId id="264"/>
             <p14:sldId id="265"/>
@@ -11750,7 +11750,7 @@
                             <a:schemeClr val="tx1"/>
                           </a:solidFill>
                         </a:rPr>
-                        <a:t>[confirm]</a:t>
+                        <a:t>in team time</a:t>
                       </a:r>
                       <a:endParaRPr lang="en-US" sz="1200" dirty="0"/>
                     </a:p>
@@ -11808,7 +11808,7 @@
                             <a:schemeClr val="tx1"/>
                           </a:solidFill>
                         </a:rPr>
-                        <a:t>blur at ingest, no personal data stored</a:t>
+                        <a:t>blur at ingest, no personal data stored, one-day legal check</a:t>
                       </a:r>
                       <a:endParaRPr lang="en-US" sz="1200" dirty="0"/>
                     </a:p>

</xml_diff>

<commit_message>
Deck slide 9: payback computed from the slide's own figures, 1.7 months
Co-Authored-By: Claude Fable 5.1 <noreply@anthropic.com>
</commit_message>
<xml_diff>
--- a/deck/LoadSafetyGate_deck.pptx
+++ b/deck/LoadSafetyGate_deck.pptx
@@ -116,22 +116,22 @@
   <p:extLst>
     <p:ext uri="{521415D9-36F7-43E2-AB2F-B90AF26B5E84}">
       <p14:sectionLst xmlns:p14="http://schemas.microsoft.com/office/powerpoint/2010/main">
-        <p14:section name="Opening" id="{54ed7cc2-a06b-4f50-2d28-28297c2132e6}">
+        <p14:section name="Opening" id="{95804005-4c0d-9d81-c002-4b88cc98edf2}">
           <p14:sldIdLst>
             <p14:sldId id="256"/>
           </p14:sldIdLst>
         </p14:section>
-        <p14:section name="Problem" id="{24543613-b2d6-1648-9fac-ba145114e62a}">
+        <p14:section name="Problem" id="{42bc5c86-9bb2-6a35-c54c-32f2233ed4ea}">
           <p14:sldIdLst>
             <p14:sldId id="257"/>
           </p14:sldIdLst>
         </p14:section>
-        <p14:section name="Demo" id="{183bf132-d018-e1b5-1714-03df444c1bd7}">
+        <p14:section name="Demo" id="{d2b46430-2c46-705b-030c-f31d141555e6}">
           <p14:sldIdLst>
             <p14:sldId id="258"/>
           </p14:sldIdLst>
         </p14:section>
-        <p14:section name="Technology" id="{c64a42ed-1b4d-f85f-83f7-e315ac3c8a4a}">
+        <p14:section name="Technology" id="{f5ea5810-32fa-a3b8-7de2-821744864ffe}">
           <p14:sldIdLst>
             <p14:sldId id="259"/>
             <p14:sldId id="260"/>
@@ -140,7 +140,7 @@
             <p14:sldId id="263"/>
           </p14:sldIdLst>
         </p14:section>
-        <p14:section name="Business" id="{40a08154-11eb-d0a3-18a9-5fc0f0c31e3e}">
+        <p14:section name="Business" id="{dd91d6d7-dde8-82c2-d993-87a54244f698}">
           <p14:sldIdLst>
             <p14:sldId id="264"/>
             <p14:sldId id="265"/>
@@ -13015,7 +13015,7 @@
                   <a:schemeClr val="tx2"/>
                 </a:solidFill>
               </a:rPr>
-              <a:t>Payback months = pilot cost / avoided loss per month. At one caught incident a month the avoided loss is $5,000 per month against $90 per month of hosting, so the one-off pilot cost is recovered within its first months. The fleet's own incident rate replaces the assumption after month one.</a:t>
+              <a:t>Pilot cost $8,570 (team $7,200 + cameras $600 + hosting $270 + labelling $500). Avoided loss $5,000 per month at one caught incident a month. Payback = 8,570 / 5,000 = 1.7 months, inside the pilot itself. The fleet's own incident rate replaces the assumption after month one.</a:t>
             </a:r>
             <a:endParaRPr lang="en-US" sz="1200" dirty="0"/>
           </a:p>

</xml_diff>

<commit_message>
Roll and height reported on rear views too (refusals 54 -> 35 of 101, specificity 93 -> 91%); shooting guidance on CANNOT ASSESS; metrics regenerated
Co-Authored-By: Claude Fable 5.1 <noreply@anthropic.com>
</commit_message>
<xml_diff>
--- a/deck/LoadSafetyGate_deck.pptx
+++ b/deck/LoadSafetyGate_deck.pptx
@@ -116,22 +116,22 @@
   <p:extLst>
     <p:ext uri="{521415D9-36F7-43E2-AB2F-B90AF26B5E84}">
       <p14:sectionLst xmlns:p14="http://schemas.microsoft.com/office/powerpoint/2010/main">
-        <p14:section name="Opening" id="{95804005-4c0d-9d81-c002-4b88cc98edf2}">
+        <p14:section name="Opening" id="{66d3fdb2-f0b3-d64b-551b-6651412fcd34}">
           <p14:sldIdLst>
             <p14:sldId id="256"/>
           </p14:sldIdLst>
         </p14:section>
-        <p14:section name="Problem" id="{42bc5c86-9bb2-6a35-c54c-32f2233ed4ea}">
+        <p14:section name="Problem" id="{dbce6cf2-354d-2183-8ff5-2490299e6d15}">
           <p14:sldIdLst>
             <p14:sldId id="257"/>
           </p14:sldIdLst>
         </p14:section>
-        <p14:section name="Demo" id="{d2b46430-2c46-705b-030c-f31d141555e6}">
+        <p14:section name="Demo" id="{bbb303e9-1677-b929-f6f6-efcaad169647}">
           <p14:sldIdLst>
             <p14:sldId id="258"/>
           </p14:sldIdLst>
         </p14:section>
-        <p14:section name="Technology" id="{f5ea5810-32fa-a3b8-7de2-821744864ffe}">
+        <p14:section name="Technology" id="{093a39bb-a0c3-bf21-1f68-d46603b2fc16}">
           <p14:sldIdLst>
             <p14:sldId id="259"/>
             <p14:sldId id="260"/>
@@ -140,7 +140,7 @@
             <p14:sldId id="263"/>
           </p14:sldIdLst>
         </p14:section>
-        <p14:section name="Business" id="{dd91d6d7-dde8-82c2-d993-87a54244f698}">
+        <p14:section name="Business" id="{cd218f0a-c8f3-772a-fc44-58aed8758567}">
           <p14:sldIdLst>
             <p14:sldId id="264"/>
             <p14:sldId id="265"/>
@@ -8448,7 +8448,7 @@
                             <a:schemeClr val="tx1"/>
                           </a:solidFill>
                         </a:rPr>
-                        <a:t>0.33</a:t>
+                        <a:t>0.40</a:t>
                       </a:r>
                       <a:endParaRPr lang="en-US" sz="1200" dirty="0"/>
                     </a:p>
@@ -8506,7 +8506,7 @@
                             <a:schemeClr val="tx1"/>
                           </a:solidFill>
                         </a:rPr>
-                        <a:t>0.09</a:t>
+                        <a:t>0.18</a:t>
                       </a:r>
                       <a:endParaRPr lang="en-US" sz="1200" dirty="0"/>
                     </a:p>
@@ -8564,7 +8564,7 @@
                             <a:schemeClr val="tx1"/>
                           </a:solidFill>
                         </a:rPr>
-                        <a:t>1/2/10</a:t>
+                        <a:t>2/3/9</a:t>
                       </a:r>
                       <a:endParaRPr lang="en-US" sz="1200" dirty="0"/>
                     </a:p>
@@ -9384,7 +9384,7 @@
                             <a:schemeClr val="tx1"/>
                           </a:solidFill>
                         </a:rPr>
-                        <a:t>41 of 44</a:t>
+                        <a:t>40 of 44</a:t>
                       </a:r>
                       <a:endParaRPr lang="en-US" sz="1200" dirty="0"/>
                     </a:p>
@@ -9492,7 +9492,7 @@
                             <a:schemeClr val="tx1"/>
                           </a:solidFill>
                         </a:rPr>
-                        <a:t>93% specificity</a:t>
+                        <a:t>91% specificity</a:t>
                       </a:r>
                       <a:endParaRPr lang="en-US" sz="1200" dirty="0"/>
                     </a:p>
@@ -9571,7 +9571,7 @@
                   <a:schemeClr val="tx2"/>
                 </a:solidFill>
               </a:rPr>
-              <a:t>Against 101 team-labelled images, 61 of them three-quarter views. Honest result: the phone mode is conservative. 93% of clean trucks pass without a false alarm, but it caught only 2 of 41 labelled positives, mostly three-quarter and rear views where no scale object is visible. The calibrated gate camera is the fix, not a bigger model.</a:t>
+              <a:t>Against 101 team-labelled images, 61 of them three-quarter views. Honest result: the phone mode is conservative. 91% of clean trucks pass without a false alarm, but it caught only 3 of 41 labelled positives, mostly three-quarter views where no scale object is visible. The calibrated gate camera is the fix, not a bigger model.</a:t>
             </a:r>
             <a:endParaRPr lang="en-US" sz="1000" dirty="0"/>
           </a:p>

</xml_diff>

<commit_message>
Height = highest detection resting on the truck (tall loads on low-loaders were measured as the truck only); over-height tp 1 -> 3, specificity 89%
Co-Authored-By: Claude Fable 5.1 <noreply@anthropic.com>
</commit_message>
<xml_diff>
--- a/deck/LoadSafetyGate_deck.pptx
+++ b/deck/LoadSafetyGate_deck.pptx
@@ -116,22 +116,22 @@
   <p:extLst>
     <p:ext uri="{521415D9-36F7-43E2-AB2F-B90AF26B5E84}">
       <p14:sectionLst xmlns:p14="http://schemas.microsoft.com/office/powerpoint/2010/main">
-        <p14:section name="Opening" id="{66d3fdb2-f0b3-d64b-551b-6651412fcd34}">
+        <p14:section name="Opening" id="{eab30b6c-6b65-23fa-a2da-b104a7e0a22d}">
           <p14:sldIdLst>
             <p14:sldId id="256"/>
           </p14:sldIdLst>
         </p14:section>
-        <p14:section name="Problem" id="{dbce6cf2-354d-2183-8ff5-2490299e6d15}">
+        <p14:section name="Problem" id="{096ffa6a-418b-8de4-1b47-679c629ed93b}">
           <p14:sldIdLst>
             <p14:sldId id="257"/>
           </p14:sldIdLst>
         </p14:section>
-        <p14:section name="Demo" id="{bbb303e9-1677-b929-f6f6-efcaad169647}">
+        <p14:section name="Demo" id="{4febb9a0-ae27-0476-c60c-d15fe10e1e0e}">
           <p14:sldIdLst>
             <p14:sldId id="258"/>
           </p14:sldIdLst>
         </p14:section>
-        <p14:section name="Technology" id="{093a39bb-a0c3-bf21-1f68-d46603b2fc16}">
+        <p14:section name="Technology" id="{7e541daf-bccb-3881-f7c9-f2d49e7b0257}">
           <p14:sldIdLst>
             <p14:sldId id="259"/>
             <p14:sldId id="260"/>
@@ -140,7 +140,7 @@
             <p14:sldId id="263"/>
           </p14:sldIdLst>
         </p14:section>
-        <p14:section name="Business" id="{cd218f0a-c8f3-772a-fc44-58aed8758567}">
+        <p14:section name="Business" id="{371d766f-00c6-ff9d-6701-53b79b533a9c}">
           <p14:sldIdLst>
             <p14:sldId id="264"/>
             <p14:sldId id="265"/>
@@ -9150,7 +9150,7 @@
                             <a:schemeClr val="tx1"/>
                           </a:solidFill>
                         </a:rPr>
-                        <a:t>0.33</a:t>
+                        <a:t>0.50</a:t>
                       </a:r>
                       <a:endParaRPr lang="en-US" sz="1200" dirty="0"/>
                     </a:p>
@@ -9208,7 +9208,7 @@
                             <a:schemeClr val="tx1"/>
                           </a:solidFill>
                         </a:rPr>
-                        <a:t>0.06</a:t>
+                        <a:t>0.18</a:t>
                       </a:r>
                       <a:endParaRPr lang="en-US" sz="1200" dirty="0"/>
                     </a:p>
@@ -9266,7 +9266,7 @@
                             <a:schemeClr val="tx1"/>
                           </a:solidFill>
                         </a:rPr>
-                        <a:t>1/2/16</a:t>
+                        <a:t>3/3/14</a:t>
                       </a:r>
                       <a:endParaRPr lang="en-US" sz="1200" dirty="0"/>
                     </a:p>
@@ -9384,7 +9384,7 @@
                             <a:schemeClr val="tx1"/>
                           </a:solidFill>
                         </a:rPr>
-                        <a:t>40 of 44</a:t>
+                        <a:t>39 of 44</a:t>
                       </a:r>
                       <a:endParaRPr lang="en-US" sz="1200" dirty="0"/>
                     </a:p>
@@ -9492,7 +9492,7 @@
                             <a:schemeClr val="tx1"/>
                           </a:solidFill>
                         </a:rPr>
-                        <a:t>91% specificity</a:t>
+                        <a:t>89% specificity</a:t>
                       </a:r>
                       <a:endParaRPr lang="en-US" sz="1200" dirty="0"/>
                     </a:p>
@@ -9571,7 +9571,7 @@
                   <a:schemeClr val="tx2"/>
                 </a:solidFill>
               </a:rPr>
-              <a:t>Against 101 team-labelled images, 61 of them three-quarter views. Honest result: the phone mode is conservative. 91% of clean trucks pass without a false alarm, but it caught only 3 of 41 labelled positives, mostly three-quarter views where no scale object is visible. The calibrated gate camera is the fix, not a bigger model.</a:t>
+              <a:t>Against 101 team-labelled images, 61 of them three-quarter views. Honest result: the phone mode is conservative. 89% of clean trucks pass without a false alarm, but it caught only 5 of 41 labelled positives, mostly three-quarter views where no scale object is visible. The calibrated gate camera is the fix, not a bigger model.</a:t>
             </a:r>
             <a:endParaRPr lang="en-US" sz="1000" dirty="0"/>
           </a:p>

</xml_diff>

<commit_message>
Tall loads: vehicle-only box for view/wheels/body width, wheel radius bounded by rig length, heights above 8 m reported as unreliable scale; over-height tp 1 -> 4
Co-Authored-By: Claude Fable 5.1 <noreply@anthropic.com>
</commit_message>
<xml_diff>
--- a/deck/LoadSafetyGate_deck.pptx
+++ b/deck/LoadSafetyGate_deck.pptx
@@ -116,22 +116,22 @@
   <p:extLst>
     <p:ext uri="{521415D9-36F7-43E2-AB2F-B90AF26B5E84}">
       <p14:sectionLst xmlns:p14="http://schemas.microsoft.com/office/powerpoint/2010/main">
-        <p14:section name="Opening" id="{eab30b6c-6b65-23fa-a2da-b104a7e0a22d}">
+        <p14:section name="Opening" id="{778ca4fb-4679-a42c-d657-5f09c2fcc6b1}">
           <p14:sldIdLst>
             <p14:sldId id="256"/>
           </p14:sldIdLst>
         </p14:section>
-        <p14:section name="Problem" id="{096ffa6a-418b-8de4-1b47-679c629ed93b}">
+        <p14:section name="Problem" id="{72c8a4ed-f41c-b867-97f8-48f0cc0f4ca4}">
           <p14:sldIdLst>
             <p14:sldId id="257"/>
           </p14:sldIdLst>
         </p14:section>
-        <p14:section name="Demo" id="{4febb9a0-ae27-0476-c60c-d15fe10e1e0e}">
+        <p14:section name="Demo" id="{2b1dc162-c32f-d3b9-ff2a-43c875686aaf}">
           <p14:sldIdLst>
             <p14:sldId id="258"/>
           </p14:sldIdLst>
         </p14:section>
-        <p14:section name="Technology" id="{7e541daf-bccb-3881-f7c9-f2d49e7b0257}">
+        <p14:section name="Technology" id="{1d3564b3-70f5-27dc-adbb-7f2ea75a84ed}">
           <p14:sldIdLst>
             <p14:sldId id="259"/>
             <p14:sldId id="260"/>
@@ -140,7 +140,7 @@
             <p14:sldId id="263"/>
           </p14:sldIdLst>
         </p14:section>
-        <p14:section name="Business" id="{371d766f-00c6-ff9d-6701-53b79b533a9c}">
+        <p14:section name="Business" id="{dbe03ec3-0df9-ca87-75fe-b6b6c84c11c1}">
           <p14:sldIdLst>
             <p14:sldId id="264"/>
             <p14:sldId id="265"/>
@@ -9150,7 +9150,7 @@
                             <a:schemeClr val="tx1"/>
                           </a:solidFill>
                         </a:rPr>
-                        <a:t>0.50</a:t>
+                        <a:t>0.57</a:t>
                       </a:r>
                       <a:endParaRPr lang="en-US" sz="1200" dirty="0"/>
                     </a:p>
@@ -9208,7 +9208,7 @@
                             <a:schemeClr val="tx1"/>
                           </a:solidFill>
                         </a:rPr>
-                        <a:t>0.18</a:t>
+                        <a:t>0.24</a:t>
                       </a:r>
                       <a:endParaRPr lang="en-US" sz="1200" dirty="0"/>
                     </a:p>
@@ -9266,7 +9266,7 @@
                             <a:schemeClr val="tx1"/>
                           </a:solidFill>
                         </a:rPr>
-                        <a:t>3/3/14</a:t>
+                        <a:t>4/3/13</a:t>
                       </a:r>
                       <a:endParaRPr lang="en-US" sz="1200" dirty="0"/>
                     </a:p>
@@ -9571,7 +9571,7 @@
                   <a:schemeClr val="tx2"/>
                 </a:solidFill>
               </a:rPr>
-              <a:t>Against 101 team-labelled images, 61 of them three-quarter views. Honest result: the phone mode is conservative. 89% of clean trucks pass without a false alarm, but it caught only 5 of 41 labelled positives, mostly three-quarter views where no scale object is visible. The calibrated gate camera is the fix, not a bigger model.</a:t>
+              <a:t>Against 101 team-labelled images, 61 of them three-quarter views. Honest result: the phone mode is conservative. 89% of clean trucks pass without a false alarm, but it caught only 6 of 41 labelled positives, mostly three-quarter views where no scale object is visible. The calibrated gate camera is the fix, not a bigger model.</a:t>
             </a:r>
             <a:endParaRPr lang="en-US" sz="1000" dirty="0"/>
           </a:p>

</xml_diff>

<commit_message>
Deck slide 7: shadowed wheels failure case
Co-Authored-By: Claude Fable 5.1 <noreply@anthropic.com>
</commit_message>
<xml_diff>
--- a/deck/LoadSafetyGate_deck.pptx
+++ b/deck/LoadSafetyGate_deck.pptx
@@ -116,22 +116,22 @@
   <p:extLst>
     <p:ext uri="{521415D9-36F7-43E2-AB2F-B90AF26B5E84}">
       <p14:sectionLst xmlns:p14="http://schemas.microsoft.com/office/powerpoint/2010/main">
-        <p14:section name="Opening" id="{778ca4fb-4679-a42c-d657-5f09c2fcc6b1}">
+        <p14:section name="Opening" id="{4775a403-6953-750a-8255-e9fdc12cd710}">
           <p14:sldIdLst>
             <p14:sldId id="256"/>
           </p14:sldIdLst>
         </p14:section>
-        <p14:section name="Problem" id="{72c8a4ed-f41c-b867-97f8-48f0cc0f4ca4}">
+        <p14:section name="Problem" id="{1de14be8-bc18-d57d-50c1-bc3f0c3a050d}">
           <p14:sldIdLst>
             <p14:sldId id="257"/>
           </p14:sldIdLst>
         </p14:section>
-        <p14:section name="Demo" id="{2b1dc162-c32f-d3b9-ff2a-43c875686aaf}">
+        <p14:section name="Demo" id="{2abc16c3-fef9-8808-98c6-ba67452de70b}">
           <p14:sldIdLst>
             <p14:sldId id="258"/>
           </p14:sldIdLst>
         </p14:section>
-        <p14:section name="Technology" id="{1d3564b3-70f5-27dc-adbb-7f2ea75a84ed}">
+        <p14:section name="Technology" id="{1a1663b7-3602-f6d0-d6a0-d8e16d35a0a1}">
           <p14:sldIdLst>
             <p14:sldId id="259"/>
             <p14:sldId id="260"/>
@@ -140,7 +140,7 @@
             <p14:sldId id="263"/>
           </p14:sldIdLst>
         </p14:section>
-        <p14:section name="Business" id="{dbe03ec3-0df9-ca87-75fe-b6b6c84c11c1}">
+        <p14:section name="Business" id="{d6770123-47df-9e12-cfc9-02dad1b6edc8}">
           <p14:sldIdLst>
             <p14:sldId id="264"/>
             <p14:sldId id="265"/>
@@ -10156,7 +10156,7 @@
                   <a:schemeClr val="tx2"/>
                 </a:solidFill>
               </a:rPr>
-              <a:t>Night street with no truck in frame: CANNOT ASSESS. Dark trucks at night give a noisy mask edge and lower roll confidence; cargo the same colour as the body can merge into the mask.</a:t>
+              <a:t>Night street with no truck in frame: CANNOT ASSESS. Wheels hidden in shadow or behind tanks give a wrong scale; a height that comes out above 8 m is shown as unreliable, never reported as a measurement.</a:t>
             </a:r>
             <a:endParaRPr lang="en-US" sz="1200" dirty="0"/>
           </a:p>

</xml_diff>

<commit_message>
Deck slide 5: three annotated photos instead of text cards
Co-Authored-By: Claude Fable 5.1 <noreply@anthropic.com>
</commit_message>
<xml_diff>
--- a/deck/LoadSafetyGate_deck.pptx
+++ b/deck/LoadSafetyGate_deck.pptx
@@ -116,22 +116,22 @@
   <p:extLst>
     <p:ext uri="{521415D9-36F7-43E2-AB2F-B90AF26B5E84}">
       <p14:sectionLst xmlns:p14="http://schemas.microsoft.com/office/powerpoint/2010/main">
-        <p14:section name="Opening" id="{4775a403-6953-750a-8255-e9fdc12cd710}">
+        <p14:section name="Opening" id="{2411df9f-7252-c906-8d67-36b160a4d231}">
           <p14:sldIdLst>
             <p14:sldId id="256"/>
           </p14:sldIdLst>
         </p14:section>
-        <p14:section name="Problem" id="{1de14be8-bc18-d57d-50c1-bc3f0c3a050d}">
+        <p14:section name="Problem" id="{105a1b19-ef4c-9eb8-af59-4740a307ca2d}">
           <p14:sldIdLst>
             <p14:sldId id="257"/>
           </p14:sldIdLst>
         </p14:section>
-        <p14:section name="Demo" id="{2abc16c3-fef9-8808-98c6-ba67452de70b}">
+        <p14:section name="Demo" id="{7ce76d47-aac0-1ab8-6d66-f2a59a1fc0a1}">
           <p14:sldIdLst>
             <p14:sldId id="258"/>
           </p14:sldIdLst>
         </p14:section>
-        <p14:section name="Technology" id="{1a1663b7-3602-f6d0-d6a0-d8e16d35a0a1}">
+        <p14:section name="Technology" id="{c33bcd73-e40e-1f0c-5382-7c88e8c3eee5}">
           <p14:sldIdLst>
             <p14:sldId id="259"/>
             <p14:sldId id="260"/>
@@ -140,7 +140,7 @@
             <p14:sldId id="263"/>
           </p14:sldIdLst>
         </p14:section>
-        <p14:section name="Business" id="{d6770123-47df-9e12-cfc9-02dad1b6edc8}">
+        <p14:section name="Business" id="{806732d8-76ac-2665-c060-ca9f2584f200}">
           <p14:sldIdLst>
             <p14:sldId id="264"/>
             <p14:sldId id="265"/>
@@ -5317,66 +5317,39 @@
           </a:p>
         </p:txBody>
       </p:sp>
-      <p:sp>
-        <p:nvSpPr>
-          <p:cNvPr id="3" name="Shape 1"/>
-          <p:cNvSpPr/>
+      <p:pic>
+        <p:nvPicPr>
+          <p:cNvPr id="3" name="Image 0" descr="../eval/out/flatbed_13_08_09_hongkong_by_RalfR_016_jpg.jpg">    </p:cNvPr>
+          <p:cNvPicPr>
+            <a:picLocks noChangeAspect="1"/>
+          </p:cNvPicPr>
           <p:nvPr/>
-        </p:nvSpPr>
-        <p:spPr>
-          <a:xfrm>
-            <a:off x="457200" y="1371600"/>
-            <a:ext cx="3657600" cy="3291840"/>
-          </a:xfrm>
-          <a:prstGeom prst="rect">
-            <a:avLst/>
-          </a:prstGeom>
-          <a:solidFill>
-            <a:srgbClr val="EEF0EC"/>
-          </a:solidFill>
-          <a:ln w="12700">
-            <a:solidFill>
-              <a:srgbClr val="EEF0EC"/>
-            </a:solidFill>
-            <a:prstDash val="solid"/>
-          </a:ln>
-        </p:spPr>
-      </p:sp>
-      <p:sp>
-        <p:nvSpPr>
-          <p:cNvPr id="4" name="Shape 2"/>
-          <p:cNvSpPr/>
-          <p:nvPr/>
-        </p:nvSpPr>
-        <p:spPr>
-          <a:xfrm>
-            <a:off x="640080" y="1554480"/>
-            <a:ext cx="384048" cy="384048"/>
-          </a:xfrm>
-          <a:prstGeom prst="ellipse">
-            <a:avLst/>
-          </a:prstGeom>
-          <a:solidFill>
-            <a:srgbClr val="1F5F8B"/>
-          </a:solidFill>
-          <a:ln w="12700">
-            <a:solidFill>
-              <a:srgbClr val="1F5F8B"/>
-            </a:solidFill>
-            <a:prstDash val="solid"/>
-          </a:ln>
-        </p:spPr>
-      </p:sp>
-      <p:sp>
-        <p:nvSpPr>
-          <p:cNvPr id="5" name="Text 3"/>
+        </p:nvPicPr>
+        <p:blipFill>
+          <a:blip r:embed="rId1"/>
+          <a:srcRect l="0" r="0" t="0" b="0"/>
+          <a:stretch/>
+        </p:blipFill>
+        <p:spPr>
+          <a:xfrm>
+            <a:off x="457200" y="1280160"/>
+            <a:ext cx="3611880" cy="2651760"/>
+          </a:xfrm>
+          <a:prstGeom prst="rect">
+            <a:avLst/>
+          </a:prstGeom>
+        </p:spPr>
+      </p:pic>
+      <p:sp>
+        <p:nvSpPr>
+          <p:cNvPr id="4" name="Text 1"/>
           <p:cNvSpPr txBox="1"/>
           <p:nvPr/>
         </p:nvSpPr>
         <p:spPr>
           <a:xfrm>
-            <a:off x="1143000" y="1508760"/>
-            <a:ext cx="2788920" cy="457200"/>
+            <a:off x="457200" y="4023360"/>
+            <a:ext cx="3611880" cy="365760"/>
           </a:xfrm>
           <a:prstGeom prst="rect">
             <a:avLst/>
@@ -5394,7 +5367,7 @@
             <a:r>
               <a:rPr lang="en-US" sz="1600" b="1" dirty="0">
                 <a:solidFill>
-                  <a:schemeClr val="tx1"/>
+                  <a:srgbClr val="1F5F8B"/>
                 </a:solidFill>
               </a:rPr>
               <a:t>Body roll</a:t>
@@ -5405,14 +5378,14 @@
       </p:sp>
       <p:sp>
         <p:nvSpPr>
-          <p:cNvPr id="6" name="Text 4"/>
+          <p:cNvPr id="5" name="Text 2"/>
           <p:cNvSpPr txBox="1"/>
           <p:nvPr/>
         </p:nvSpPr>
         <p:spPr>
           <a:xfrm>
-            <a:off x="640080" y="1993392"/>
-            <a:ext cx="3291840" cy="2578608"/>
+            <a:off x="457200" y="4389120"/>
+            <a:ext cx="3611880" cy="1188720"/>
           </a:xfrm>
           <a:prstGeom prst="rect">
             <a:avLst/>
@@ -5433,72 +5406,45 @@
                   <a:schemeClr val="tx2"/>
                 </a:solidFill>
               </a:rPr>
-              <a:t>Horizontal edges converge under perspective, so a level truck looks tilted if you compare top and bottom edges. We use the body's vertical edges instead: left and right halves converge in opposite directions and their mean cancels perspective. Reference: vertical lines in the scene (poles, walls), else the camera vertical at lower confidence.</a:t>
+              <a:t>Green: the body's vertical edges. Cyan: vertical lines in the scene. The angle between them is the roll, so a tilted phone does not tilt the truck.</a:t>
             </a:r>
             <a:endParaRPr lang="en-US" sz="1200" dirty="0"/>
           </a:p>
         </p:txBody>
       </p:sp>
-      <p:sp>
-        <p:nvSpPr>
-          <p:cNvPr id="7" name="Shape 5"/>
-          <p:cNvSpPr/>
+      <p:pic>
+        <p:nvPicPr>
+          <p:cNvPr id="6" name="Image 1" descr="../eval/out/car_carrier_Ram_3500_DS_Towing_BMW_X5_F15_JPG.jpg">    </p:cNvPr>
+          <p:cNvPicPr>
+            <a:picLocks noChangeAspect="1"/>
+          </p:cNvPicPr>
           <p:nvPr/>
-        </p:nvSpPr>
-        <p:spPr>
-          <a:xfrm>
-            <a:off x="4251960" y="1371600"/>
-            <a:ext cx="3657600" cy="3291840"/>
-          </a:xfrm>
-          <a:prstGeom prst="rect">
-            <a:avLst/>
-          </a:prstGeom>
-          <a:solidFill>
-            <a:srgbClr val="EEF0EC"/>
-          </a:solidFill>
-          <a:ln w="12700">
-            <a:solidFill>
-              <a:srgbClr val="EEF0EC"/>
-            </a:solidFill>
-            <a:prstDash val="solid"/>
-          </a:ln>
-        </p:spPr>
-      </p:sp>
-      <p:sp>
-        <p:nvSpPr>
-          <p:cNvPr id="8" name="Shape 6"/>
-          <p:cNvSpPr/>
-          <p:nvPr/>
-        </p:nvSpPr>
-        <p:spPr>
-          <a:xfrm>
-            <a:off x="4434840" y="1554480"/>
-            <a:ext cx="384048" cy="384048"/>
-          </a:xfrm>
-          <a:prstGeom prst="ellipse">
-            <a:avLst/>
-          </a:prstGeom>
-          <a:solidFill>
-            <a:srgbClr val="E03A3A"/>
-          </a:solidFill>
-          <a:ln w="12700">
-            <a:solidFill>
-              <a:srgbClr val="E03A3A"/>
-            </a:solidFill>
-            <a:prstDash val="solid"/>
-          </a:ln>
-        </p:spPr>
-      </p:sp>
-      <p:sp>
-        <p:nvSpPr>
-          <p:cNvPr id="9" name="Text 7"/>
+        </p:nvPicPr>
+        <p:blipFill>
+          <a:blip r:embed="rId2"/>
+          <a:srcRect l="0" r="0" t="0" b="0"/>
+          <a:stretch/>
+        </p:blipFill>
+        <p:spPr>
+          <a:xfrm>
+            <a:off x="4251960" y="1280160"/>
+            <a:ext cx="3611880" cy="2651760"/>
+          </a:xfrm>
+          <a:prstGeom prst="rect">
+            <a:avLst/>
+          </a:prstGeom>
+        </p:spPr>
+      </p:pic>
+      <p:sp>
+        <p:nvSpPr>
+          <p:cNvPr id="7" name="Text 3"/>
           <p:cNvSpPr txBox="1"/>
           <p:nvPr/>
         </p:nvSpPr>
         <p:spPr>
           <a:xfrm>
-            <a:off x="4937760" y="1508760"/>
-            <a:ext cx="2788920" cy="457200"/>
+            <a:off x="4251960" y="4023360"/>
+            <a:ext cx="3611880" cy="365760"/>
           </a:xfrm>
           <a:prstGeom prst="rect">
             <a:avLst/>
@@ -5516,7 +5462,7 @@
             <a:r>
               <a:rPr lang="en-US" sz="1600" b="1" dirty="0">
                 <a:solidFill>
-                  <a:schemeClr val="tx1"/>
+                  <a:srgbClr val="E03A3A"/>
                 </a:solidFill>
               </a:rPr>
               <a:t>Overhang</a:t>
@@ -5527,14 +5473,14 @@
       </p:sp>
       <p:sp>
         <p:nvSpPr>
-          <p:cNvPr id="10" name="Text 8"/>
+          <p:cNvPr id="8" name="Text 4"/>
           <p:cNvSpPr txBox="1"/>
           <p:nvPr/>
         </p:nvSpPr>
         <p:spPr>
           <a:xfrm>
-            <a:off x="4434840" y="1993392"/>
-            <a:ext cx="3291840" cy="2578608"/>
+            <a:off x="4251960" y="4389120"/>
+            <a:ext cx="3611880" cy="1188720"/>
           </a:xfrm>
           <a:prstGeom prst="rect">
             <a:avLst/>
@@ -5555,72 +5501,45 @@
                   <a:schemeClr val="tx2"/>
                 </a:solidFill>
               </a:rPr>
-              <a:t>Cargo extent beyond the body edge at cargo height. Rear overhang in a side view, side overhang in a rear view. Converted to centimetres with a known object in the same image: body width 2.55 m or wheel diameter 1.05 m.</a:t>
+              <a:t>Red: cargo beyond the body edge, converted to centimetres with the 1.05 m wheel or the 2.55 m body width in the same photo.</a:t>
             </a:r>
             <a:endParaRPr lang="en-US" sz="1200" dirty="0"/>
           </a:p>
         </p:txBody>
       </p:sp>
-      <p:sp>
-        <p:nvSpPr>
-          <p:cNvPr id="11" name="Shape 9"/>
-          <p:cNvSpPr/>
+      <p:pic>
+        <p:nvPicPr>
+          <p:cNvPr id="9" name="Image 2" descr="../eval/out/oversized_Abnormal_Load_Front_End_Loader_Mammoet_Near_Ogies_15_3_2012.jpg">    </p:cNvPr>
+          <p:cNvPicPr>
+            <a:picLocks noChangeAspect="1"/>
+          </p:cNvPicPr>
           <p:nvPr/>
-        </p:nvSpPr>
-        <p:spPr>
-          <a:xfrm>
-            <a:off x="8046720" y="1371600"/>
-            <a:ext cx="3657600" cy="3291840"/>
-          </a:xfrm>
-          <a:prstGeom prst="rect">
-            <a:avLst/>
-          </a:prstGeom>
-          <a:solidFill>
-            <a:srgbClr val="EEF0EC"/>
-          </a:solidFill>
-          <a:ln w="12700">
-            <a:solidFill>
-              <a:srgbClr val="EEF0EC"/>
-            </a:solidFill>
-            <a:prstDash val="solid"/>
-          </a:ln>
-        </p:spPr>
-      </p:sp>
-      <p:sp>
-        <p:nvSpPr>
-          <p:cNvPr id="12" name="Shape 10"/>
-          <p:cNvSpPr/>
-          <p:nvPr/>
-        </p:nvSpPr>
-        <p:spPr>
-          <a:xfrm>
-            <a:off x="8229600" y="1554480"/>
-            <a:ext cx="384048" cy="384048"/>
-          </a:xfrm>
-          <a:prstGeom prst="ellipse">
-            <a:avLst/>
-          </a:prstGeom>
-          <a:solidFill>
-            <a:srgbClr val="F2B705"/>
-          </a:solidFill>
-          <a:ln w="12700">
-            <a:solidFill>
-              <a:srgbClr val="F2B705"/>
-            </a:solidFill>
-            <a:prstDash val="solid"/>
-          </a:ln>
-        </p:spPr>
-      </p:sp>
-      <p:sp>
-        <p:nvSpPr>
-          <p:cNvPr id="13" name="Text 11"/>
+        </p:nvPicPr>
+        <p:blipFill>
+          <a:blip r:embed="rId3"/>
+          <a:srcRect l="0" r="0" t="0" b="0"/>
+          <a:stretch/>
+        </p:blipFill>
+        <p:spPr>
+          <a:xfrm>
+            <a:off x="8046720" y="1280160"/>
+            <a:ext cx="3611880" cy="2651760"/>
+          </a:xfrm>
+          <a:prstGeom prst="rect">
+            <a:avLst/>
+          </a:prstGeom>
+        </p:spPr>
+      </p:pic>
+      <p:sp>
+        <p:nvSpPr>
+          <p:cNvPr id="10" name="Text 5"/>
           <p:cNvSpPr txBox="1"/>
           <p:nvPr/>
         </p:nvSpPr>
         <p:spPr>
           <a:xfrm>
-            <a:off x="8732520" y="1508760"/>
-            <a:ext cx="2788920" cy="457200"/>
+            <a:off x="8046720" y="4023360"/>
+            <a:ext cx="3611880" cy="365760"/>
           </a:xfrm>
           <a:prstGeom prst="rect">
             <a:avLst/>
@@ -5638,7 +5557,7 @@
             <a:r>
               <a:rPr lang="en-US" sz="1600" b="1" dirty="0">
                 <a:solidFill>
-                  <a:schemeClr val="tx1"/>
+                  <a:srgbClr val="F2B705"/>
                 </a:solidFill>
               </a:rPr>
               <a:t>Height</a:t>
@@ -5649,14 +5568,14 @@
       </p:sp>
       <p:sp>
         <p:nvSpPr>
-          <p:cNvPr id="14" name="Text 12"/>
+          <p:cNvPr id="11" name="Text 6"/>
           <p:cNvSpPr txBox="1"/>
           <p:nvPr/>
         </p:nvSpPr>
         <p:spPr>
           <a:xfrm>
-            <a:off x="8229600" y="1993392"/>
-            <a:ext cx="3291840" cy="2578608"/>
+            <a:off x="8046720" y="4389120"/>
+            <a:ext cx="3611880" cy="1188720"/>
           </a:xfrm>
           <a:prstGeom prst="rect">
             <a:avLst/>
@@ -5677,7 +5596,7 @@
                   <a:schemeClr val="tx2"/>
                 </a:solidFill>
               </a:rPr>
-              <a:t>Ground line through the tyre contact points to the top of cargo or body, same scale. Compared with the 4.0 m legal limit.</a:t>
+              <a:t>Magenta: cargo top to the ground line through the tyres, in metres, against the 4.0 m limit.</a:t>
             </a:r>
             <a:endParaRPr lang="en-US" sz="1200" dirty="0"/>
           </a:p>
@@ -5685,64 +5604,14 @@
       </p:sp>
       <p:sp>
         <p:nvSpPr>
-          <p:cNvPr id="15" name="Shape 13"/>
-          <p:cNvSpPr/>
-          <p:nvPr/>
-        </p:nvSpPr>
-        <p:spPr>
-          <a:xfrm>
-            <a:off x="457200" y="4846320"/>
-            <a:ext cx="11247120" cy="1280160"/>
-          </a:xfrm>
-          <a:prstGeom prst="rect">
-            <a:avLst/>
-          </a:prstGeom>
-          <a:solidFill>
-            <a:srgbClr val="EEF0EC"/>
-          </a:solidFill>
-          <a:ln w="12700">
-            <a:solidFill>
-              <a:srgbClr val="EEF0EC"/>
-            </a:solidFill>
-            <a:prstDash val="solid"/>
-          </a:ln>
-        </p:spPr>
-      </p:sp>
-      <p:sp>
-        <p:nvSpPr>
-          <p:cNvPr id="16" name="Shape 14"/>
-          <p:cNvSpPr/>
-          <p:nvPr/>
-        </p:nvSpPr>
-        <p:spPr>
-          <a:xfrm>
-            <a:off x="640080" y="5029200"/>
-            <a:ext cx="384048" cy="384048"/>
-          </a:xfrm>
-          <a:prstGeom prst="ellipse">
-            <a:avLst/>
-          </a:prstGeom>
-          <a:solidFill>
-            <a:srgbClr val="2A8A4A"/>
-          </a:solidFill>
-          <a:ln w="12700">
-            <a:solidFill>
-              <a:srgbClr val="2A8A4A"/>
-            </a:solidFill>
-            <a:prstDash val="solid"/>
-          </a:ln>
-        </p:spPr>
-      </p:sp>
-      <p:sp>
-        <p:nvSpPr>
-          <p:cNvPr id="17" name="Text 15"/>
+          <p:cNvPr id="12" name="Text 7"/>
           <p:cNvSpPr txBox="1"/>
           <p:nvPr/>
         </p:nvSpPr>
         <p:spPr>
           <a:xfrm>
-            <a:off x="1143000" y="4983480"/>
-            <a:ext cx="10378440" cy="457200"/>
+            <a:off x="457200" y="5577840"/>
+            <a:ext cx="11247120" cy="457200"/>
           </a:xfrm>
           <a:prstGeom prst="rect">
             <a:avLst/>
@@ -5758,27 +5627,27 @@
               <a:buNone/>
             </a:pPr>
             <a:r>
-              <a:rPr lang="en-US" sz="1600" b="1" dirty="0">
+              <a:rPr lang="en-US" sz="1300" dirty="0">
                 <a:solidFill>
                   <a:schemeClr val="tx1"/>
                 </a:solidFill>
               </a:rPr>
-              <a:t>Product version</a:t>
+              <a:t>Every number is relative to an object in the same photo. No camera calibration, no absolute pose. When the photo has no usable reference the check says CANNOT ASSESS.</a:t>
             </a:r>
-            <a:endParaRPr lang="en-US" sz="1600" dirty="0"/>
+            <a:endParaRPr lang="en-US" sz="1300" dirty="0"/>
           </a:p>
         </p:txBody>
       </p:sp>
       <p:sp>
         <p:nvSpPr>
-          <p:cNvPr id="18" name="Text 16"/>
+          <p:cNvPr id="13" name="Text 8"/>
           <p:cNvSpPr txBox="1"/>
           <p:nvPr/>
         </p:nvSpPr>
         <p:spPr>
           <a:xfrm>
-            <a:off x="640080" y="5468112"/>
-            <a:ext cx="10881360" cy="566928"/>
+            <a:off x="457200" y="6035040"/>
+            <a:ext cx="11247120" cy="320040"/>
           </a:xfrm>
           <a:prstGeom prst="rect">
             <a:avLst/>
@@ -5787,21 +5656,21 @@
           <a:ln/>
         </p:spPr>
         <p:txBody>
-          <a:bodyPr wrap="square" lIns="0" tIns="0" rIns="0" bIns="0" rtlCol="0" anchor="t"/>
+          <a:bodyPr wrap="square" lIns="0" tIns="0" rIns="0" bIns="0" rtlCol="0" anchor="ctr"/>
           <a:lstStyle/>
           <a:p>
             <a:pPr indent="0" marL="0">
               <a:buNone/>
             </a:pPr>
             <a:r>
-              <a:rPr lang="en-US" sz="1200" dirty="0">
+              <a:rPr lang="en-US" sz="800" dirty="0">
                 <a:solidFill>
-                  <a:schemeClr val="tx2"/>
+                  <a:srgbClr val="8A96A0"/>
                 </a:solidFill>
               </a:rPr>
-              <a:t>A fixed gate camera with known position and a reference marker removes the remaining ambiguity. The phone mode you see today is the degraded fallback, and it says CANNOT ASSESS when the view does not support a measurement.</a:t>
+              <a:t>Photos: Wikimedia Commons, Ralf Roletschek (CC BY 3.0); Bull-Doser (Public domain); Bob Adams from George, South Africa (CC BY-SA 2.0). Annotations drawn by the pipeline.</a:t>
             </a:r>
-            <a:endParaRPr lang="en-US" sz="1200" dirty="0"/>
+            <a:endParaRPr lang="en-US" sz="800" dirty="0"/>
           </a:p>
         </p:txBody>
       </p:sp>

</xml_diff>

<commit_message>
Deck: remove the replication slide
Co-Authored-By: Claude Fable 5.1 <noreply@anthropic.com>
</commit_message>
<xml_diff>
--- a/deck/LoadSafetyGate_deck.pptx
+++ b/deck/LoadSafetyGate_deck.pptx
@@ -14,10 +14,9 @@
     <p:sldId id="262" r:id="rId8"/>
     <p:sldId id="263" r:id="rId9"/>
     <p:sldId id="264" r:id="rId10"/>
-    <p:sldId id="265" r:id="rId11"/>
   </p:sldIdLst>
   <p:notesMasterIdLst>
-    <p:notesMasterId r:id="rId12"/>
+    <p:notesMasterId r:id="rId11"/>
   </p:notesMasterIdLst>
   <p:sldSz cx="12192000" cy="6858000"/>
   <p:notesSz cx="6858000" cy="12192000"/>
@@ -116,34 +115,33 @@
   <p:extLst>
     <p:ext uri="{521415D9-36F7-43E2-AB2F-B90AF26B5E84}">
       <p14:sectionLst xmlns:p14="http://schemas.microsoft.com/office/powerpoint/2010/main">
-        <p14:section name="Opening" id="{2411df9f-7252-c906-8d67-36b160a4d231}">
+        <p14:section name="Opening" id="{c51a4084-375b-86fb-2370-9d7d14e21103}">
           <p14:sldIdLst>
             <p14:sldId id="256"/>
           </p14:sldIdLst>
         </p14:section>
-        <p14:section name="Problem" id="{105a1b19-ef4c-9eb8-af59-4740a307ca2d}">
+        <p14:section name="Problem" id="{c73b3cd7-44e0-2d70-5542-5ddd05547d1f}">
           <p14:sldIdLst>
             <p14:sldId id="257"/>
           </p14:sldIdLst>
         </p14:section>
-        <p14:section name="Demo" id="{7ce76d47-aac0-1ab8-6d66-f2a59a1fc0a1}">
+        <p14:section name="Demo" id="{10f041df-a752-15fb-d6c0-06b916aa03b8}">
           <p14:sldIdLst>
             <p14:sldId id="258"/>
           </p14:sldIdLst>
         </p14:section>
-        <p14:section name="Technology" id="{c33bcd73-e40e-1f0c-5382-7c88e8c3eee5}">
+        <p14:section name="Technology" id="{f4f2c24e-2cb9-a3af-2ac8-67ef902d0542}">
           <p14:sldIdLst>
             <p14:sldId id="259"/>
             <p14:sldId id="260"/>
             <p14:sldId id="261"/>
             <p14:sldId id="262"/>
-            <p14:sldId id="263"/>
           </p14:sldIdLst>
         </p14:section>
-        <p14:section name="Business" id="{806732d8-76ac-2665-c060-ca9f2584f200}">
+        <p14:section name="Business" id="{4dc4d476-e95a-4280-9065-327ee33a84a7}">
           <p14:sldIdLst>
+            <p14:sldId id="263"/>
             <p14:sldId id="264"/>
-            <p14:sldId id="265"/>
           </p14:sldIdLst>
         </p14:section>
       </p14:sectionLst>
@@ -574,94 +572,6 @@
             <a:fld id="{F7021451-1387-4CA6-816F-3879F97B5CBC}" type="slidenum">
               <a:rPr lang="en-US"/>
               <a:t>1</a:t>
-            </a:fld>
-            <a:endParaRPr lang="en-US"/>
-          </a:p>
-        </p:txBody>
-      </p:sp>
-    </p:spTree>
-    <p:extLst>
-      <p:ext uri="{BB962C8B-B14F-4D97-AF65-F5344CB8AC3E}">
-        <p14:creationId xmlns:p14="http://schemas.microsoft.com/office/powerpoint/2010/main" val="1024086991"/>
-      </p:ext>
-    </p:extLst>
-  </p:cSld>
-  <p:clrMapOvr>
-    <a:masterClrMapping/>
-  </p:clrMapOvr>
-</p:notes>
-</file>
-
-<file path=ppt/notesSlides/notesSlide10.xml><?xml version="1.0" encoding="utf-8"?>
-<p:notes xmlns:a="http://schemas.openxmlformats.org/drawingml/2006/main" xmlns:r="http://schemas.openxmlformats.org/officeDocument/2006/relationships" xmlns:p="http://schemas.openxmlformats.org/presentationml/2006/main">
-  <p:cSld>
-    <p:spTree>
-      <p:nvGrpSpPr>
-        <p:cNvPr id="1" name=""/>
-        <p:cNvGrpSpPr/>
-        <p:nvPr/>
-      </p:nvGrpSpPr>
-      <p:grpSpPr>
-        <a:xfrm>
-          <a:off x="0" y="0"/>
-          <a:ext cx="0" cy="0"/>
-          <a:chOff x="0" y="0"/>
-          <a:chExt cx="0" cy="0"/>
-        </a:xfrm>
-      </p:grpSpPr>
-      <p:sp>
-        <p:nvSpPr>
-          <p:cNvPr id="2" name="Slide Image Placeholder 1"/>
-          <p:cNvSpPr>
-            <a:spLocks noGrp="1" noRot="1" noChangeAspect="1"/>
-          </p:cNvSpPr>
-          <p:nvPr>
-            <p:ph type="sldImg"/>
-          </p:nvPr>
-        </p:nvSpPr>
-        <p:spPr/>
-      </p:sp>
-      <p:sp>
-        <p:nvSpPr>
-          <p:cNvPr id="3" name="Notes Placeholder 2"/>
-          <p:cNvSpPr>
-            <a:spLocks noGrp="1"/>
-          </p:cNvSpPr>
-          <p:nvPr>
-            <p:ph type="body" idx="1"/>
-          </p:nvPr>
-        </p:nvSpPr>
-        <p:spPr/>
-        <p:txBody>
-          <a:bodyPr/>
-          <a:lstStyle/>
-          <a:p>
-            <a:r>
-              <a:rPr lang="en-US" dirty="0"/>
-              <a:t/>
-            </a:r>
-            <a:endParaRPr lang="en-US" dirty="0"/>
-          </a:p>
-        </p:txBody>
-      </p:sp>
-      <p:sp>
-        <p:nvSpPr>
-          <p:cNvPr id="4" name="Slide Number Placeholder 3"/>
-          <p:cNvSpPr>
-            <a:spLocks noGrp="1"/>
-          </p:cNvSpPr>
-          <p:nvPr>
-            <p:ph type="sldNum" sz="quarter" idx="10"/>
-          </p:nvPr>
-        </p:nvSpPr>
-        <p:spPr/>
-        <p:txBody>
-          <a:bodyPr/>
-          <a:lstStyle/>
-          <a:p>
-            <a:fld id="{F7021451-1387-4CA6-816F-3879F97B5CBC}" type="slidenum">
-              <a:rPr lang="en-US"/>
-              <a:t>10</a:t>
             </a:fld>
             <a:endParaRPr lang="en-US"/>
           </a:p>
@@ -2409,442 +2319,6 @@
 </p:sld>
 </file>
 
-<file path=ppt/slides/slide10.xml><?xml version="1.0" encoding="utf-8"?>
-<p:sld xmlns:a="http://schemas.openxmlformats.org/drawingml/2006/main" xmlns:r="http://schemas.openxmlformats.org/officeDocument/2006/relationships" xmlns:p="http://schemas.openxmlformats.org/presentationml/2006/main">
-  <p:cSld name="Slide 10">
-    <p:spTree>
-      <p:nvGrpSpPr>
-        <p:cNvPr id="1" name=""/>
-        <p:cNvGrpSpPr/>
-        <p:nvPr/>
-      </p:nvGrpSpPr>
-      <p:grpSpPr>
-        <a:xfrm>
-          <a:off x="0" y="0"/>
-          <a:ext cx="0" cy="0"/>
-          <a:chOff x="0" y="0"/>
-          <a:chExt cx="0" cy="0"/>
-        </a:xfrm>
-      </p:grpSpPr>
-      <p:sp>
-        <p:nvSpPr>
-          <p:cNvPr id="2" name="Text 0"/>
-          <p:cNvSpPr txBox="1"/>
-          <p:nvPr/>
-        </p:nvSpPr>
-        <p:spPr>
-          <a:xfrm>
-            <a:off x="640080" y="457200"/>
-            <a:ext cx="10972800" cy="731520"/>
-          </a:xfrm>
-          <a:prstGeom prst="rect">
-            <a:avLst/>
-          </a:prstGeom>
-          <a:noFill/>
-          <a:ln/>
-        </p:spPr>
-        <p:txBody>
-          <a:bodyPr wrap="square" lIns="0" tIns="0" rIns="0" bIns="0" rtlCol="0" anchor="ctr"/>
-          <a:lstStyle/>
-          <a:p>
-            <a:pPr indent="0" marL="0">
-              <a:buNone/>
-            </a:pPr>
-            <a:r>
-              <a:rPr lang="en-US" sz="3600" b="1" dirty="0">
-                <a:solidFill>
-                  <a:schemeClr val="bg1"/>
-                </a:solidFill>
-                <a:latin typeface="Cambria" pitchFamily="34" charset="0"/>
-                <a:ea typeface="Cambria" pitchFamily="34" charset="-122"/>
-                <a:cs typeface="Cambria" pitchFamily="34" charset="-120"/>
-              </a:rPr>
-              <a:t>Next steps</a:t>
-            </a:r>
-            <a:endParaRPr lang="en-US" sz="3600" dirty="0"/>
-          </a:p>
-        </p:txBody>
-      </p:sp>
-      <p:sp>
-        <p:nvSpPr>
-          <p:cNvPr id="3" name="Shape 1"/>
-          <p:cNvSpPr/>
-          <p:nvPr/>
-        </p:nvSpPr>
-        <p:spPr>
-          <a:xfrm>
-            <a:off x="640080" y="1554480"/>
-            <a:ext cx="3474720" cy="2926080"/>
-          </a:xfrm>
-          <a:prstGeom prst="rect">
-            <a:avLst/>
-          </a:prstGeom>
-          <a:solidFill>
-            <a:srgbClr val="3A4248"/>
-          </a:solidFill>
-          <a:ln w="12700">
-            <a:solidFill>
-              <a:srgbClr val="3A4248"/>
-            </a:solidFill>
-            <a:prstDash val="solid"/>
-          </a:ln>
-        </p:spPr>
-      </p:sp>
-      <p:sp>
-        <p:nvSpPr>
-          <p:cNvPr id="4" name="Text 2"/>
-          <p:cNvSpPr txBox="1"/>
-          <p:nvPr/>
-        </p:nvSpPr>
-        <p:spPr>
-          <a:xfrm>
-            <a:off x="914400" y="1737360"/>
-            <a:ext cx="2926080" cy="457200"/>
-          </a:xfrm>
-          <a:prstGeom prst="rect">
-            <a:avLst/>
-          </a:prstGeom>
-          <a:noFill/>
-          <a:ln/>
-        </p:spPr>
-        <p:txBody>
-          <a:bodyPr wrap="square" lIns="0" tIns="0" rIns="0" bIns="0" rtlCol="0" anchor="ctr"/>
-          <a:lstStyle/>
-          <a:p>
-            <a:pPr indent="0" marL="0">
-              <a:buNone/>
-            </a:pPr>
-            <a:r>
-              <a:rPr lang="en-US" sz="2000" b="1" dirty="0">
-                <a:solidFill>
-                  <a:srgbClr val="F2B705"/>
-                </a:solidFill>
-              </a:rPr>
-              <a:t>Month 1</a:t>
-            </a:r>
-            <a:endParaRPr lang="en-US" sz="2000" dirty="0"/>
-          </a:p>
-        </p:txBody>
-      </p:sp>
-      <p:sp>
-        <p:nvSpPr>
-          <p:cNvPr id="5" name="Text 3"/>
-          <p:cNvSpPr txBox="1"/>
-          <p:nvPr/>
-        </p:nvSpPr>
-        <p:spPr>
-          <a:xfrm>
-            <a:off x="914400" y="2286000"/>
-            <a:ext cx="2926080" cy="2011680"/>
-          </a:xfrm>
-          <a:prstGeom prst="rect">
-            <a:avLst/>
-          </a:prstGeom>
-          <a:noFill/>
-          <a:ln/>
-        </p:spPr>
-        <p:txBody>
-          <a:bodyPr wrap="square" lIns="0" tIns="0" rIns="0" bIns="0" rtlCol="0" anchor="t"/>
-          <a:lstStyle/>
-          <a:p>
-            <a:pPr indent="0" marL="0">
-              <a:buNone/>
-            </a:pPr>
-            <a:r>
-              <a:rPr lang="en-US" sz="1400" dirty="0">
-                <a:solidFill>
-                  <a:schemeClr val="bg1"/>
-                </a:solidFill>
-              </a:rPr>
-              <a:t>Fixed, calibrated camera at one gate. Reference marker removes scale ambiguity. Ten-second video mode.</a:t>
-            </a:r>
-            <a:endParaRPr lang="en-US" sz="1400" dirty="0"/>
-          </a:p>
-        </p:txBody>
-      </p:sp>
-      <p:sp>
-        <p:nvSpPr>
-          <p:cNvPr id="6" name="Shape 4"/>
-          <p:cNvSpPr/>
-          <p:nvPr/>
-        </p:nvSpPr>
-        <p:spPr>
-          <a:xfrm>
-            <a:off x="4389120" y="1554480"/>
-            <a:ext cx="3474720" cy="2926080"/>
-          </a:xfrm>
-          <a:prstGeom prst="rect">
-            <a:avLst/>
-          </a:prstGeom>
-          <a:solidFill>
-            <a:srgbClr val="3A4248"/>
-          </a:solidFill>
-          <a:ln w="12700">
-            <a:solidFill>
-              <a:srgbClr val="3A4248"/>
-            </a:solidFill>
-            <a:prstDash val="solid"/>
-          </a:ln>
-        </p:spPr>
-      </p:sp>
-      <p:sp>
-        <p:nvSpPr>
-          <p:cNvPr id="7" name="Text 5"/>
-          <p:cNvSpPr txBox="1"/>
-          <p:nvPr/>
-        </p:nvSpPr>
-        <p:spPr>
-          <a:xfrm>
-            <a:off x="4663440" y="1737360"/>
-            <a:ext cx="2926080" cy="457200"/>
-          </a:xfrm>
-          <a:prstGeom prst="rect">
-            <a:avLst/>
-          </a:prstGeom>
-          <a:noFill/>
-          <a:ln/>
-        </p:spPr>
-        <p:txBody>
-          <a:bodyPr wrap="square" lIns="0" tIns="0" rIns="0" bIns="0" rtlCol="0" anchor="ctr"/>
-          <a:lstStyle/>
-          <a:p>
-            <a:pPr indent="0" marL="0">
-              <a:buNone/>
-            </a:pPr>
-            <a:r>
-              <a:rPr lang="en-US" sz="2000" b="1" dirty="0">
-                <a:solidFill>
-                  <a:srgbClr val="F2B705"/>
-                </a:solidFill>
-              </a:rPr>
-              <a:t>Month 2</a:t>
-            </a:r>
-            <a:endParaRPr lang="en-US" sz="2000" dirty="0"/>
-          </a:p>
-        </p:txBody>
-      </p:sp>
-      <p:sp>
-        <p:nvSpPr>
-          <p:cNvPr id="8" name="Text 6"/>
-          <p:cNvSpPr txBox="1"/>
-          <p:nvPr/>
-        </p:nvSpPr>
-        <p:spPr>
-          <a:xfrm>
-            <a:off x="4663440" y="2286000"/>
-            <a:ext cx="2926080" cy="2011680"/>
-          </a:xfrm>
-          <a:prstGeom prst="rect">
-            <a:avLst/>
-          </a:prstGeom>
-          <a:noFill/>
-          <a:ln/>
-        </p:spPr>
-        <p:txBody>
-          <a:bodyPr wrap="square" lIns="0" tIns="0" rIns="0" bIns="0" rtlCol="0" anchor="t"/>
-          <a:lstStyle/>
-          <a:p>
-            <a:pPr indent="0" marL="0">
-              <a:buNone/>
-            </a:pPr>
-            <a:r>
-              <a:rPr lang="en-US" sz="1400" dirty="0">
-                <a:solidFill>
-                  <a:schemeClr val="bg1"/>
-                </a:solidFill>
-              </a:rPr>
-              <a:t>Fine-tune the detector on our labelled set. Add open door, loose strap and missing marking classes.</a:t>
-            </a:r>
-            <a:endParaRPr lang="en-US" sz="1400" dirty="0"/>
-          </a:p>
-        </p:txBody>
-      </p:sp>
-      <p:sp>
-        <p:nvSpPr>
-          <p:cNvPr id="9" name="Shape 7"/>
-          <p:cNvSpPr/>
-          <p:nvPr/>
-        </p:nvSpPr>
-        <p:spPr>
-          <a:xfrm>
-            <a:off x="8138160" y="1554480"/>
-            <a:ext cx="3474720" cy="2926080"/>
-          </a:xfrm>
-          <a:prstGeom prst="rect">
-            <a:avLst/>
-          </a:prstGeom>
-          <a:solidFill>
-            <a:srgbClr val="3A4248"/>
-          </a:solidFill>
-          <a:ln w="12700">
-            <a:solidFill>
-              <a:srgbClr val="3A4248"/>
-            </a:solidFill>
-            <a:prstDash val="solid"/>
-          </a:ln>
-        </p:spPr>
-      </p:sp>
-      <p:sp>
-        <p:nvSpPr>
-          <p:cNvPr id="10" name="Text 8"/>
-          <p:cNvSpPr txBox="1"/>
-          <p:nvPr/>
-        </p:nvSpPr>
-        <p:spPr>
-          <a:xfrm>
-            <a:off x="8412480" y="1737360"/>
-            <a:ext cx="2926080" cy="457200"/>
-          </a:xfrm>
-          <a:prstGeom prst="rect">
-            <a:avLst/>
-          </a:prstGeom>
-          <a:noFill/>
-          <a:ln/>
-        </p:spPr>
-        <p:txBody>
-          <a:bodyPr wrap="square" lIns="0" tIns="0" rIns="0" bIns="0" rtlCol="0" anchor="ctr"/>
-          <a:lstStyle/>
-          <a:p>
-            <a:pPr indent="0" marL="0">
-              <a:buNone/>
-            </a:pPr>
-            <a:r>
-              <a:rPr lang="en-US" sz="2000" b="1" dirty="0">
-                <a:solidFill>
-                  <a:srgbClr val="F2B705"/>
-                </a:solidFill>
-              </a:rPr>
-              <a:t>Month 3</a:t>
-            </a:r>
-            <a:endParaRPr lang="en-US" sz="2000" dirty="0"/>
-          </a:p>
-        </p:txBody>
-      </p:sp>
-      <p:sp>
-        <p:nvSpPr>
-          <p:cNvPr id="11" name="Text 9"/>
-          <p:cNvSpPr txBox="1"/>
-          <p:nvPr/>
-        </p:nvSpPr>
-        <p:spPr>
-          <a:xfrm>
-            <a:off x="8412480" y="2286000"/>
-            <a:ext cx="2926080" cy="2011680"/>
-          </a:xfrm>
-          <a:prstGeom prst="rect">
-            <a:avLst/>
-          </a:prstGeom>
-          <a:noFill/>
-          <a:ln/>
-        </p:spPr>
-        <p:txBody>
-          <a:bodyPr wrap="square" lIns="0" tIns="0" rIns="0" bIns="0" rtlCol="0" anchor="t"/>
-          <a:lstStyle/>
-          <a:p>
-            <a:pPr indent="0" marL="0">
-              <a:buNone/>
-            </a:pPr>
-            <a:r>
-              <a:rPr lang="en-US" sz="1400" dirty="0">
-                <a:solidFill>
-                  <a:schemeClr val="bg1"/>
-                </a:solidFill>
-              </a:rPr>
-              <a:t>Weighbridge and dispatch integration. Pilot at a Royal Motors receiving yard on incoming car carriers.</a:t>
-            </a:r>
-            <a:endParaRPr lang="en-US" sz="1400" dirty="0"/>
-          </a:p>
-        </p:txBody>
-      </p:sp>
-      <p:sp>
-        <p:nvSpPr>
-          <p:cNvPr id="12" name="Text 10"/>
-          <p:cNvSpPr txBox="1"/>
-          <p:nvPr/>
-        </p:nvSpPr>
-        <p:spPr>
-          <a:xfrm>
-            <a:off x="640080" y="4937760"/>
-            <a:ext cx="10972800" cy="457200"/>
-          </a:xfrm>
-          <a:prstGeom prst="rect">
-            <a:avLst/>
-          </a:prstGeom>
-          <a:noFill/>
-          <a:ln/>
-        </p:spPr>
-        <p:txBody>
-          <a:bodyPr wrap="square" lIns="0" tIns="0" rIns="0" bIns="0" rtlCol="0" anchor="ctr"/>
-          <a:lstStyle/>
-          <a:p>
-            <a:pPr indent="0" marL="0">
-              <a:buNone/>
-            </a:pPr>
-            <a:r>
-              <a:rPr lang="en-US" sz="1300" dirty="0">
-                <a:solidFill>
-                  <a:srgbClr val="8A96A0"/>
-                </a:solidFill>
-              </a:rPr>
-              <a:t>Repository: github.com/Winner-121/Destroyerrrrs_Final_Stage   ·   Demo: amir-kuldashev--load-safety-gate-web.modal.run</a:t>
-            </a:r>
-            <a:endParaRPr lang="en-US" sz="1300" dirty="0"/>
-          </a:p>
-        </p:txBody>
-      </p:sp>
-      <p:sp>
-        <p:nvSpPr>
-          <p:cNvPr id="25" name="Slide Number Placeholder 0"/>
-          <p:cNvSpPr>
-            <a:spLocks noGrp="1"/>
-          </p:cNvSpPr>
-          <p:nvPr>
-            <p:ph type="sldNum" sz="quarter" idx="4294967295"/>
-          </p:nvPr>
-        </p:nvSpPr>
-        <p:spPr>
-          <a:xfrm>
-            <a:off x="11247120" y="6446520"/>
-            <a:ext cx="548640" cy="274320"/>
-          </a:xfrm>
-          <a:prstGeom prst="rect">
-            <a:avLst/>
-          </a:prstGeom>
-          <a:extLst>
-            <a:ext uri="{C572A759-6A51-4108-AA02-DFA0A04FC94B}">
-              <ma14:wrappingTextBoxFlag xmlns:ma14="http://schemas.microsoft.com/office/mac/drawingml/2011/main" val="0"/>
-            </a:ext>
-          </a:extLst>
-        </p:spPr>
-        <p:txBody>
-          <a:bodyPr/>
-          <a:lstStyle>
-            <a:lvl1pPr>
-              <a:defRPr sz="1000">
-                <a:solidFill>
-                  <a:srgbClr val="8A96A0"/>
-                </a:solidFill>
-              </a:defRPr>
-            </a:lvl1pPr>
-          </a:lstStyle>
-          <a:p>
-            <a:pPr algn="l"/>
-            <a:fld id="{F7021451-1387-4CA6-816F-3879F97B5CBC}" type="slidenum">
-              <a:rPr b="0" lang="en-US"/>
-              <a:t>10</a:t>
-            </a:fld>
-            <a:endParaRPr lang="en-US"/>
-          </a:p>
-        </p:txBody>
-      </p:sp>
-    </p:spTree>
-  </p:cSld>
-  <p:clrMapOvr>
-    <a:masterClrMapping/>
-  </p:clrMapOvr>
-</p:sld>
-</file>
-
 <file path=ppt/slides/slide2.xml><?xml version="1.0" encoding="utf-8"?>
 <p:sld xmlns:a="http://schemas.openxmlformats.org/drawingml/2006/main" xmlns:r="http://schemas.openxmlformats.org/officeDocument/2006/relationships" xmlns:p="http://schemas.openxmlformats.org/presentationml/2006/main">
   <p:cSld name="Slide 2">
@@ -10226,375 +9700,6 @@
       <p:sp>
         <p:nvSpPr>
           <p:cNvPr id="2" name="Text 0"/>
-          <p:cNvSpPr txBox="1"/>
-          <p:nvPr/>
-        </p:nvSpPr>
-        <p:spPr>
-          <a:xfrm>
-            <a:off x="640080" y="457200"/>
-            <a:ext cx="10972800" cy="731520"/>
-          </a:xfrm>
-          <a:prstGeom prst="rect">
-            <a:avLst/>
-          </a:prstGeom>
-          <a:noFill/>
-          <a:ln/>
-        </p:spPr>
-        <p:txBody>
-          <a:bodyPr wrap="square" lIns="0" tIns="0" rIns="0" bIns="0" rtlCol="0" anchor="ctr"/>
-          <a:lstStyle/>
-          <a:p>
-            <a:pPr indent="0" marL="0">
-              <a:buNone/>
-            </a:pPr>
-            <a:r>
-              <a:rPr lang="en-US" sz="3600" b="1" dirty="0">
-                <a:solidFill>
-                  <a:schemeClr val="bg1"/>
-                </a:solidFill>
-                <a:latin typeface="Cambria" pitchFamily="34" charset="0"/>
-                <a:ea typeface="Cambria" pitchFamily="34" charset="-122"/>
-                <a:cs typeface="Cambria" pitchFamily="34" charset="-120"/>
-              </a:rPr>
-              <a:t>The replication test</a:t>
-            </a:r>
-            <a:endParaRPr lang="en-US" sz="3600" dirty="0"/>
-          </a:p>
-        </p:txBody>
-      </p:sp>
-      <p:sp>
-        <p:nvSpPr>
-          <p:cNvPr id="3" name="Text 1"/>
-          <p:cNvSpPr txBox="1"/>
-          <p:nvPr/>
-        </p:nvSpPr>
-        <p:spPr>
-          <a:xfrm>
-            <a:off x="640080" y="1371600"/>
-            <a:ext cx="5303520" cy="457200"/>
-          </a:xfrm>
-          <a:prstGeom prst="rect">
-            <a:avLst/>
-          </a:prstGeom>
-          <a:noFill/>
-          <a:ln/>
-        </p:spPr>
-        <p:txBody>
-          <a:bodyPr wrap="square" lIns="0" tIns="0" rIns="0" bIns="0" rtlCol="0" anchor="ctr"/>
-          <a:lstStyle/>
-          <a:p>
-            <a:pPr indent="0" marL="0">
-              <a:buNone/>
-            </a:pPr>
-            <a:r>
-              <a:rPr lang="en-US" sz="1800" b="1" dirty="0">
-                <a:solidFill>
-                  <a:srgbClr val="8A96A0"/>
-                </a:solidFill>
-              </a:rPr>
-              <a:t>A weekend with the same tools gets you</a:t>
-            </a:r>
-            <a:endParaRPr lang="en-US" sz="1800" dirty="0"/>
-          </a:p>
-        </p:txBody>
-      </p:sp>
-      <p:sp>
-        <p:nvSpPr>
-          <p:cNvPr id="4" name="Text 2"/>
-          <p:cNvSpPr txBox="1"/>
-          <p:nvPr/>
-        </p:nvSpPr>
-        <p:spPr>
-          <a:xfrm>
-            <a:off x="640080" y="1920240"/>
-            <a:ext cx="5303520" cy="3200400"/>
-          </a:xfrm>
-          <a:prstGeom prst="rect">
-            <a:avLst/>
-          </a:prstGeom>
-          <a:noFill/>
-          <a:ln/>
-        </p:spPr>
-        <p:txBody>
-          <a:bodyPr wrap="square" lIns="0" tIns="0" rIns="0" bIns="0" rtlCol="0" anchor="t"/>
-          <a:lstStyle/>
-          <a:p>
-            <a:pPr marL="342900" indent="-342900">
-              <a:spcAft>
-                <a:spcPts val="600"/>
-              </a:spcAft>
-              <a:buSzPct val="100000"/>
-              <a:buChar char="•"/>
-            </a:pPr>
-            <a:r>
-              <a:rPr lang="en-US" sz="1500" dirty="0">
-                <a:solidFill>
-                  <a:schemeClr val="bg1"/>
-                </a:solidFill>
-              </a:rPr>
-              <a:t>A detector that draws boxes around trucks and cargo</a:t>
-            </a:r>
-            <a:endParaRPr lang="en-US" sz="1500" dirty="0"/>
-          </a:p>
-          <a:p>
-            <a:pPr marL="342900" indent="-342900">
-              <a:spcAft>
-                <a:spcPts val="600"/>
-              </a:spcAft>
-              <a:buSzPct val="100000"/>
-              <a:buChar char="•"/>
-            </a:pPr>
-            <a:r>
-              <a:rPr lang="en-US" sz="1500" dirty="0">
-                <a:solidFill>
-                  <a:schemeClr val="bg1"/>
-                </a:solidFill>
-              </a:rPr>
-              <a:t>A prompt to a vision model that says "looks overloaded"</a:t>
-            </a:r>
-            <a:endParaRPr lang="en-US" sz="1500" dirty="0"/>
-          </a:p>
-          <a:p>
-            <a:pPr marL="342900" indent="-342900">
-              <a:spcAft>
-                <a:spcPts val="600"/>
-              </a:spcAft>
-              <a:buSzPct val="100000"/>
-              <a:buChar char="•"/>
-            </a:pPr>
-            <a:r>
-              <a:rPr lang="en-US" sz="1500" dirty="0">
-                <a:solidFill>
-                  <a:schemeClr val="bg1"/>
-                </a:solidFill>
-              </a:rPr>
-              <a:t>No measurement, no threshold, no number a gate operator can act on</a:t>
-            </a:r>
-            <a:endParaRPr lang="en-US" sz="1500" dirty="0"/>
-          </a:p>
-        </p:txBody>
-      </p:sp>
-      <p:sp>
-        <p:nvSpPr>
-          <p:cNvPr id="5" name="Text 3"/>
-          <p:cNvSpPr txBox="1"/>
-          <p:nvPr/>
-        </p:nvSpPr>
-        <p:spPr>
-          <a:xfrm>
-            <a:off x="6309360" y="1371600"/>
-            <a:ext cx="5303520" cy="457200"/>
-          </a:xfrm>
-          <a:prstGeom prst="rect">
-            <a:avLst/>
-          </a:prstGeom>
-          <a:noFill/>
-          <a:ln/>
-        </p:spPr>
-        <p:txBody>
-          <a:bodyPr wrap="square" lIns="0" tIns="0" rIns="0" bIns="0" rtlCol="0" anchor="ctr"/>
-          <a:lstStyle/>
-          <a:p>
-            <a:pPr indent="0" marL="0">
-              <a:buNone/>
-            </a:pPr>
-            <a:r>
-              <a:rPr lang="en-US" sz="1800" b="1" dirty="0">
-                <a:solidFill>
-                  <a:srgbClr val="F2B705"/>
-                </a:solidFill>
-              </a:rPr>
-              <a:t>What they do not get</a:t>
-            </a:r>
-            <a:endParaRPr lang="en-US" sz="1800" dirty="0"/>
-          </a:p>
-        </p:txBody>
-      </p:sp>
-      <p:sp>
-        <p:nvSpPr>
-          <p:cNvPr id="6" name="Text 4"/>
-          <p:cNvSpPr txBox="1"/>
-          <p:nvPr/>
-        </p:nvSpPr>
-        <p:spPr>
-          <a:xfrm>
-            <a:off x="6309360" y="1920240"/>
-            <a:ext cx="5303520" cy="3657600"/>
-          </a:xfrm>
-          <a:prstGeom prst="rect">
-            <a:avLst/>
-          </a:prstGeom>
-          <a:noFill/>
-          <a:ln/>
-        </p:spPr>
-        <p:txBody>
-          <a:bodyPr wrap="square" lIns="0" tIns="0" rIns="0" bIns="0" rtlCol="0" anchor="t"/>
-          <a:lstStyle/>
-          <a:p>
-            <a:pPr marL="342900" indent="-342900">
-              <a:spcAft>
-                <a:spcPts val="600"/>
-              </a:spcAft>
-              <a:buSzPct val="100000"/>
-              <a:buChar char="•"/>
-            </a:pPr>
-            <a:r>
-              <a:rPr lang="en-US" sz="1500" dirty="0">
-                <a:solidFill>
-                  <a:schemeClr val="bg1"/>
-                </a:solidFill>
-              </a:rPr>
-              <a:t>Perspective-safe roll from vertical edges, with a gravity reference in the same image</a:t>
-            </a:r>
-            <a:endParaRPr lang="en-US" sz="1500" dirty="0"/>
-          </a:p>
-          <a:p>
-            <a:pPr marL="342900" indent="-342900">
-              <a:spcAft>
-                <a:spcPts val="600"/>
-              </a:spcAft>
-              <a:buSzPct val="100000"/>
-              <a:buChar char="•"/>
-            </a:pPr>
-            <a:r>
-              <a:rPr lang="en-US" sz="1500" dirty="0">
-                <a:solidFill>
-                  <a:schemeClr val="bg1"/>
-                </a:solidFill>
-              </a:rPr>
-              <a:t>Centimetres and metres from a known object in the frame, and a CANNOT ASSESS path</a:t>
-            </a:r>
-            <a:endParaRPr lang="en-US" sz="1500" dirty="0"/>
-          </a:p>
-          <a:p>
-            <a:pPr marL="342900" indent="-342900">
-              <a:spcAft>
-                <a:spcPts val="600"/>
-              </a:spcAft>
-              <a:buSzPct val="100000"/>
-              <a:buChar char="•"/>
-            </a:pPr>
-            <a:r>
-              <a:rPr lang="en-US" sz="1500" dirty="0">
-                <a:solidFill>
-                  <a:schemeClr val="bg1"/>
-                </a:solidFill>
-              </a:rPr>
-              <a:t>A decision layer written from Decree 342, the regulation a police post actually applies</a:t>
-            </a:r>
-            <a:endParaRPr lang="en-US" sz="1500" dirty="0"/>
-          </a:p>
-          <a:p>
-            <a:pPr marL="342900" indent="-342900">
-              <a:spcAft>
-                <a:spcPts val="600"/>
-              </a:spcAft>
-              <a:buSzPct val="100000"/>
-              <a:buChar char="•"/>
-            </a:pPr>
-            <a:r>
-              <a:rPr lang="en-US" sz="1500" dirty="0">
-                <a:solidFill>
-                  <a:schemeClr val="bg1"/>
-                </a:solidFill>
-              </a:rPr>
-              <a:t>A privacy stage that makes the product legal to pilot</a:t>
-            </a:r>
-            <a:endParaRPr lang="en-US" sz="1500" dirty="0"/>
-          </a:p>
-          <a:p>
-            <a:pPr marL="342900" indent="-342900">
-              <a:spcAft>
-                <a:spcPts val="600"/>
-              </a:spcAft>
-              <a:buSzPct val="100000"/>
-              <a:buChar char="•"/>
-            </a:pPr>
-            <a:r>
-              <a:rPr lang="en-US" sz="1500" dirty="0">
-                <a:solidFill>
-                  <a:schemeClr val="bg1"/>
-                </a:solidFill>
-              </a:rPr>
-              <a:t>301 licensed images with hit rates, 120 labelled, and a deployed gate product</a:t>
-            </a:r>
-            <a:endParaRPr lang="en-US" sz="1500" dirty="0"/>
-          </a:p>
-        </p:txBody>
-      </p:sp>
-      <p:sp>
-        <p:nvSpPr>
-          <p:cNvPr id="25" name="Slide Number Placeholder 0"/>
-          <p:cNvSpPr>
-            <a:spLocks noGrp="1"/>
-          </p:cNvSpPr>
-          <p:nvPr>
-            <p:ph type="sldNum" sz="quarter" idx="4294967295"/>
-          </p:nvPr>
-        </p:nvSpPr>
-        <p:spPr>
-          <a:xfrm>
-            <a:off x="11247120" y="6446520"/>
-            <a:ext cx="548640" cy="274320"/>
-          </a:xfrm>
-          <a:prstGeom prst="rect">
-            <a:avLst/>
-          </a:prstGeom>
-          <a:extLst>
-            <a:ext uri="{C572A759-6A51-4108-AA02-DFA0A04FC94B}">
-              <ma14:wrappingTextBoxFlag xmlns:ma14="http://schemas.microsoft.com/office/mac/drawingml/2011/main" val="0"/>
-            </a:ext>
-          </a:extLst>
-        </p:spPr>
-        <p:txBody>
-          <a:bodyPr/>
-          <a:lstStyle>
-            <a:lvl1pPr>
-              <a:defRPr sz="1000">
-                <a:solidFill>
-                  <a:srgbClr val="8A96A0"/>
-                </a:solidFill>
-              </a:defRPr>
-            </a:lvl1pPr>
-          </a:lstStyle>
-          <a:p>
-            <a:pPr algn="l"/>
-            <a:fld id="{F7021451-1387-4CA6-816F-3879F97B5CBC}" type="slidenum">
-              <a:rPr b="0" lang="en-US"/>
-              <a:t>8</a:t>
-            </a:fld>
-            <a:endParaRPr lang="en-US"/>
-          </a:p>
-        </p:txBody>
-      </p:sp>
-    </p:spTree>
-  </p:cSld>
-  <p:clrMapOvr>
-    <a:masterClrMapping/>
-  </p:clrMapOvr>
-</p:sld>
-</file>
-
-<file path=ppt/slides/slide9.xml><?xml version="1.0" encoding="utf-8"?>
-<p:sld xmlns:a="http://schemas.openxmlformats.org/drawingml/2006/main" xmlns:r="http://schemas.openxmlformats.org/officeDocument/2006/relationships" xmlns:p="http://schemas.openxmlformats.org/presentationml/2006/main">
-  <p:cSld name="Slide 9">
-    <p:spTree>
-      <p:nvGrpSpPr>
-        <p:cNvPr id="1" name=""/>
-        <p:cNvGrpSpPr/>
-        <p:nvPr/>
-      </p:nvGrpSpPr>
-      <p:grpSpPr>
-        <a:xfrm>
-          <a:off x="0" y="0"/>
-          <a:ext cx="0" cy="0"/>
-          <a:chOff x="0" y="0"/>
-          <a:chExt cx="0" cy="0"/>
-        </a:xfrm>
-      </p:grpSpPr>
-      <p:sp>
-        <p:nvSpPr>
-          <p:cNvPr id="2" name="Text 0"/>
           <p:cNvSpPr/>
           <p:nvPr>
             <p:ph idx="100" type="title" hasCustomPrompt="1"/>
@@ -10632,7 +9737,7 @@
       </p:sp>
       <p:graphicFrame>
         <p:nvGraphicFramePr>
-          <p:cNvPr id="10" name="Table 0"/>
+          <p:cNvPr id="9" name="Table 0"/>
           <p:cNvGraphicFramePr>
             <a:graphicFrameLocks noGrp="1"/>
           </p:cNvGraphicFramePr>
@@ -11728,7 +10833,7 @@
       </p:graphicFrame>
       <p:graphicFrame>
         <p:nvGraphicFramePr>
-          <p:cNvPr id="19" name="Table 1"/>
+          <p:cNvPr id="17" name="Table 1"/>
           <p:cNvGraphicFramePr>
             <a:graphicFrameLocks noGrp="1"/>
           </p:cNvGraphicFramePr>
@@ -12887,6 +11992,442 @@
               <a:t>Pilot cost $8,570 (team $7,200 + cameras $600 + hosting $270 + labelling $500). Avoided loss $5,000 per month at one caught incident a month. Payback = 8,570 / 5,000 = 1.7 months, inside the pilot itself. The fleet's own incident rate replaces the assumption after month one.</a:t>
             </a:r>
             <a:endParaRPr lang="en-US" sz="1200" dirty="0"/>
+          </a:p>
+        </p:txBody>
+      </p:sp>
+      <p:sp>
+        <p:nvSpPr>
+          <p:cNvPr id="25" name="Slide Number Placeholder 0"/>
+          <p:cNvSpPr>
+            <a:spLocks noGrp="1"/>
+          </p:cNvSpPr>
+          <p:nvPr>
+            <p:ph type="sldNum" sz="quarter" idx="4294967295"/>
+          </p:nvPr>
+        </p:nvSpPr>
+        <p:spPr>
+          <a:xfrm>
+            <a:off x="11247120" y="6446520"/>
+            <a:ext cx="548640" cy="274320"/>
+          </a:xfrm>
+          <a:prstGeom prst="rect">
+            <a:avLst/>
+          </a:prstGeom>
+          <a:extLst>
+            <a:ext uri="{C572A759-6A51-4108-AA02-DFA0A04FC94B}">
+              <ma14:wrappingTextBoxFlag xmlns:ma14="http://schemas.microsoft.com/office/mac/drawingml/2011/main" val="0"/>
+            </a:ext>
+          </a:extLst>
+        </p:spPr>
+        <p:txBody>
+          <a:bodyPr/>
+          <a:lstStyle>
+            <a:lvl1pPr>
+              <a:defRPr sz="1000">
+                <a:solidFill>
+                  <a:srgbClr val="8A96A0"/>
+                </a:solidFill>
+              </a:defRPr>
+            </a:lvl1pPr>
+          </a:lstStyle>
+          <a:p>
+            <a:pPr algn="l"/>
+            <a:fld id="{F7021451-1387-4CA6-816F-3879F97B5CBC}" type="slidenum">
+              <a:rPr b="0" lang="en-US"/>
+              <a:t>8</a:t>
+            </a:fld>
+            <a:endParaRPr lang="en-US"/>
+          </a:p>
+        </p:txBody>
+      </p:sp>
+    </p:spTree>
+  </p:cSld>
+  <p:clrMapOvr>
+    <a:masterClrMapping/>
+  </p:clrMapOvr>
+</p:sld>
+</file>
+
+<file path=ppt/slides/slide9.xml><?xml version="1.0" encoding="utf-8"?>
+<p:sld xmlns:a="http://schemas.openxmlformats.org/drawingml/2006/main" xmlns:r="http://schemas.openxmlformats.org/officeDocument/2006/relationships" xmlns:p="http://schemas.openxmlformats.org/presentationml/2006/main">
+  <p:cSld name="Slide 9">
+    <p:spTree>
+      <p:nvGrpSpPr>
+        <p:cNvPr id="1" name=""/>
+        <p:cNvGrpSpPr/>
+        <p:nvPr/>
+      </p:nvGrpSpPr>
+      <p:grpSpPr>
+        <a:xfrm>
+          <a:off x="0" y="0"/>
+          <a:ext cx="0" cy="0"/>
+          <a:chOff x="0" y="0"/>
+          <a:chExt cx="0" cy="0"/>
+        </a:xfrm>
+      </p:grpSpPr>
+      <p:sp>
+        <p:nvSpPr>
+          <p:cNvPr id="2" name="Text 0"/>
+          <p:cNvSpPr txBox="1"/>
+          <p:nvPr/>
+        </p:nvSpPr>
+        <p:spPr>
+          <a:xfrm>
+            <a:off x="640080" y="457200"/>
+            <a:ext cx="10972800" cy="731520"/>
+          </a:xfrm>
+          <a:prstGeom prst="rect">
+            <a:avLst/>
+          </a:prstGeom>
+          <a:noFill/>
+          <a:ln/>
+        </p:spPr>
+        <p:txBody>
+          <a:bodyPr wrap="square" lIns="0" tIns="0" rIns="0" bIns="0" rtlCol="0" anchor="ctr"/>
+          <a:lstStyle/>
+          <a:p>
+            <a:pPr indent="0" marL="0">
+              <a:buNone/>
+            </a:pPr>
+            <a:r>
+              <a:rPr lang="en-US" sz="3600" b="1" dirty="0">
+                <a:solidFill>
+                  <a:schemeClr val="bg1"/>
+                </a:solidFill>
+                <a:latin typeface="Cambria" pitchFamily="34" charset="0"/>
+                <a:ea typeface="Cambria" pitchFamily="34" charset="-122"/>
+                <a:cs typeface="Cambria" pitchFamily="34" charset="-120"/>
+              </a:rPr>
+              <a:t>Next steps</a:t>
+            </a:r>
+            <a:endParaRPr lang="en-US" sz="3600" dirty="0"/>
+          </a:p>
+        </p:txBody>
+      </p:sp>
+      <p:sp>
+        <p:nvSpPr>
+          <p:cNvPr id="3" name="Shape 1"/>
+          <p:cNvSpPr/>
+          <p:nvPr/>
+        </p:nvSpPr>
+        <p:spPr>
+          <a:xfrm>
+            <a:off x="640080" y="1554480"/>
+            <a:ext cx="3474720" cy="2926080"/>
+          </a:xfrm>
+          <a:prstGeom prst="rect">
+            <a:avLst/>
+          </a:prstGeom>
+          <a:solidFill>
+            <a:srgbClr val="3A4248"/>
+          </a:solidFill>
+          <a:ln w="12700">
+            <a:solidFill>
+              <a:srgbClr val="3A4248"/>
+            </a:solidFill>
+            <a:prstDash val="solid"/>
+          </a:ln>
+        </p:spPr>
+      </p:sp>
+      <p:sp>
+        <p:nvSpPr>
+          <p:cNvPr id="4" name="Text 2"/>
+          <p:cNvSpPr txBox="1"/>
+          <p:nvPr/>
+        </p:nvSpPr>
+        <p:spPr>
+          <a:xfrm>
+            <a:off x="914400" y="1737360"/>
+            <a:ext cx="2926080" cy="457200"/>
+          </a:xfrm>
+          <a:prstGeom prst="rect">
+            <a:avLst/>
+          </a:prstGeom>
+          <a:noFill/>
+          <a:ln/>
+        </p:spPr>
+        <p:txBody>
+          <a:bodyPr wrap="square" lIns="0" tIns="0" rIns="0" bIns="0" rtlCol="0" anchor="ctr"/>
+          <a:lstStyle/>
+          <a:p>
+            <a:pPr indent="0" marL="0">
+              <a:buNone/>
+            </a:pPr>
+            <a:r>
+              <a:rPr lang="en-US" sz="2000" b="1" dirty="0">
+                <a:solidFill>
+                  <a:srgbClr val="F2B705"/>
+                </a:solidFill>
+              </a:rPr>
+              <a:t>Month 1</a:t>
+            </a:r>
+            <a:endParaRPr lang="en-US" sz="2000" dirty="0"/>
+          </a:p>
+        </p:txBody>
+      </p:sp>
+      <p:sp>
+        <p:nvSpPr>
+          <p:cNvPr id="5" name="Text 3"/>
+          <p:cNvSpPr txBox="1"/>
+          <p:nvPr/>
+        </p:nvSpPr>
+        <p:spPr>
+          <a:xfrm>
+            <a:off x="914400" y="2286000"/>
+            <a:ext cx="2926080" cy="2011680"/>
+          </a:xfrm>
+          <a:prstGeom prst="rect">
+            <a:avLst/>
+          </a:prstGeom>
+          <a:noFill/>
+          <a:ln/>
+        </p:spPr>
+        <p:txBody>
+          <a:bodyPr wrap="square" lIns="0" tIns="0" rIns="0" bIns="0" rtlCol="0" anchor="t"/>
+          <a:lstStyle/>
+          <a:p>
+            <a:pPr indent="0" marL="0">
+              <a:buNone/>
+            </a:pPr>
+            <a:r>
+              <a:rPr lang="en-US" sz="1400" dirty="0">
+                <a:solidFill>
+                  <a:schemeClr val="bg1"/>
+                </a:solidFill>
+              </a:rPr>
+              <a:t>Fixed, calibrated camera at one gate. Reference marker removes scale ambiguity. Ten-second video mode.</a:t>
+            </a:r>
+            <a:endParaRPr lang="en-US" sz="1400" dirty="0"/>
+          </a:p>
+        </p:txBody>
+      </p:sp>
+      <p:sp>
+        <p:nvSpPr>
+          <p:cNvPr id="6" name="Shape 4"/>
+          <p:cNvSpPr/>
+          <p:nvPr/>
+        </p:nvSpPr>
+        <p:spPr>
+          <a:xfrm>
+            <a:off x="4389120" y="1554480"/>
+            <a:ext cx="3474720" cy="2926080"/>
+          </a:xfrm>
+          <a:prstGeom prst="rect">
+            <a:avLst/>
+          </a:prstGeom>
+          <a:solidFill>
+            <a:srgbClr val="3A4248"/>
+          </a:solidFill>
+          <a:ln w="12700">
+            <a:solidFill>
+              <a:srgbClr val="3A4248"/>
+            </a:solidFill>
+            <a:prstDash val="solid"/>
+          </a:ln>
+        </p:spPr>
+      </p:sp>
+      <p:sp>
+        <p:nvSpPr>
+          <p:cNvPr id="7" name="Text 5"/>
+          <p:cNvSpPr txBox="1"/>
+          <p:nvPr/>
+        </p:nvSpPr>
+        <p:spPr>
+          <a:xfrm>
+            <a:off x="4663440" y="1737360"/>
+            <a:ext cx="2926080" cy="457200"/>
+          </a:xfrm>
+          <a:prstGeom prst="rect">
+            <a:avLst/>
+          </a:prstGeom>
+          <a:noFill/>
+          <a:ln/>
+        </p:spPr>
+        <p:txBody>
+          <a:bodyPr wrap="square" lIns="0" tIns="0" rIns="0" bIns="0" rtlCol="0" anchor="ctr"/>
+          <a:lstStyle/>
+          <a:p>
+            <a:pPr indent="0" marL="0">
+              <a:buNone/>
+            </a:pPr>
+            <a:r>
+              <a:rPr lang="en-US" sz="2000" b="1" dirty="0">
+                <a:solidFill>
+                  <a:srgbClr val="F2B705"/>
+                </a:solidFill>
+              </a:rPr>
+              <a:t>Month 2</a:t>
+            </a:r>
+            <a:endParaRPr lang="en-US" sz="2000" dirty="0"/>
+          </a:p>
+        </p:txBody>
+      </p:sp>
+      <p:sp>
+        <p:nvSpPr>
+          <p:cNvPr id="8" name="Text 6"/>
+          <p:cNvSpPr txBox="1"/>
+          <p:nvPr/>
+        </p:nvSpPr>
+        <p:spPr>
+          <a:xfrm>
+            <a:off x="4663440" y="2286000"/>
+            <a:ext cx="2926080" cy="2011680"/>
+          </a:xfrm>
+          <a:prstGeom prst="rect">
+            <a:avLst/>
+          </a:prstGeom>
+          <a:noFill/>
+          <a:ln/>
+        </p:spPr>
+        <p:txBody>
+          <a:bodyPr wrap="square" lIns="0" tIns="0" rIns="0" bIns="0" rtlCol="0" anchor="t"/>
+          <a:lstStyle/>
+          <a:p>
+            <a:pPr indent="0" marL="0">
+              <a:buNone/>
+            </a:pPr>
+            <a:r>
+              <a:rPr lang="en-US" sz="1400" dirty="0">
+                <a:solidFill>
+                  <a:schemeClr val="bg1"/>
+                </a:solidFill>
+              </a:rPr>
+              <a:t>Fine-tune the detector on our labelled set. Add open door, loose strap and missing marking classes.</a:t>
+            </a:r>
+            <a:endParaRPr lang="en-US" sz="1400" dirty="0"/>
+          </a:p>
+        </p:txBody>
+      </p:sp>
+      <p:sp>
+        <p:nvSpPr>
+          <p:cNvPr id="9" name="Shape 7"/>
+          <p:cNvSpPr/>
+          <p:nvPr/>
+        </p:nvSpPr>
+        <p:spPr>
+          <a:xfrm>
+            <a:off x="8138160" y="1554480"/>
+            <a:ext cx="3474720" cy="2926080"/>
+          </a:xfrm>
+          <a:prstGeom prst="rect">
+            <a:avLst/>
+          </a:prstGeom>
+          <a:solidFill>
+            <a:srgbClr val="3A4248"/>
+          </a:solidFill>
+          <a:ln w="12700">
+            <a:solidFill>
+              <a:srgbClr val="3A4248"/>
+            </a:solidFill>
+            <a:prstDash val="solid"/>
+          </a:ln>
+        </p:spPr>
+      </p:sp>
+      <p:sp>
+        <p:nvSpPr>
+          <p:cNvPr id="10" name="Text 8"/>
+          <p:cNvSpPr txBox="1"/>
+          <p:nvPr/>
+        </p:nvSpPr>
+        <p:spPr>
+          <a:xfrm>
+            <a:off x="8412480" y="1737360"/>
+            <a:ext cx="2926080" cy="457200"/>
+          </a:xfrm>
+          <a:prstGeom prst="rect">
+            <a:avLst/>
+          </a:prstGeom>
+          <a:noFill/>
+          <a:ln/>
+        </p:spPr>
+        <p:txBody>
+          <a:bodyPr wrap="square" lIns="0" tIns="0" rIns="0" bIns="0" rtlCol="0" anchor="ctr"/>
+          <a:lstStyle/>
+          <a:p>
+            <a:pPr indent="0" marL="0">
+              <a:buNone/>
+            </a:pPr>
+            <a:r>
+              <a:rPr lang="en-US" sz="2000" b="1" dirty="0">
+                <a:solidFill>
+                  <a:srgbClr val="F2B705"/>
+                </a:solidFill>
+              </a:rPr>
+              <a:t>Month 3</a:t>
+            </a:r>
+            <a:endParaRPr lang="en-US" sz="2000" dirty="0"/>
+          </a:p>
+        </p:txBody>
+      </p:sp>
+      <p:sp>
+        <p:nvSpPr>
+          <p:cNvPr id="11" name="Text 9"/>
+          <p:cNvSpPr txBox="1"/>
+          <p:nvPr/>
+        </p:nvSpPr>
+        <p:spPr>
+          <a:xfrm>
+            <a:off x="8412480" y="2286000"/>
+            <a:ext cx="2926080" cy="2011680"/>
+          </a:xfrm>
+          <a:prstGeom prst="rect">
+            <a:avLst/>
+          </a:prstGeom>
+          <a:noFill/>
+          <a:ln/>
+        </p:spPr>
+        <p:txBody>
+          <a:bodyPr wrap="square" lIns="0" tIns="0" rIns="0" bIns="0" rtlCol="0" anchor="t"/>
+          <a:lstStyle/>
+          <a:p>
+            <a:pPr indent="0" marL="0">
+              <a:buNone/>
+            </a:pPr>
+            <a:r>
+              <a:rPr lang="en-US" sz="1400" dirty="0">
+                <a:solidFill>
+                  <a:schemeClr val="bg1"/>
+                </a:solidFill>
+              </a:rPr>
+              <a:t>Weighbridge and dispatch integration. Pilot at a Royal Motors receiving yard on incoming car carriers.</a:t>
+            </a:r>
+            <a:endParaRPr lang="en-US" sz="1400" dirty="0"/>
+          </a:p>
+        </p:txBody>
+      </p:sp>
+      <p:sp>
+        <p:nvSpPr>
+          <p:cNvPr id="12" name="Text 10"/>
+          <p:cNvSpPr txBox="1"/>
+          <p:nvPr/>
+        </p:nvSpPr>
+        <p:spPr>
+          <a:xfrm>
+            <a:off x="640080" y="4937760"/>
+            <a:ext cx="10972800" cy="457200"/>
+          </a:xfrm>
+          <a:prstGeom prst="rect">
+            <a:avLst/>
+          </a:prstGeom>
+          <a:noFill/>
+          <a:ln/>
+        </p:spPr>
+        <p:txBody>
+          <a:bodyPr wrap="square" lIns="0" tIns="0" rIns="0" bIns="0" rtlCol="0" anchor="ctr"/>
+          <a:lstStyle/>
+          <a:p>
+            <a:pPr indent="0" marL="0">
+              <a:buNone/>
+            </a:pPr>
+            <a:r>
+              <a:rPr lang="en-US" sz="1300" dirty="0">
+                <a:solidFill>
+                  <a:srgbClr val="8A96A0"/>
+                </a:solidFill>
+              </a:rPr>
+              <a:t>Repository: github.com/Winner-121/Destroyerrrrs_Final_Stage   ·   Demo: amir-kuldashev--load-safety-gate-web.modal.run</a:t>
+            </a:r>
+            <a:endParaRPr lang="en-US" sz="1300" dirty="0"/>
           </a:p>
         </p:txBody>
       </p:sp>

</xml_diff>

<commit_message>
Revert "Deck: remove the replication slide"
This reverts commit 3d443a6a540f60130cfaa06634339749515c3f76.
</commit_message>
<xml_diff>
--- a/deck/LoadSafetyGate_deck.pptx
+++ b/deck/LoadSafetyGate_deck.pptx
@@ -14,9 +14,10 @@
     <p:sldId id="262" r:id="rId8"/>
     <p:sldId id="263" r:id="rId9"/>
     <p:sldId id="264" r:id="rId10"/>
+    <p:sldId id="265" r:id="rId11"/>
   </p:sldIdLst>
   <p:notesMasterIdLst>
-    <p:notesMasterId r:id="rId11"/>
+    <p:notesMasterId r:id="rId12"/>
   </p:notesMasterIdLst>
   <p:sldSz cx="12192000" cy="6858000"/>
   <p:notesSz cx="6858000" cy="12192000"/>
@@ -115,33 +116,34 @@
   <p:extLst>
     <p:ext uri="{521415D9-36F7-43E2-AB2F-B90AF26B5E84}">
       <p14:sectionLst xmlns:p14="http://schemas.microsoft.com/office/powerpoint/2010/main">
-        <p14:section name="Opening" id="{c51a4084-375b-86fb-2370-9d7d14e21103}">
+        <p14:section name="Opening" id="{2411df9f-7252-c906-8d67-36b160a4d231}">
           <p14:sldIdLst>
             <p14:sldId id="256"/>
           </p14:sldIdLst>
         </p14:section>
-        <p14:section name="Problem" id="{c73b3cd7-44e0-2d70-5542-5ddd05547d1f}">
+        <p14:section name="Problem" id="{105a1b19-ef4c-9eb8-af59-4740a307ca2d}">
           <p14:sldIdLst>
             <p14:sldId id="257"/>
           </p14:sldIdLst>
         </p14:section>
-        <p14:section name="Demo" id="{10f041df-a752-15fb-d6c0-06b916aa03b8}">
+        <p14:section name="Demo" id="{7ce76d47-aac0-1ab8-6d66-f2a59a1fc0a1}">
           <p14:sldIdLst>
             <p14:sldId id="258"/>
           </p14:sldIdLst>
         </p14:section>
-        <p14:section name="Technology" id="{f4f2c24e-2cb9-a3af-2ac8-67ef902d0542}">
+        <p14:section name="Technology" id="{c33bcd73-e40e-1f0c-5382-7c88e8c3eee5}">
           <p14:sldIdLst>
             <p14:sldId id="259"/>
             <p14:sldId id="260"/>
             <p14:sldId id="261"/>
             <p14:sldId id="262"/>
+            <p14:sldId id="263"/>
           </p14:sldIdLst>
         </p14:section>
-        <p14:section name="Business" id="{4dc4d476-e95a-4280-9065-327ee33a84a7}">
+        <p14:section name="Business" id="{806732d8-76ac-2665-c060-ca9f2584f200}">
           <p14:sldIdLst>
-            <p14:sldId id="263"/>
             <p14:sldId id="264"/>
+            <p14:sldId id="265"/>
           </p14:sldIdLst>
         </p14:section>
       </p14:sectionLst>
@@ -572,6 +574,94 @@
             <a:fld id="{F7021451-1387-4CA6-816F-3879F97B5CBC}" type="slidenum">
               <a:rPr lang="en-US"/>
               <a:t>1</a:t>
+            </a:fld>
+            <a:endParaRPr lang="en-US"/>
+          </a:p>
+        </p:txBody>
+      </p:sp>
+    </p:spTree>
+    <p:extLst>
+      <p:ext uri="{BB962C8B-B14F-4D97-AF65-F5344CB8AC3E}">
+        <p14:creationId xmlns:p14="http://schemas.microsoft.com/office/powerpoint/2010/main" val="1024086991"/>
+      </p:ext>
+    </p:extLst>
+  </p:cSld>
+  <p:clrMapOvr>
+    <a:masterClrMapping/>
+  </p:clrMapOvr>
+</p:notes>
+</file>
+
+<file path=ppt/notesSlides/notesSlide10.xml><?xml version="1.0" encoding="utf-8"?>
+<p:notes xmlns:a="http://schemas.openxmlformats.org/drawingml/2006/main" xmlns:r="http://schemas.openxmlformats.org/officeDocument/2006/relationships" xmlns:p="http://schemas.openxmlformats.org/presentationml/2006/main">
+  <p:cSld>
+    <p:spTree>
+      <p:nvGrpSpPr>
+        <p:cNvPr id="1" name=""/>
+        <p:cNvGrpSpPr/>
+        <p:nvPr/>
+      </p:nvGrpSpPr>
+      <p:grpSpPr>
+        <a:xfrm>
+          <a:off x="0" y="0"/>
+          <a:ext cx="0" cy="0"/>
+          <a:chOff x="0" y="0"/>
+          <a:chExt cx="0" cy="0"/>
+        </a:xfrm>
+      </p:grpSpPr>
+      <p:sp>
+        <p:nvSpPr>
+          <p:cNvPr id="2" name="Slide Image Placeholder 1"/>
+          <p:cNvSpPr>
+            <a:spLocks noGrp="1" noRot="1" noChangeAspect="1"/>
+          </p:cNvSpPr>
+          <p:nvPr>
+            <p:ph type="sldImg"/>
+          </p:nvPr>
+        </p:nvSpPr>
+        <p:spPr/>
+      </p:sp>
+      <p:sp>
+        <p:nvSpPr>
+          <p:cNvPr id="3" name="Notes Placeholder 2"/>
+          <p:cNvSpPr>
+            <a:spLocks noGrp="1"/>
+          </p:cNvSpPr>
+          <p:nvPr>
+            <p:ph type="body" idx="1"/>
+          </p:nvPr>
+        </p:nvSpPr>
+        <p:spPr/>
+        <p:txBody>
+          <a:bodyPr/>
+          <a:lstStyle/>
+          <a:p>
+            <a:r>
+              <a:rPr lang="en-US" dirty="0"/>
+              <a:t/>
+            </a:r>
+            <a:endParaRPr lang="en-US" dirty="0"/>
+          </a:p>
+        </p:txBody>
+      </p:sp>
+      <p:sp>
+        <p:nvSpPr>
+          <p:cNvPr id="4" name="Slide Number Placeholder 3"/>
+          <p:cNvSpPr>
+            <a:spLocks noGrp="1"/>
+          </p:cNvSpPr>
+          <p:nvPr>
+            <p:ph type="sldNum" sz="quarter" idx="10"/>
+          </p:nvPr>
+        </p:nvSpPr>
+        <p:spPr/>
+        <p:txBody>
+          <a:bodyPr/>
+          <a:lstStyle/>
+          <a:p>
+            <a:fld id="{F7021451-1387-4CA6-816F-3879F97B5CBC}" type="slidenum">
+              <a:rPr lang="en-US"/>
+              <a:t>10</a:t>
             </a:fld>
             <a:endParaRPr lang="en-US"/>
           </a:p>
@@ -2319,6 +2409,442 @@
 </p:sld>
 </file>
 
+<file path=ppt/slides/slide10.xml><?xml version="1.0" encoding="utf-8"?>
+<p:sld xmlns:a="http://schemas.openxmlformats.org/drawingml/2006/main" xmlns:r="http://schemas.openxmlformats.org/officeDocument/2006/relationships" xmlns:p="http://schemas.openxmlformats.org/presentationml/2006/main">
+  <p:cSld name="Slide 10">
+    <p:spTree>
+      <p:nvGrpSpPr>
+        <p:cNvPr id="1" name=""/>
+        <p:cNvGrpSpPr/>
+        <p:nvPr/>
+      </p:nvGrpSpPr>
+      <p:grpSpPr>
+        <a:xfrm>
+          <a:off x="0" y="0"/>
+          <a:ext cx="0" cy="0"/>
+          <a:chOff x="0" y="0"/>
+          <a:chExt cx="0" cy="0"/>
+        </a:xfrm>
+      </p:grpSpPr>
+      <p:sp>
+        <p:nvSpPr>
+          <p:cNvPr id="2" name="Text 0"/>
+          <p:cNvSpPr txBox="1"/>
+          <p:nvPr/>
+        </p:nvSpPr>
+        <p:spPr>
+          <a:xfrm>
+            <a:off x="640080" y="457200"/>
+            <a:ext cx="10972800" cy="731520"/>
+          </a:xfrm>
+          <a:prstGeom prst="rect">
+            <a:avLst/>
+          </a:prstGeom>
+          <a:noFill/>
+          <a:ln/>
+        </p:spPr>
+        <p:txBody>
+          <a:bodyPr wrap="square" lIns="0" tIns="0" rIns="0" bIns="0" rtlCol="0" anchor="ctr"/>
+          <a:lstStyle/>
+          <a:p>
+            <a:pPr indent="0" marL="0">
+              <a:buNone/>
+            </a:pPr>
+            <a:r>
+              <a:rPr lang="en-US" sz="3600" b="1" dirty="0">
+                <a:solidFill>
+                  <a:schemeClr val="bg1"/>
+                </a:solidFill>
+                <a:latin typeface="Cambria" pitchFamily="34" charset="0"/>
+                <a:ea typeface="Cambria" pitchFamily="34" charset="-122"/>
+                <a:cs typeface="Cambria" pitchFamily="34" charset="-120"/>
+              </a:rPr>
+              <a:t>Next steps</a:t>
+            </a:r>
+            <a:endParaRPr lang="en-US" sz="3600" dirty="0"/>
+          </a:p>
+        </p:txBody>
+      </p:sp>
+      <p:sp>
+        <p:nvSpPr>
+          <p:cNvPr id="3" name="Shape 1"/>
+          <p:cNvSpPr/>
+          <p:nvPr/>
+        </p:nvSpPr>
+        <p:spPr>
+          <a:xfrm>
+            <a:off x="640080" y="1554480"/>
+            <a:ext cx="3474720" cy="2926080"/>
+          </a:xfrm>
+          <a:prstGeom prst="rect">
+            <a:avLst/>
+          </a:prstGeom>
+          <a:solidFill>
+            <a:srgbClr val="3A4248"/>
+          </a:solidFill>
+          <a:ln w="12700">
+            <a:solidFill>
+              <a:srgbClr val="3A4248"/>
+            </a:solidFill>
+            <a:prstDash val="solid"/>
+          </a:ln>
+        </p:spPr>
+      </p:sp>
+      <p:sp>
+        <p:nvSpPr>
+          <p:cNvPr id="4" name="Text 2"/>
+          <p:cNvSpPr txBox="1"/>
+          <p:nvPr/>
+        </p:nvSpPr>
+        <p:spPr>
+          <a:xfrm>
+            <a:off x="914400" y="1737360"/>
+            <a:ext cx="2926080" cy="457200"/>
+          </a:xfrm>
+          <a:prstGeom prst="rect">
+            <a:avLst/>
+          </a:prstGeom>
+          <a:noFill/>
+          <a:ln/>
+        </p:spPr>
+        <p:txBody>
+          <a:bodyPr wrap="square" lIns="0" tIns="0" rIns="0" bIns="0" rtlCol="0" anchor="ctr"/>
+          <a:lstStyle/>
+          <a:p>
+            <a:pPr indent="0" marL="0">
+              <a:buNone/>
+            </a:pPr>
+            <a:r>
+              <a:rPr lang="en-US" sz="2000" b="1" dirty="0">
+                <a:solidFill>
+                  <a:srgbClr val="F2B705"/>
+                </a:solidFill>
+              </a:rPr>
+              <a:t>Month 1</a:t>
+            </a:r>
+            <a:endParaRPr lang="en-US" sz="2000" dirty="0"/>
+          </a:p>
+        </p:txBody>
+      </p:sp>
+      <p:sp>
+        <p:nvSpPr>
+          <p:cNvPr id="5" name="Text 3"/>
+          <p:cNvSpPr txBox="1"/>
+          <p:nvPr/>
+        </p:nvSpPr>
+        <p:spPr>
+          <a:xfrm>
+            <a:off x="914400" y="2286000"/>
+            <a:ext cx="2926080" cy="2011680"/>
+          </a:xfrm>
+          <a:prstGeom prst="rect">
+            <a:avLst/>
+          </a:prstGeom>
+          <a:noFill/>
+          <a:ln/>
+        </p:spPr>
+        <p:txBody>
+          <a:bodyPr wrap="square" lIns="0" tIns="0" rIns="0" bIns="0" rtlCol="0" anchor="t"/>
+          <a:lstStyle/>
+          <a:p>
+            <a:pPr indent="0" marL="0">
+              <a:buNone/>
+            </a:pPr>
+            <a:r>
+              <a:rPr lang="en-US" sz="1400" dirty="0">
+                <a:solidFill>
+                  <a:schemeClr val="bg1"/>
+                </a:solidFill>
+              </a:rPr>
+              <a:t>Fixed, calibrated camera at one gate. Reference marker removes scale ambiguity. Ten-second video mode.</a:t>
+            </a:r>
+            <a:endParaRPr lang="en-US" sz="1400" dirty="0"/>
+          </a:p>
+        </p:txBody>
+      </p:sp>
+      <p:sp>
+        <p:nvSpPr>
+          <p:cNvPr id="6" name="Shape 4"/>
+          <p:cNvSpPr/>
+          <p:nvPr/>
+        </p:nvSpPr>
+        <p:spPr>
+          <a:xfrm>
+            <a:off x="4389120" y="1554480"/>
+            <a:ext cx="3474720" cy="2926080"/>
+          </a:xfrm>
+          <a:prstGeom prst="rect">
+            <a:avLst/>
+          </a:prstGeom>
+          <a:solidFill>
+            <a:srgbClr val="3A4248"/>
+          </a:solidFill>
+          <a:ln w="12700">
+            <a:solidFill>
+              <a:srgbClr val="3A4248"/>
+            </a:solidFill>
+            <a:prstDash val="solid"/>
+          </a:ln>
+        </p:spPr>
+      </p:sp>
+      <p:sp>
+        <p:nvSpPr>
+          <p:cNvPr id="7" name="Text 5"/>
+          <p:cNvSpPr txBox="1"/>
+          <p:nvPr/>
+        </p:nvSpPr>
+        <p:spPr>
+          <a:xfrm>
+            <a:off x="4663440" y="1737360"/>
+            <a:ext cx="2926080" cy="457200"/>
+          </a:xfrm>
+          <a:prstGeom prst="rect">
+            <a:avLst/>
+          </a:prstGeom>
+          <a:noFill/>
+          <a:ln/>
+        </p:spPr>
+        <p:txBody>
+          <a:bodyPr wrap="square" lIns="0" tIns="0" rIns="0" bIns="0" rtlCol="0" anchor="ctr"/>
+          <a:lstStyle/>
+          <a:p>
+            <a:pPr indent="0" marL="0">
+              <a:buNone/>
+            </a:pPr>
+            <a:r>
+              <a:rPr lang="en-US" sz="2000" b="1" dirty="0">
+                <a:solidFill>
+                  <a:srgbClr val="F2B705"/>
+                </a:solidFill>
+              </a:rPr>
+              <a:t>Month 2</a:t>
+            </a:r>
+            <a:endParaRPr lang="en-US" sz="2000" dirty="0"/>
+          </a:p>
+        </p:txBody>
+      </p:sp>
+      <p:sp>
+        <p:nvSpPr>
+          <p:cNvPr id="8" name="Text 6"/>
+          <p:cNvSpPr txBox="1"/>
+          <p:nvPr/>
+        </p:nvSpPr>
+        <p:spPr>
+          <a:xfrm>
+            <a:off x="4663440" y="2286000"/>
+            <a:ext cx="2926080" cy="2011680"/>
+          </a:xfrm>
+          <a:prstGeom prst="rect">
+            <a:avLst/>
+          </a:prstGeom>
+          <a:noFill/>
+          <a:ln/>
+        </p:spPr>
+        <p:txBody>
+          <a:bodyPr wrap="square" lIns="0" tIns="0" rIns="0" bIns="0" rtlCol="0" anchor="t"/>
+          <a:lstStyle/>
+          <a:p>
+            <a:pPr indent="0" marL="0">
+              <a:buNone/>
+            </a:pPr>
+            <a:r>
+              <a:rPr lang="en-US" sz="1400" dirty="0">
+                <a:solidFill>
+                  <a:schemeClr val="bg1"/>
+                </a:solidFill>
+              </a:rPr>
+              <a:t>Fine-tune the detector on our labelled set. Add open door, loose strap and missing marking classes.</a:t>
+            </a:r>
+            <a:endParaRPr lang="en-US" sz="1400" dirty="0"/>
+          </a:p>
+        </p:txBody>
+      </p:sp>
+      <p:sp>
+        <p:nvSpPr>
+          <p:cNvPr id="9" name="Shape 7"/>
+          <p:cNvSpPr/>
+          <p:nvPr/>
+        </p:nvSpPr>
+        <p:spPr>
+          <a:xfrm>
+            <a:off x="8138160" y="1554480"/>
+            <a:ext cx="3474720" cy="2926080"/>
+          </a:xfrm>
+          <a:prstGeom prst="rect">
+            <a:avLst/>
+          </a:prstGeom>
+          <a:solidFill>
+            <a:srgbClr val="3A4248"/>
+          </a:solidFill>
+          <a:ln w="12700">
+            <a:solidFill>
+              <a:srgbClr val="3A4248"/>
+            </a:solidFill>
+            <a:prstDash val="solid"/>
+          </a:ln>
+        </p:spPr>
+      </p:sp>
+      <p:sp>
+        <p:nvSpPr>
+          <p:cNvPr id="10" name="Text 8"/>
+          <p:cNvSpPr txBox="1"/>
+          <p:nvPr/>
+        </p:nvSpPr>
+        <p:spPr>
+          <a:xfrm>
+            <a:off x="8412480" y="1737360"/>
+            <a:ext cx="2926080" cy="457200"/>
+          </a:xfrm>
+          <a:prstGeom prst="rect">
+            <a:avLst/>
+          </a:prstGeom>
+          <a:noFill/>
+          <a:ln/>
+        </p:spPr>
+        <p:txBody>
+          <a:bodyPr wrap="square" lIns="0" tIns="0" rIns="0" bIns="0" rtlCol="0" anchor="ctr"/>
+          <a:lstStyle/>
+          <a:p>
+            <a:pPr indent="0" marL="0">
+              <a:buNone/>
+            </a:pPr>
+            <a:r>
+              <a:rPr lang="en-US" sz="2000" b="1" dirty="0">
+                <a:solidFill>
+                  <a:srgbClr val="F2B705"/>
+                </a:solidFill>
+              </a:rPr>
+              <a:t>Month 3</a:t>
+            </a:r>
+            <a:endParaRPr lang="en-US" sz="2000" dirty="0"/>
+          </a:p>
+        </p:txBody>
+      </p:sp>
+      <p:sp>
+        <p:nvSpPr>
+          <p:cNvPr id="11" name="Text 9"/>
+          <p:cNvSpPr txBox="1"/>
+          <p:nvPr/>
+        </p:nvSpPr>
+        <p:spPr>
+          <a:xfrm>
+            <a:off x="8412480" y="2286000"/>
+            <a:ext cx="2926080" cy="2011680"/>
+          </a:xfrm>
+          <a:prstGeom prst="rect">
+            <a:avLst/>
+          </a:prstGeom>
+          <a:noFill/>
+          <a:ln/>
+        </p:spPr>
+        <p:txBody>
+          <a:bodyPr wrap="square" lIns="0" tIns="0" rIns="0" bIns="0" rtlCol="0" anchor="t"/>
+          <a:lstStyle/>
+          <a:p>
+            <a:pPr indent="0" marL="0">
+              <a:buNone/>
+            </a:pPr>
+            <a:r>
+              <a:rPr lang="en-US" sz="1400" dirty="0">
+                <a:solidFill>
+                  <a:schemeClr val="bg1"/>
+                </a:solidFill>
+              </a:rPr>
+              <a:t>Weighbridge and dispatch integration. Pilot at a Royal Motors receiving yard on incoming car carriers.</a:t>
+            </a:r>
+            <a:endParaRPr lang="en-US" sz="1400" dirty="0"/>
+          </a:p>
+        </p:txBody>
+      </p:sp>
+      <p:sp>
+        <p:nvSpPr>
+          <p:cNvPr id="12" name="Text 10"/>
+          <p:cNvSpPr txBox="1"/>
+          <p:nvPr/>
+        </p:nvSpPr>
+        <p:spPr>
+          <a:xfrm>
+            <a:off x="640080" y="4937760"/>
+            <a:ext cx="10972800" cy="457200"/>
+          </a:xfrm>
+          <a:prstGeom prst="rect">
+            <a:avLst/>
+          </a:prstGeom>
+          <a:noFill/>
+          <a:ln/>
+        </p:spPr>
+        <p:txBody>
+          <a:bodyPr wrap="square" lIns="0" tIns="0" rIns="0" bIns="0" rtlCol="0" anchor="ctr"/>
+          <a:lstStyle/>
+          <a:p>
+            <a:pPr indent="0" marL="0">
+              <a:buNone/>
+            </a:pPr>
+            <a:r>
+              <a:rPr lang="en-US" sz="1300" dirty="0">
+                <a:solidFill>
+                  <a:srgbClr val="8A96A0"/>
+                </a:solidFill>
+              </a:rPr>
+              <a:t>Repository: github.com/Winner-121/Destroyerrrrs_Final_Stage   ·   Demo: amir-kuldashev--load-safety-gate-web.modal.run</a:t>
+            </a:r>
+            <a:endParaRPr lang="en-US" sz="1300" dirty="0"/>
+          </a:p>
+        </p:txBody>
+      </p:sp>
+      <p:sp>
+        <p:nvSpPr>
+          <p:cNvPr id="25" name="Slide Number Placeholder 0"/>
+          <p:cNvSpPr>
+            <a:spLocks noGrp="1"/>
+          </p:cNvSpPr>
+          <p:nvPr>
+            <p:ph type="sldNum" sz="quarter" idx="4294967295"/>
+          </p:nvPr>
+        </p:nvSpPr>
+        <p:spPr>
+          <a:xfrm>
+            <a:off x="11247120" y="6446520"/>
+            <a:ext cx="548640" cy="274320"/>
+          </a:xfrm>
+          <a:prstGeom prst="rect">
+            <a:avLst/>
+          </a:prstGeom>
+          <a:extLst>
+            <a:ext uri="{C572A759-6A51-4108-AA02-DFA0A04FC94B}">
+              <ma14:wrappingTextBoxFlag xmlns:ma14="http://schemas.microsoft.com/office/mac/drawingml/2011/main" val="0"/>
+            </a:ext>
+          </a:extLst>
+        </p:spPr>
+        <p:txBody>
+          <a:bodyPr/>
+          <a:lstStyle>
+            <a:lvl1pPr>
+              <a:defRPr sz="1000">
+                <a:solidFill>
+                  <a:srgbClr val="8A96A0"/>
+                </a:solidFill>
+              </a:defRPr>
+            </a:lvl1pPr>
+          </a:lstStyle>
+          <a:p>
+            <a:pPr algn="l"/>
+            <a:fld id="{F7021451-1387-4CA6-816F-3879F97B5CBC}" type="slidenum">
+              <a:rPr b="0" lang="en-US"/>
+              <a:t>10</a:t>
+            </a:fld>
+            <a:endParaRPr lang="en-US"/>
+          </a:p>
+        </p:txBody>
+      </p:sp>
+    </p:spTree>
+  </p:cSld>
+  <p:clrMapOvr>
+    <a:masterClrMapping/>
+  </p:clrMapOvr>
+</p:sld>
+</file>
+
 <file path=ppt/slides/slide2.xml><?xml version="1.0" encoding="utf-8"?>
 <p:sld xmlns:a="http://schemas.openxmlformats.org/drawingml/2006/main" xmlns:r="http://schemas.openxmlformats.org/officeDocument/2006/relationships" xmlns:p="http://schemas.openxmlformats.org/presentationml/2006/main">
   <p:cSld name="Slide 2">
@@ -9700,6 +10226,375 @@
       <p:sp>
         <p:nvSpPr>
           <p:cNvPr id="2" name="Text 0"/>
+          <p:cNvSpPr txBox="1"/>
+          <p:nvPr/>
+        </p:nvSpPr>
+        <p:spPr>
+          <a:xfrm>
+            <a:off x="640080" y="457200"/>
+            <a:ext cx="10972800" cy="731520"/>
+          </a:xfrm>
+          <a:prstGeom prst="rect">
+            <a:avLst/>
+          </a:prstGeom>
+          <a:noFill/>
+          <a:ln/>
+        </p:spPr>
+        <p:txBody>
+          <a:bodyPr wrap="square" lIns="0" tIns="0" rIns="0" bIns="0" rtlCol="0" anchor="ctr"/>
+          <a:lstStyle/>
+          <a:p>
+            <a:pPr indent="0" marL="0">
+              <a:buNone/>
+            </a:pPr>
+            <a:r>
+              <a:rPr lang="en-US" sz="3600" b="1" dirty="0">
+                <a:solidFill>
+                  <a:schemeClr val="bg1"/>
+                </a:solidFill>
+                <a:latin typeface="Cambria" pitchFamily="34" charset="0"/>
+                <a:ea typeface="Cambria" pitchFamily="34" charset="-122"/>
+                <a:cs typeface="Cambria" pitchFamily="34" charset="-120"/>
+              </a:rPr>
+              <a:t>The replication test</a:t>
+            </a:r>
+            <a:endParaRPr lang="en-US" sz="3600" dirty="0"/>
+          </a:p>
+        </p:txBody>
+      </p:sp>
+      <p:sp>
+        <p:nvSpPr>
+          <p:cNvPr id="3" name="Text 1"/>
+          <p:cNvSpPr txBox="1"/>
+          <p:nvPr/>
+        </p:nvSpPr>
+        <p:spPr>
+          <a:xfrm>
+            <a:off x="640080" y="1371600"/>
+            <a:ext cx="5303520" cy="457200"/>
+          </a:xfrm>
+          <a:prstGeom prst="rect">
+            <a:avLst/>
+          </a:prstGeom>
+          <a:noFill/>
+          <a:ln/>
+        </p:spPr>
+        <p:txBody>
+          <a:bodyPr wrap="square" lIns="0" tIns="0" rIns="0" bIns="0" rtlCol="0" anchor="ctr"/>
+          <a:lstStyle/>
+          <a:p>
+            <a:pPr indent="0" marL="0">
+              <a:buNone/>
+            </a:pPr>
+            <a:r>
+              <a:rPr lang="en-US" sz="1800" b="1" dirty="0">
+                <a:solidFill>
+                  <a:srgbClr val="8A96A0"/>
+                </a:solidFill>
+              </a:rPr>
+              <a:t>A weekend with the same tools gets you</a:t>
+            </a:r>
+            <a:endParaRPr lang="en-US" sz="1800" dirty="0"/>
+          </a:p>
+        </p:txBody>
+      </p:sp>
+      <p:sp>
+        <p:nvSpPr>
+          <p:cNvPr id="4" name="Text 2"/>
+          <p:cNvSpPr txBox="1"/>
+          <p:nvPr/>
+        </p:nvSpPr>
+        <p:spPr>
+          <a:xfrm>
+            <a:off x="640080" y="1920240"/>
+            <a:ext cx="5303520" cy="3200400"/>
+          </a:xfrm>
+          <a:prstGeom prst="rect">
+            <a:avLst/>
+          </a:prstGeom>
+          <a:noFill/>
+          <a:ln/>
+        </p:spPr>
+        <p:txBody>
+          <a:bodyPr wrap="square" lIns="0" tIns="0" rIns="0" bIns="0" rtlCol="0" anchor="t"/>
+          <a:lstStyle/>
+          <a:p>
+            <a:pPr marL="342900" indent="-342900">
+              <a:spcAft>
+                <a:spcPts val="600"/>
+              </a:spcAft>
+              <a:buSzPct val="100000"/>
+              <a:buChar char="•"/>
+            </a:pPr>
+            <a:r>
+              <a:rPr lang="en-US" sz="1500" dirty="0">
+                <a:solidFill>
+                  <a:schemeClr val="bg1"/>
+                </a:solidFill>
+              </a:rPr>
+              <a:t>A detector that draws boxes around trucks and cargo</a:t>
+            </a:r>
+            <a:endParaRPr lang="en-US" sz="1500" dirty="0"/>
+          </a:p>
+          <a:p>
+            <a:pPr marL="342900" indent="-342900">
+              <a:spcAft>
+                <a:spcPts val="600"/>
+              </a:spcAft>
+              <a:buSzPct val="100000"/>
+              <a:buChar char="•"/>
+            </a:pPr>
+            <a:r>
+              <a:rPr lang="en-US" sz="1500" dirty="0">
+                <a:solidFill>
+                  <a:schemeClr val="bg1"/>
+                </a:solidFill>
+              </a:rPr>
+              <a:t>A prompt to a vision model that says "looks overloaded"</a:t>
+            </a:r>
+            <a:endParaRPr lang="en-US" sz="1500" dirty="0"/>
+          </a:p>
+          <a:p>
+            <a:pPr marL="342900" indent="-342900">
+              <a:spcAft>
+                <a:spcPts val="600"/>
+              </a:spcAft>
+              <a:buSzPct val="100000"/>
+              <a:buChar char="•"/>
+            </a:pPr>
+            <a:r>
+              <a:rPr lang="en-US" sz="1500" dirty="0">
+                <a:solidFill>
+                  <a:schemeClr val="bg1"/>
+                </a:solidFill>
+              </a:rPr>
+              <a:t>No measurement, no threshold, no number a gate operator can act on</a:t>
+            </a:r>
+            <a:endParaRPr lang="en-US" sz="1500" dirty="0"/>
+          </a:p>
+        </p:txBody>
+      </p:sp>
+      <p:sp>
+        <p:nvSpPr>
+          <p:cNvPr id="5" name="Text 3"/>
+          <p:cNvSpPr txBox="1"/>
+          <p:nvPr/>
+        </p:nvSpPr>
+        <p:spPr>
+          <a:xfrm>
+            <a:off x="6309360" y="1371600"/>
+            <a:ext cx="5303520" cy="457200"/>
+          </a:xfrm>
+          <a:prstGeom prst="rect">
+            <a:avLst/>
+          </a:prstGeom>
+          <a:noFill/>
+          <a:ln/>
+        </p:spPr>
+        <p:txBody>
+          <a:bodyPr wrap="square" lIns="0" tIns="0" rIns="0" bIns="0" rtlCol="0" anchor="ctr"/>
+          <a:lstStyle/>
+          <a:p>
+            <a:pPr indent="0" marL="0">
+              <a:buNone/>
+            </a:pPr>
+            <a:r>
+              <a:rPr lang="en-US" sz="1800" b="1" dirty="0">
+                <a:solidFill>
+                  <a:srgbClr val="F2B705"/>
+                </a:solidFill>
+              </a:rPr>
+              <a:t>What they do not get</a:t>
+            </a:r>
+            <a:endParaRPr lang="en-US" sz="1800" dirty="0"/>
+          </a:p>
+        </p:txBody>
+      </p:sp>
+      <p:sp>
+        <p:nvSpPr>
+          <p:cNvPr id="6" name="Text 4"/>
+          <p:cNvSpPr txBox="1"/>
+          <p:nvPr/>
+        </p:nvSpPr>
+        <p:spPr>
+          <a:xfrm>
+            <a:off x="6309360" y="1920240"/>
+            <a:ext cx="5303520" cy="3657600"/>
+          </a:xfrm>
+          <a:prstGeom prst="rect">
+            <a:avLst/>
+          </a:prstGeom>
+          <a:noFill/>
+          <a:ln/>
+        </p:spPr>
+        <p:txBody>
+          <a:bodyPr wrap="square" lIns="0" tIns="0" rIns="0" bIns="0" rtlCol="0" anchor="t"/>
+          <a:lstStyle/>
+          <a:p>
+            <a:pPr marL="342900" indent="-342900">
+              <a:spcAft>
+                <a:spcPts val="600"/>
+              </a:spcAft>
+              <a:buSzPct val="100000"/>
+              <a:buChar char="•"/>
+            </a:pPr>
+            <a:r>
+              <a:rPr lang="en-US" sz="1500" dirty="0">
+                <a:solidFill>
+                  <a:schemeClr val="bg1"/>
+                </a:solidFill>
+              </a:rPr>
+              <a:t>Perspective-safe roll from vertical edges, with a gravity reference in the same image</a:t>
+            </a:r>
+            <a:endParaRPr lang="en-US" sz="1500" dirty="0"/>
+          </a:p>
+          <a:p>
+            <a:pPr marL="342900" indent="-342900">
+              <a:spcAft>
+                <a:spcPts val="600"/>
+              </a:spcAft>
+              <a:buSzPct val="100000"/>
+              <a:buChar char="•"/>
+            </a:pPr>
+            <a:r>
+              <a:rPr lang="en-US" sz="1500" dirty="0">
+                <a:solidFill>
+                  <a:schemeClr val="bg1"/>
+                </a:solidFill>
+              </a:rPr>
+              <a:t>Centimetres and metres from a known object in the frame, and a CANNOT ASSESS path</a:t>
+            </a:r>
+            <a:endParaRPr lang="en-US" sz="1500" dirty="0"/>
+          </a:p>
+          <a:p>
+            <a:pPr marL="342900" indent="-342900">
+              <a:spcAft>
+                <a:spcPts val="600"/>
+              </a:spcAft>
+              <a:buSzPct val="100000"/>
+              <a:buChar char="•"/>
+            </a:pPr>
+            <a:r>
+              <a:rPr lang="en-US" sz="1500" dirty="0">
+                <a:solidFill>
+                  <a:schemeClr val="bg1"/>
+                </a:solidFill>
+              </a:rPr>
+              <a:t>A decision layer written from Decree 342, the regulation a police post actually applies</a:t>
+            </a:r>
+            <a:endParaRPr lang="en-US" sz="1500" dirty="0"/>
+          </a:p>
+          <a:p>
+            <a:pPr marL="342900" indent="-342900">
+              <a:spcAft>
+                <a:spcPts val="600"/>
+              </a:spcAft>
+              <a:buSzPct val="100000"/>
+              <a:buChar char="•"/>
+            </a:pPr>
+            <a:r>
+              <a:rPr lang="en-US" sz="1500" dirty="0">
+                <a:solidFill>
+                  <a:schemeClr val="bg1"/>
+                </a:solidFill>
+              </a:rPr>
+              <a:t>A privacy stage that makes the product legal to pilot</a:t>
+            </a:r>
+            <a:endParaRPr lang="en-US" sz="1500" dirty="0"/>
+          </a:p>
+          <a:p>
+            <a:pPr marL="342900" indent="-342900">
+              <a:spcAft>
+                <a:spcPts val="600"/>
+              </a:spcAft>
+              <a:buSzPct val="100000"/>
+              <a:buChar char="•"/>
+            </a:pPr>
+            <a:r>
+              <a:rPr lang="en-US" sz="1500" dirty="0">
+                <a:solidFill>
+                  <a:schemeClr val="bg1"/>
+                </a:solidFill>
+              </a:rPr>
+              <a:t>301 licensed images with hit rates, 120 labelled, and a deployed gate product</a:t>
+            </a:r>
+            <a:endParaRPr lang="en-US" sz="1500" dirty="0"/>
+          </a:p>
+        </p:txBody>
+      </p:sp>
+      <p:sp>
+        <p:nvSpPr>
+          <p:cNvPr id="25" name="Slide Number Placeholder 0"/>
+          <p:cNvSpPr>
+            <a:spLocks noGrp="1"/>
+          </p:cNvSpPr>
+          <p:nvPr>
+            <p:ph type="sldNum" sz="quarter" idx="4294967295"/>
+          </p:nvPr>
+        </p:nvSpPr>
+        <p:spPr>
+          <a:xfrm>
+            <a:off x="11247120" y="6446520"/>
+            <a:ext cx="548640" cy="274320"/>
+          </a:xfrm>
+          <a:prstGeom prst="rect">
+            <a:avLst/>
+          </a:prstGeom>
+          <a:extLst>
+            <a:ext uri="{C572A759-6A51-4108-AA02-DFA0A04FC94B}">
+              <ma14:wrappingTextBoxFlag xmlns:ma14="http://schemas.microsoft.com/office/mac/drawingml/2011/main" val="0"/>
+            </a:ext>
+          </a:extLst>
+        </p:spPr>
+        <p:txBody>
+          <a:bodyPr/>
+          <a:lstStyle>
+            <a:lvl1pPr>
+              <a:defRPr sz="1000">
+                <a:solidFill>
+                  <a:srgbClr val="8A96A0"/>
+                </a:solidFill>
+              </a:defRPr>
+            </a:lvl1pPr>
+          </a:lstStyle>
+          <a:p>
+            <a:pPr algn="l"/>
+            <a:fld id="{F7021451-1387-4CA6-816F-3879F97B5CBC}" type="slidenum">
+              <a:rPr b="0" lang="en-US"/>
+              <a:t>8</a:t>
+            </a:fld>
+            <a:endParaRPr lang="en-US"/>
+          </a:p>
+        </p:txBody>
+      </p:sp>
+    </p:spTree>
+  </p:cSld>
+  <p:clrMapOvr>
+    <a:masterClrMapping/>
+  </p:clrMapOvr>
+</p:sld>
+</file>
+
+<file path=ppt/slides/slide9.xml><?xml version="1.0" encoding="utf-8"?>
+<p:sld xmlns:a="http://schemas.openxmlformats.org/drawingml/2006/main" xmlns:r="http://schemas.openxmlformats.org/officeDocument/2006/relationships" xmlns:p="http://schemas.openxmlformats.org/presentationml/2006/main">
+  <p:cSld name="Slide 9">
+    <p:spTree>
+      <p:nvGrpSpPr>
+        <p:cNvPr id="1" name=""/>
+        <p:cNvGrpSpPr/>
+        <p:nvPr/>
+      </p:nvGrpSpPr>
+      <p:grpSpPr>
+        <a:xfrm>
+          <a:off x="0" y="0"/>
+          <a:ext cx="0" cy="0"/>
+          <a:chOff x="0" y="0"/>
+          <a:chExt cx="0" cy="0"/>
+        </a:xfrm>
+      </p:grpSpPr>
+      <p:sp>
+        <p:nvSpPr>
+          <p:cNvPr id="2" name="Text 0"/>
           <p:cNvSpPr/>
           <p:nvPr>
             <p:ph idx="100" type="title" hasCustomPrompt="1"/>
@@ -9737,7 +10632,7 @@
       </p:sp>
       <p:graphicFrame>
         <p:nvGraphicFramePr>
-          <p:cNvPr id="9" name="Table 0"/>
+          <p:cNvPr id="10" name="Table 0"/>
           <p:cNvGraphicFramePr>
             <a:graphicFrameLocks noGrp="1"/>
           </p:cNvGraphicFramePr>
@@ -10833,7 +11728,7 @@
       </p:graphicFrame>
       <p:graphicFrame>
         <p:nvGraphicFramePr>
-          <p:cNvPr id="17" name="Table 1"/>
+          <p:cNvPr id="19" name="Table 1"/>
           <p:cNvGraphicFramePr>
             <a:graphicFrameLocks noGrp="1"/>
           </p:cNvGraphicFramePr>
@@ -11992,442 +12887,6 @@
               <a:t>Pilot cost $8,570 (team $7,200 + cameras $600 + hosting $270 + labelling $500). Avoided loss $5,000 per month at one caught incident a month. Payback = 8,570 / 5,000 = 1.7 months, inside the pilot itself. The fleet's own incident rate replaces the assumption after month one.</a:t>
             </a:r>
             <a:endParaRPr lang="en-US" sz="1200" dirty="0"/>
-          </a:p>
-        </p:txBody>
-      </p:sp>
-      <p:sp>
-        <p:nvSpPr>
-          <p:cNvPr id="25" name="Slide Number Placeholder 0"/>
-          <p:cNvSpPr>
-            <a:spLocks noGrp="1"/>
-          </p:cNvSpPr>
-          <p:nvPr>
-            <p:ph type="sldNum" sz="quarter" idx="4294967295"/>
-          </p:nvPr>
-        </p:nvSpPr>
-        <p:spPr>
-          <a:xfrm>
-            <a:off x="11247120" y="6446520"/>
-            <a:ext cx="548640" cy="274320"/>
-          </a:xfrm>
-          <a:prstGeom prst="rect">
-            <a:avLst/>
-          </a:prstGeom>
-          <a:extLst>
-            <a:ext uri="{C572A759-6A51-4108-AA02-DFA0A04FC94B}">
-              <ma14:wrappingTextBoxFlag xmlns:ma14="http://schemas.microsoft.com/office/mac/drawingml/2011/main" val="0"/>
-            </a:ext>
-          </a:extLst>
-        </p:spPr>
-        <p:txBody>
-          <a:bodyPr/>
-          <a:lstStyle>
-            <a:lvl1pPr>
-              <a:defRPr sz="1000">
-                <a:solidFill>
-                  <a:srgbClr val="8A96A0"/>
-                </a:solidFill>
-              </a:defRPr>
-            </a:lvl1pPr>
-          </a:lstStyle>
-          <a:p>
-            <a:pPr algn="l"/>
-            <a:fld id="{F7021451-1387-4CA6-816F-3879F97B5CBC}" type="slidenum">
-              <a:rPr b="0" lang="en-US"/>
-              <a:t>8</a:t>
-            </a:fld>
-            <a:endParaRPr lang="en-US"/>
-          </a:p>
-        </p:txBody>
-      </p:sp>
-    </p:spTree>
-  </p:cSld>
-  <p:clrMapOvr>
-    <a:masterClrMapping/>
-  </p:clrMapOvr>
-</p:sld>
-</file>
-
-<file path=ppt/slides/slide9.xml><?xml version="1.0" encoding="utf-8"?>
-<p:sld xmlns:a="http://schemas.openxmlformats.org/drawingml/2006/main" xmlns:r="http://schemas.openxmlformats.org/officeDocument/2006/relationships" xmlns:p="http://schemas.openxmlformats.org/presentationml/2006/main">
-  <p:cSld name="Slide 9">
-    <p:spTree>
-      <p:nvGrpSpPr>
-        <p:cNvPr id="1" name=""/>
-        <p:cNvGrpSpPr/>
-        <p:nvPr/>
-      </p:nvGrpSpPr>
-      <p:grpSpPr>
-        <a:xfrm>
-          <a:off x="0" y="0"/>
-          <a:ext cx="0" cy="0"/>
-          <a:chOff x="0" y="0"/>
-          <a:chExt cx="0" cy="0"/>
-        </a:xfrm>
-      </p:grpSpPr>
-      <p:sp>
-        <p:nvSpPr>
-          <p:cNvPr id="2" name="Text 0"/>
-          <p:cNvSpPr txBox="1"/>
-          <p:nvPr/>
-        </p:nvSpPr>
-        <p:spPr>
-          <a:xfrm>
-            <a:off x="640080" y="457200"/>
-            <a:ext cx="10972800" cy="731520"/>
-          </a:xfrm>
-          <a:prstGeom prst="rect">
-            <a:avLst/>
-          </a:prstGeom>
-          <a:noFill/>
-          <a:ln/>
-        </p:spPr>
-        <p:txBody>
-          <a:bodyPr wrap="square" lIns="0" tIns="0" rIns="0" bIns="0" rtlCol="0" anchor="ctr"/>
-          <a:lstStyle/>
-          <a:p>
-            <a:pPr indent="0" marL="0">
-              <a:buNone/>
-            </a:pPr>
-            <a:r>
-              <a:rPr lang="en-US" sz="3600" b="1" dirty="0">
-                <a:solidFill>
-                  <a:schemeClr val="bg1"/>
-                </a:solidFill>
-                <a:latin typeface="Cambria" pitchFamily="34" charset="0"/>
-                <a:ea typeface="Cambria" pitchFamily="34" charset="-122"/>
-                <a:cs typeface="Cambria" pitchFamily="34" charset="-120"/>
-              </a:rPr>
-              <a:t>Next steps</a:t>
-            </a:r>
-            <a:endParaRPr lang="en-US" sz="3600" dirty="0"/>
-          </a:p>
-        </p:txBody>
-      </p:sp>
-      <p:sp>
-        <p:nvSpPr>
-          <p:cNvPr id="3" name="Shape 1"/>
-          <p:cNvSpPr/>
-          <p:nvPr/>
-        </p:nvSpPr>
-        <p:spPr>
-          <a:xfrm>
-            <a:off x="640080" y="1554480"/>
-            <a:ext cx="3474720" cy="2926080"/>
-          </a:xfrm>
-          <a:prstGeom prst="rect">
-            <a:avLst/>
-          </a:prstGeom>
-          <a:solidFill>
-            <a:srgbClr val="3A4248"/>
-          </a:solidFill>
-          <a:ln w="12700">
-            <a:solidFill>
-              <a:srgbClr val="3A4248"/>
-            </a:solidFill>
-            <a:prstDash val="solid"/>
-          </a:ln>
-        </p:spPr>
-      </p:sp>
-      <p:sp>
-        <p:nvSpPr>
-          <p:cNvPr id="4" name="Text 2"/>
-          <p:cNvSpPr txBox="1"/>
-          <p:nvPr/>
-        </p:nvSpPr>
-        <p:spPr>
-          <a:xfrm>
-            <a:off x="914400" y="1737360"/>
-            <a:ext cx="2926080" cy="457200"/>
-          </a:xfrm>
-          <a:prstGeom prst="rect">
-            <a:avLst/>
-          </a:prstGeom>
-          <a:noFill/>
-          <a:ln/>
-        </p:spPr>
-        <p:txBody>
-          <a:bodyPr wrap="square" lIns="0" tIns="0" rIns="0" bIns="0" rtlCol="0" anchor="ctr"/>
-          <a:lstStyle/>
-          <a:p>
-            <a:pPr indent="0" marL="0">
-              <a:buNone/>
-            </a:pPr>
-            <a:r>
-              <a:rPr lang="en-US" sz="2000" b="1" dirty="0">
-                <a:solidFill>
-                  <a:srgbClr val="F2B705"/>
-                </a:solidFill>
-              </a:rPr>
-              <a:t>Month 1</a:t>
-            </a:r>
-            <a:endParaRPr lang="en-US" sz="2000" dirty="0"/>
-          </a:p>
-        </p:txBody>
-      </p:sp>
-      <p:sp>
-        <p:nvSpPr>
-          <p:cNvPr id="5" name="Text 3"/>
-          <p:cNvSpPr txBox="1"/>
-          <p:nvPr/>
-        </p:nvSpPr>
-        <p:spPr>
-          <a:xfrm>
-            <a:off x="914400" y="2286000"/>
-            <a:ext cx="2926080" cy="2011680"/>
-          </a:xfrm>
-          <a:prstGeom prst="rect">
-            <a:avLst/>
-          </a:prstGeom>
-          <a:noFill/>
-          <a:ln/>
-        </p:spPr>
-        <p:txBody>
-          <a:bodyPr wrap="square" lIns="0" tIns="0" rIns="0" bIns="0" rtlCol="0" anchor="t"/>
-          <a:lstStyle/>
-          <a:p>
-            <a:pPr indent="0" marL="0">
-              <a:buNone/>
-            </a:pPr>
-            <a:r>
-              <a:rPr lang="en-US" sz="1400" dirty="0">
-                <a:solidFill>
-                  <a:schemeClr val="bg1"/>
-                </a:solidFill>
-              </a:rPr>
-              <a:t>Fixed, calibrated camera at one gate. Reference marker removes scale ambiguity. Ten-second video mode.</a:t>
-            </a:r>
-            <a:endParaRPr lang="en-US" sz="1400" dirty="0"/>
-          </a:p>
-        </p:txBody>
-      </p:sp>
-      <p:sp>
-        <p:nvSpPr>
-          <p:cNvPr id="6" name="Shape 4"/>
-          <p:cNvSpPr/>
-          <p:nvPr/>
-        </p:nvSpPr>
-        <p:spPr>
-          <a:xfrm>
-            <a:off x="4389120" y="1554480"/>
-            <a:ext cx="3474720" cy="2926080"/>
-          </a:xfrm>
-          <a:prstGeom prst="rect">
-            <a:avLst/>
-          </a:prstGeom>
-          <a:solidFill>
-            <a:srgbClr val="3A4248"/>
-          </a:solidFill>
-          <a:ln w="12700">
-            <a:solidFill>
-              <a:srgbClr val="3A4248"/>
-            </a:solidFill>
-            <a:prstDash val="solid"/>
-          </a:ln>
-        </p:spPr>
-      </p:sp>
-      <p:sp>
-        <p:nvSpPr>
-          <p:cNvPr id="7" name="Text 5"/>
-          <p:cNvSpPr txBox="1"/>
-          <p:nvPr/>
-        </p:nvSpPr>
-        <p:spPr>
-          <a:xfrm>
-            <a:off x="4663440" y="1737360"/>
-            <a:ext cx="2926080" cy="457200"/>
-          </a:xfrm>
-          <a:prstGeom prst="rect">
-            <a:avLst/>
-          </a:prstGeom>
-          <a:noFill/>
-          <a:ln/>
-        </p:spPr>
-        <p:txBody>
-          <a:bodyPr wrap="square" lIns="0" tIns="0" rIns="0" bIns="0" rtlCol="0" anchor="ctr"/>
-          <a:lstStyle/>
-          <a:p>
-            <a:pPr indent="0" marL="0">
-              <a:buNone/>
-            </a:pPr>
-            <a:r>
-              <a:rPr lang="en-US" sz="2000" b="1" dirty="0">
-                <a:solidFill>
-                  <a:srgbClr val="F2B705"/>
-                </a:solidFill>
-              </a:rPr>
-              <a:t>Month 2</a:t>
-            </a:r>
-            <a:endParaRPr lang="en-US" sz="2000" dirty="0"/>
-          </a:p>
-        </p:txBody>
-      </p:sp>
-      <p:sp>
-        <p:nvSpPr>
-          <p:cNvPr id="8" name="Text 6"/>
-          <p:cNvSpPr txBox="1"/>
-          <p:nvPr/>
-        </p:nvSpPr>
-        <p:spPr>
-          <a:xfrm>
-            <a:off x="4663440" y="2286000"/>
-            <a:ext cx="2926080" cy="2011680"/>
-          </a:xfrm>
-          <a:prstGeom prst="rect">
-            <a:avLst/>
-          </a:prstGeom>
-          <a:noFill/>
-          <a:ln/>
-        </p:spPr>
-        <p:txBody>
-          <a:bodyPr wrap="square" lIns="0" tIns="0" rIns="0" bIns="0" rtlCol="0" anchor="t"/>
-          <a:lstStyle/>
-          <a:p>
-            <a:pPr indent="0" marL="0">
-              <a:buNone/>
-            </a:pPr>
-            <a:r>
-              <a:rPr lang="en-US" sz="1400" dirty="0">
-                <a:solidFill>
-                  <a:schemeClr val="bg1"/>
-                </a:solidFill>
-              </a:rPr>
-              <a:t>Fine-tune the detector on our labelled set. Add open door, loose strap and missing marking classes.</a:t>
-            </a:r>
-            <a:endParaRPr lang="en-US" sz="1400" dirty="0"/>
-          </a:p>
-        </p:txBody>
-      </p:sp>
-      <p:sp>
-        <p:nvSpPr>
-          <p:cNvPr id="9" name="Shape 7"/>
-          <p:cNvSpPr/>
-          <p:nvPr/>
-        </p:nvSpPr>
-        <p:spPr>
-          <a:xfrm>
-            <a:off x="8138160" y="1554480"/>
-            <a:ext cx="3474720" cy="2926080"/>
-          </a:xfrm>
-          <a:prstGeom prst="rect">
-            <a:avLst/>
-          </a:prstGeom>
-          <a:solidFill>
-            <a:srgbClr val="3A4248"/>
-          </a:solidFill>
-          <a:ln w="12700">
-            <a:solidFill>
-              <a:srgbClr val="3A4248"/>
-            </a:solidFill>
-            <a:prstDash val="solid"/>
-          </a:ln>
-        </p:spPr>
-      </p:sp>
-      <p:sp>
-        <p:nvSpPr>
-          <p:cNvPr id="10" name="Text 8"/>
-          <p:cNvSpPr txBox="1"/>
-          <p:nvPr/>
-        </p:nvSpPr>
-        <p:spPr>
-          <a:xfrm>
-            <a:off x="8412480" y="1737360"/>
-            <a:ext cx="2926080" cy="457200"/>
-          </a:xfrm>
-          <a:prstGeom prst="rect">
-            <a:avLst/>
-          </a:prstGeom>
-          <a:noFill/>
-          <a:ln/>
-        </p:spPr>
-        <p:txBody>
-          <a:bodyPr wrap="square" lIns="0" tIns="0" rIns="0" bIns="0" rtlCol="0" anchor="ctr"/>
-          <a:lstStyle/>
-          <a:p>
-            <a:pPr indent="0" marL="0">
-              <a:buNone/>
-            </a:pPr>
-            <a:r>
-              <a:rPr lang="en-US" sz="2000" b="1" dirty="0">
-                <a:solidFill>
-                  <a:srgbClr val="F2B705"/>
-                </a:solidFill>
-              </a:rPr>
-              <a:t>Month 3</a:t>
-            </a:r>
-            <a:endParaRPr lang="en-US" sz="2000" dirty="0"/>
-          </a:p>
-        </p:txBody>
-      </p:sp>
-      <p:sp>
-        <p:nvSpPr>
-          <p:cNvPr id="11" name="Text 9"/>
-          <p:cNvSpPr txBox="1"/>
-          <p:nvPr/>
-        </p:nvSpPr>
-        <p:spPr>
-          <a:xfrm>
-            <a:off x="8412480" y="2286000"/>
-            <a:ext cx="2926080" cy="2011680"/>
-          </a:xfrm>
-          <a:prstGeom prst="rect">
-            <a:avLst/>
-          </a:prstGeom>
-          <a:noFill/>
-          <a:ln/>
-        </p:spPr>
-        <p:txBody>
-          <a:bodyPr wrap="square" lIns="0" tIns="0" rIns="0" bIns="0" rtlCol="0" anchor="t"/>
-          <a:lstStyle/>
-          <a:p>
-            <a:pPr indent="0" marL="0">
-              <a:buNone/>
-            </a:pPr>
-            <a:r>
-              <a:rPr lang="en-US" sz="1400" dirty="0">
-                <a:solidFill>
-                  <a:schemeClr val="bg1"/>
-                </a:solidFill>
-              </a:rPr>
-              <a:t>Weighbridge and dispatch integration. Pilot at a Royal Motors receiving yard on incoming car carriers.</a:t>
-            </a:r>
-            <a:endParaRPr lang="en-US" sz="1400" dirty="0"/>
-          </a:p>
-        </p:txBody>
-      </p:sp>
-      <p:sp>
-        <p:nvSpPr>
-          <p:cNvPr id="12" name="Text 10"/>
-          <p:cNvSpPr txBox="1"/>
-          <p:nvPr/>
-        </p:nvSpPr>
-        <p:spPr>
-          <a:xfrm>
-            <a:off x="640080" y="4937760"/>
-            <a:ext cx="10972800" cy="457200"/>
-          </a:xfrm>
-          <a:prstGeom prst="rect">
-            <a:avLst/>
-          </a:prstGeom>
-          <a:noFill/>
-          <a:ln/>
-        </p:spPr>
-        <p:txBody>
-          <a:bodyPr wrap="square" lIns="0" tIns="0" rIns="0" bIns="0" rtlCol="0" anchor="ctr"/>
-          <a:lstStyle/>
-          <a:p>
-            <a:pPr indent="0" marL="0">
-              <a:buNone/>
-            </a:pPr>
-            <a:r>
-              <a:rPr lang="en-US" sz="1300" dirty="0">
-                <a:solidFill>
-                  <a:srgbClr val="8A96A0"/>
-                </a:solidFill>
-              </a:rPr>
-              <a:t>Repository: github.com/Winner-121/Destroyerrrrs_Final_Stage   ·   Demo: amir-kuldashev--load-safety-gate-web.modal.run</a:t>
-            </a:r>
-            <a:endParaRPr lang="en-US" sz="1300" dirty="0"/>
           </a:p>
         </p:txBody>
       </p:sp>

</xml_diff>

<commit_message>
Deck rebuilt with the replication slide restored
Co-Authored-By: Claude Fable 5.1 <noreply@anthropic.com>
</commit_message>
<xml_diff>
--- a/deck/LoadSafetyGate_deck.pptx
+++ b/deck/LoadSafetyGate_deck.pptx
@@ -116,22 +116,22 @@
   <p:extLst>
     <p:ext uri="{521415D9-36F7-43E2-AB2F-B90AF26B5E84}">
       <p14:sectionLst xmlns:p14="http://schemas.microsoft.com/office/powerpoint/2010/main">
-        <p14:section name="Opening" id="{2411df9f-7252-c906-8d67-36b160a4d231}">
+        <p14:section name="Opening" id="{df5d8a36-4d1b-c7a2-038f-73f7b849d794}">
           <p14:sldIdLst>
             <p14:sldId id="256"/>
           </p14:sldIdLst>
         </p14:section>
-        <p14:section name="Problem" id="{105a1b19-ef4c-9eb8-af59-4740a307ca2d}">
+        <p14:section name="Problem" id="{5914140f-5a7d-134c-eccf-4d7f28156d0e}">
           <p14:sldIdLst>
             <p14:sldId id="257"/>
           </p14:sldIdLst>
         </p14:section>
-        <p14:section name="Demo" id="{7ce76d47-aac0-1ab8-6d66-f2a59a1fc0a1}">
+        <p14:section name="Demo" id="{2b56c816-9bd1-ed24-4c3b-43e1629d66bf}">
           <p14:sldIdLst>
             <p14:sldId id="258"/>
           </p14:sldIdLst>
         </p14:section>
-        <p14:section name="Technology" id="{c33bcd73-e40e-1f0c-5382-7c88e8c3eee5}">
+        <p14:section name="Technology" id="{d60ed1a2-35f8-cf39-ddac-565e1cd8b5d2}">
           <p14:sldIdLst>
             <p14:sldId id="259"/>
             <p14:sldId id="260"/>
@@ -140,7 +140,7 @@
             <p14:sldId id="263"/>
           </p14:sldIdLst>
         </p14:section>
-        <p14:section name="Business" id="{806732d8-76ac-2665-c060-ca9f2584f200}">
+        <p14:section name="Business" id="{4a70d33c-3469-d335-18fb-bb1e729db886}">
           <p14:sldIdLst>
             <p14:sldId id="264"/>
             <p14:sldId id="265"/>

</xml_diff>

<commit_message>
Deck: rounded shadowed cards, accent bars, translucent orbs, fade transitions, closing slide with an original dancing cat GIF
Co-Authored-By: Claude Fable 5.1 <noreply@anthropic.com>
</commit_message>
<xml_diff>
--- a/deck/LoadSafetyGate_deck.pptx
+++ b/deck/LoadSafetyGate_deck.pptx
@@ -15,9 +15,10 @@
     <p:sldId id="263" r:id="rId9"/>
     <p:sldId id="264" r:id="rId10"/>
     <p:sldId id="265" r:id="rId11"/>
+    <p:sldId id="266" r:id="rId12"/>
   </p:sldIdLst>
   <p:notesMasterIdLst>
-    <p:notesMasterId r:id="rId12"/>
+    <p:notesMasterId r:id="rId13"/>
   </p:notesMasterIdLst>
   <p:sldSz cx="12192000" cy="6858000"/>
   <p:notesSz cx="6858000" cy="12192000"/>
@@ -116,22 +117,22 @@
   <p:extLst>
     <p:ext uri="{521415D9-36F7-43E2-AB2F-B90AF26B5E84}">
       <p14:sectionLst xmlns:p14="http://schemas.microsoft.com/office/powerpoint/2010/main">
-        <p14:section name="Opening" id="{df5d8a36-4d1b-c7a2-038f-73f7b849d794}">
+        <p14:section name="Opening" id="{8426936e-308e-86f5-e3e6-46ecdd8cc8b8}">
           <p14:sldIdLst>
             <p14:sldId id="256"/>
           </p14:sldIdLst>
         </p14:section>
-        <p14:section name="Problem" id="{5914140f-5a7d-134c-eccf-4d7f28156d0e}">
+        <p14:section name="Problem" id="{392484ad-cceb-b466-f494-42f1ab00ff71}">
           <p14:sldIdLst>
             <p14:sldId id="257"/>
           </p14:sldIdLst>
         </p14:section>
-        <p14:section name="Demo" id="{2b56c816-9bd1-ed24-4c3b-43e1629d66bf}">
+        <p14:section name="Demo" id="{33744c6a-54f8-a9c2-425e-78ee8cbf8e29}">
           <p14:sldIdLst>
             <p14:sldId id="258"/>
           </p14:sldIdLst>
         </p14:section>
-        <p14:section name="Technology" id="{d60ed1a2-35f8-cf39-ddac-565e1cd8b5d2}">
+        <p14:section name="Technology" id="{95512579-e881-5331-439e-6b55348fe19c}">
           <p14:sldIdLst>
             <p14:sldId id="259"/>
             <p14:sldId id="260"/>
@@ -140,10 +141,11 @@
             <p14:sldId id="263"/>
           </p14:sldIdLst>
         </p14:section>
-        <p14:section name="Business" id="{4a70d33c-3469-d335-18fb-bb1e729db886}">
+        <p14:section name="Business" id="{27dddc89-fe20-2940-3a23-e6c5e59871da}">
           <p14:sldIdLst>
             <p14:sldId id="264"/>
             <p14:sldId id="265"/>
+            <p14:sldId id="266"/>
           </p14:sldIdLst>
         </p14:section>
       </p14:sectionLst>
@@ -680,6 +682,94 @@
 </p:notes>
 </file>
 
+<file path=ppt/notesSlides/notesSlide11.xml><?xml version="1.0" encoding="utf-8"?>
+<p:notes xmlns:a="http://schemas.openxmlformats.org/drawingml/2006/main" xmlns:r="http://schemas.openxmlformats.org/officeDocument/2006/relationships" xmlns:p="http://schemas.openxmlformats.org/presentationml/2006/main">
+  <p:cSld>
+    <p:spTree>
+      <p:nvGrpSpPr>
+        <p:cNvPr id="1" name=""/>
+        <p:cNvGrpSpPr/>
+        <p:nvPr/>
+      </p:nvGrpSpPr>
+      <p:grpSpPr>
+        <a:xfrm>
+          <a:off x="0" y="0"/>
+          <a:ext cx="0" cy="0"/>
+          <a:chOff x="0" y="0"/>
+          <a:chExt cx="0" cy="0"/>
+        </a:xfrm>
+      </p:grpSpPr>
+      <p:sp>
+        <p:nvSpPr>
+          <p:cNvPr id="2" name="Slide Image Placeholder 1"/>
+          <p:cNvSpPr>
+            <a:spLocks noGrp="1" noRot="1" noChangeAspect="1"/>
+          </p:cNvSpPr>
+          <p:nvPr>
+            <p:ph type="sldImg"/>
+          </p:nvPr>
+        </p:nvSpPr>
+        <p:spPr/>
+      </p:sp>
+      <p:sp>
+        <p:nvSpPr>
+          <p:cNvPr id="3" name="Notes Placeholder 2"/>
+          <p:cNvSpPr>
+            <a:spLocks noGrp="1"/>
+          </p:cNvSpPr>
+          <p:nvPr>
+            <p:ph type="body" idx="1"/>
+          </p:nvPr>
+        </p:nvSpPr>
+        <p:spPr/>
+        <p:txBody>
+          <a:bodyPr/>
+          <a:lstStyle/>
+          <a:p>
+            <a:r>
+              <a:rPr lang="en-US" dirty="0"/>
+              <a:t/>
+            </a:r>
+            <a:endParaRPr lang="en-US" dirty="0"/>
+          </a:p>
+        </p:txBody>
+      </p:sp>
+      <p:sp>
+        <p:nvSpPr>
+          <p:cNvPr id="4" name="Slide Number Placeholder 3"/>
+          <p:cNvSpPr>
+            <a:spLocks noGrp="1"/>
+          </p:cNvSpPr>
+          <p:nvPr>
+            <p:ph type="sldNum" sz="quarter" idx="10"/>
+          </p:nvPr>
+        </p:nvSpPr>
+        <p:spPr/>
+        <p:txBody>
+          <a:bodyPr/>
+          <a:lstStyle/>
+          <a:p>
+            <a:fld id="{F7021451-1387-4CA6-816F-3879F97B5CBC}" type="slidenum">
+              <a:rPr lang="en-US"/>
+              <a:t>11</a:t>
+            </a:fld>
+            <a:endParaRPr lang="en-US"/>
+          </a:p>
+        </p:txBody>
+      </p:sp>
+    </p:spTree>
+    <p:extLst>
+      <p:ext uri="{BB962C8B-B14F-4D97-AF65-F5344CB8AC3E}">
+        <p14:creationId xmlns:p14="http://schemas.microsoft.com/office/powerpoint/2010/main" val="1024086991"/>
+      </p:ext>
+    </p:extLst>
+  </p:cSld>
+  <p:clrMapOvr>
+    <a:masterClrMapping/>
+  </p:clrMapOvr>
+</p:notes>
+</file>
+
 <file path=ppt/notesSlides/notesSlide2.xml><?xml version="1.0" encoding="utf-8"?>
 <p:notes xmlns:a="http://schemas.openxmlformats.org/drawingml/2006/main" xmlns:r="http://schemas.openxmlformats.org/officeDocument/2006/relationships" xmlns:p="http://schemas.openxmlformats.org/presentationml/2006/main">
   <p:cSld>
@@ -1561,8 +1651,8 @@
         </p:nvSpPr>
         <p:spPr>
           <a:xfrm>
-            <a:off x="457200" y="320040"/>
-            <a:ext cx="11247120" cy="731520"/>
+            <a:off x="685800" y="320040"/>
+            <a:ext cx="11018520" cy="731520"/>
           </a:xfrm>
           <a:prstGeom prst="rect">
             <a:avLst/>
@@ -2022,7 +2112,169 @@
       </p:grpSpPr>
       <p:sp>
         <p:nvSpPr>
-          <p:cNvPr id="2" name="Text 0"/>
+          <p:cNvPr id="2" name="Shape 0"/>
+          <p:cNvSpPr/>
+          <p:nvPr/>
+        </p:nvSpPr>
+        <p:spPr>
+          <a:xfrm>
+            <a:off x="8778240" y="-1463040"/>
+            <a:ext cx="4754880" cy="4754880"/>
+          </a:xfrm>
+          <a:prstGeom prst="ellipse">
+            <a:avLst/>
+          </a:prstGeom>
+          <a:solidFill>
+            <a:srgbClr val="1F5F8B">
+              <a:alpha val="28000"/>
+            </a:srgbClr>
+          </a:solidFill>
+          <a:ln w="12700">
+            <a:solidFill>
+              <a:srgbClr val="1F5F8B"/>
+            </a:solidFill>
+            <a:prstDash val="solid"/>
+          </a:ln>
+        </p:spPr>
+      </p:sp>
+      <p:sp>
+        <p:nvSpPr>
+          <p:cNvPr id="3" name="Shape 1"/>
+          <p:cNvSpPr/>
+          <p:nvPr/>
+        </p:nvSpPr>
+        <p:spPr>
+          <a:xfrm>
+            <a:off x="-1280160" y="4206240"/>
+            <a:ext cx="3657600" cy="3657600"/>
+          </a:xfrm>
+          <a:prstGeom prst="ellipse">
+            <a:avLst/>
+          </a:prstGeom>
+          <a:solidFill>
+            <a:srgbClr val="F2B705">
+              <a:alpha val="16000"/>
+            </a:srgbClr>
+          </a:solidFill>
+          <a:ln w="12700">
+            <a:solidFill>
+              <a:srgbClr val="F2B705"/>
+            </a:solidFill>
+            <a:prstDash val="solid"/>
+          </a:ln>
+        </p:spPr>
+      </p:sp>
+      <p:sp>
+        <p:nvSpPr>
+          <p:cNvPr id="4" name="Shape 2"/>
+          <p:cNvSpPr/>
+          <p:nvPr/>
+        </p:nvSpPr>
+        <p:spPr>
+          <a:xfrm>
+            <a:off x="10607040" y="4937760"/>
+            <a:ext cx="2377440" cy="2377440"/>
+          </a:xfrm>
+          <a:prstGeom prst="ellipse">
+            <a:avLst/>
+          </a:prstGeom>
+          <a:solidFill>
+            <a:srgbClr val="2A8A4A">
+              <a:alpha val="20000"/>
+            </a:srgbClr>
+          </a:solidFill>
+          <a:ln w="12700">
+            <a:solidFill>
+              <a:srgbClr val="2A8A4A"/>
+            </a:solidFill>
+            <a:prstDash val="solid"/>
+          </a:ln>
+        </p:spPr>
+      </p:sp>
+      <p:sp>
+        <p:nvSpPr>
+          <p:cNvPr id="5" name="Shape 3"/>
+          <p:cNvSpPr/>
+          <p:nvPr/>
+        </p:nvSpPr>
+        <p:spPr>
+          <a:xfrm>
+            <a:off x="8778240" y="-1463040"/>
+            <a:ext cx="4754880" cy="4754880"/>
+          </a:xfrm>
+          <a:prstGeom prst="ellipse">
+            <a:avLst/>
+          </a:prstGeom>
+          <a:solidFill>
+            <a:srgbClr val="1F5F8B">
+              <a:alpha val="28000"/>
+            </a:srgbClr>
+          </a:solidFill>
+          <a:ln w="12700">
+            <a:solidFill>
+              <a:srgbClr val="1F5F8B"/>
+            </a:solidFill>
+            <a:prstDash val="solid"/>
+          </a:ln>
+        </p:spPr>
+      </p:sp>
+      <p:sp>
+        <p:nvSpPr>
+          <p:cNvPr id="6" name="Shape 4"/>
+          <p:cNvSpPr/>
+          <p:nvPr/>
+        </p:nvSpPr>
+        <p:spPr>
+          <a:xfrm>
+            <a:off x="-1280160" y="4206240"/>
+            <a:ext cx="3657600" cy="3657600"/>
+          </a:xfrm>
+          <a:prstGeom prst="ellipse">
+            <a:avLst/>
+          </a:prstGeom>
+          <a:solidFill>
+            <a:srgbClr val="F2B705">
+              <a:alpha val="16000"/>
+            </a:srgbClr>
+          </a:solidFill>
+          <a:ln w="12700">
+            <a:solidFill>
+              <a:srgbClr val="F2B705"/>
+            </a:solidFill>
+            <a:prstDash val="solid"/>
+          </a:ln>
+        </p:spPr>
+      </p:sp>
+      <p:sp>
+        <p:nvSpPr>
+          <p:cNvPr id="7" name="Shape 5"/>
+          <p:cNvSpPr/>
+          <p:nvPr/>
+        </p:nvSpPr>
+        <p:spPr>
+          <a:xfrm>
+            <a:off x="10607040" y="4937760"/>
+            <a:ext cx="2377440" cy="2377440"/>
+          </a:xfrm>
+          <a:prstGeom prst="ellipse">
+            <a:avLst/>
+          </a:prstGeom>
+          <a:solidFill>
+            <a:srgbClr val="2A8A4A">
+              <a:alpha val="20000"/>
+            </a:srgbClr>
+          </a:solidFill>
+          <a:ln w="12700">
+            <a:solidFill>
+              <a:srgbClr val="2A8A4A"/>
+            </a:solidFill>
+            <a:prstDash val="solid"/>
+          </a:ln>
+        </p:spPr>
+      </p:sp>
+      <p:sp>
+        <p:nvSpPr>
+          <p:cNvPr id="8" name="Text 6"/>
           <p:cNvSpPr txBox="1"/>
           <p:nvPr/>
         </p:nvSpPr>
@@ -2061,7 +2313,7 @@
       </p:sp>
       <p:sp>
         <p:nvSpPr>
-          <p:cNvPr id="3" name="Text 1"/>
+          <p:cNvPr id="9" name="Text 7"/>
           <p:cNvSpPr txBox="1"/>
           <p:nvPr/>
         </p:nvSpPr>
@@ -2097,7 +2349,7 @@
       </p:sp>
       <p:sp>
         <p:nvSpPr>
-          <p:cNvPr id="4" name="Text 2"/>
+          <p:cNvPr id="10" name="Text 8"/>
           <p:cNvSpPr txBox="1"/>
           <p:nvPr/>
         </p:nvSpPr>
@@ -2133,7 +2385,7 @@
       </p:sp>
       <p:sp>
         <p:nvSpPr>
-          <p:cNvPr id="5" name="Shape 3"/>
+          <p:cNvPr id="11" name="Shape 9"/>
           <p:cNvSpPr/>
           <p:nvPr/>
         </p:nvSpPr>
@@ -2160,7 +2412,7 @@
       </p:sp>
       <p:sp>
         <p:nvSpPr>
-          <p:cNvPr id="6" name="Text 4"/>
+          <p:cNvPr id="12" name="Text 10"/>
           <p:cNvSpPr txBox="1"/>
           <p:nvPr/>
         </p:nvSpPr>
@@ -2196,7 +2448,7 @@
       </p:sp>
       <p:sp>
         <p:nvSpPr>
-          <p:cNvPr id="7" name="Shape 5"/>
+          <p:cNvPr id="13" name="Shape 11"/>
           <p:cNvSpPr/>
           <p:nvPr/>
         </p:nvSpPr>
@@ -2223,7 +2475,7 @@
       </p:sp>
       <p:sp>
         <p:nvSpPr>
-          <p:cNvPr id="8" name="Text 6"/>
+          <p:cNvPr id="14" name="Text 12"/>
           <p:cNvSpPr txBox="1"/>
           <p:nvPr/>
         </p:nvSpPr>
@@ -2259,7 +2511,7 @@
       </p:sp>
       <p:sp>
         <p:nvSpPr>
-          <p:cNvPr id="9" name="Shape 7"/>
+          <p:cNvPr id="15" name="Shape 13"/>
           <p:cNvSpPr/>
           <p:nvPr/>
         </p:nvSpPr>
@@ -2286,7 +2538,7 @@
       </p:sp>
       <p:sp>
         <p:nvSpPr>
-          <p:cNvPr id="10" name="Text 8"/>
+          <p:cNvPr id="16" name="Text 14"/>
           <p:cNvSpPr txBox="1"/>
           <p:nvPr/>
         </p:nvSpPr>
@@ -2322,7 +2574,7 @@
       </p:sp>
       <p:sp>
         <p:nvSpPr>
-          <p:cNvPr id="11" name="Text 9"/>
+          <p:cNvPr id="17" name="Text 15"/>
           <p:cNvSpPr txBox="1"/>
           <p:nvPr/>
         </p:nvSpPr>
@@ -2406,6 +2658,9 @@
   <p:clrMapOvr>
     <a:masterClrMapping/>
   </p:clrMapOvr>
+  <p:transition spd="med">
+    <p:fade/>
+  </p:transition>
 </p:sld>
 </file>
 
@@ -2428,7 +2683,61 @@
       </p:grpSpPr>
       <p:sp>
         <p:nvSpPr>
-          <p:cNvPr id="2" name="Text 0"/>
+          <p:cNvPr id="2" name="Shape 0"/>
+          <p:cNvSpPr/>
+          <p:nvPr/>
+        </p:nvSpPr>
+        <p:spPr>
+          <a:xfrm>
+            <a:off x="-1645920" y="-1645920"/>
+            <a:ext cx="4206240" cy="4206240"/>
+          </a:xfrm>
+          <a:prstGeom prst="ellipse">
+            <a:avLst/>
+          </a:prstGeom>
+          <a:solidFill>
+            <a:srgbClr val="1F5F8B">
+              <a:alpha val="22000"/>
+            </a:srgbClr>
+          </a:solidFill>
+          <a:ln w="12700">
+            <a:solidFill>
+              <a:srgbClr val="1F5F8B"/>
+            </a:solidFill>
+            <a:prstDash val="solid"/>
+          </a:ln>
+        </p:spPr>
+      </p:sp>
+      <p:sp>
+        <p:nvSpPr>
+          <p:cNvPr id="3" name="Shape 1"/>
+          <p:cNvSpPr/>
+          <p:nvPr/>
+        </p:nvSpPr>
+        <p:spPr>
+          <a:xfrm>
+            <a:off x="9326880" y="4023360"/>
+            <a:ext cx="4023360" cy="4023360"/>
+          </a:xfrm>
+          <a:prstGeom prst="ellipse">
+            <a:avLst/>
+          </a:prstGeom>
+          <a:solidFill>
+            <a:srgbClr val="E03A3A">
+              <a:alpha val="16000"/>
+            </a:srgbClr>
+          </a:solidFill>
+          <a:ln w="12700">
+            <a:solidFill>
+              <a:srgbClr val="E03A3A"/>
+            </a:solidFill>
+            <a:prstDash val="solid"/>
+          </a:ln>
+        </p:spPr>
+      </p:sp>
+      <p:sp>
+        <p:nvSpPr>
+          <p:cNvPr id="4" name="Text 2"/>
           <p:cNvSpPr txBox="1"/>
           <p:nvPr/>
         </p:nvSpPr>
@@ -2467,7 +2776,7 @@
       </p:sp>
       <p:sp>
         <p:nvSpPr>
-          <p:cNvPr id="3" name="Shape 1"/>
+          <p:cNvPr id="5" name="Shape 3"/>
           <p:cNvSpPr/>
           <p:nvPr/>
         </p:nvSpPr>
@@ -2492,7 +2801,7 @@
       </p:sp>
       <p:sp>
         <p:nvSpPr>
-          <p:cNvPr id="4" name="Text 2"/>
+          <p:cNvPr id="6" name="Text 4"/>
           <p:cNvSpPr txBox="1"/>
           <p:nvPr/>
         </p:nvSpPr>
@@ -2528,7 +2837,7 @@
       </p:sp>
       <p:sp>
         <p:nvSpPr>
-          <p:cNvPr id="5" name="Text 3"/>
+          <p:cNvPr id="7" name="Text 5"/>
           <p:cNvSpPr txBox="1"/>
           <p:nvPr/>
         </p:nvSpPr>
@@ -2564,7 +2873,7 @@
       </p:sp>
       <p:sp>
         <p:nvSpPr>
-          <p:cNvPr id="6" name="Shape 4"/>
+          <p:cNvPr id="8" name="Shape 6"/>
           <p:cNvSpPr/>
           <p:nvPr/>
         </p:nvSpPr>
@@ -2589,7 +2898,7 @@
       </p:sp>
       <p:sp>
         <p:nvSpPr>
-          <p:cNvPr id="7" name="Text 5"/>
+          <p:cNvPr id="9" name="Text 7"/>
           <p:cNvSpPr txBox="1"/>
           <p:nvPr/>
         </p:nvSpPr>
@@ -2625,7 +2934,7 @@
       </p:sp>
       <p:sp>
         <p:nvSpPr>
-          <p:cNvPr id="8" name="Text 6"/>
+          <p:cNvPr id="10" name="Text 8"/>
           <p:cNvSpPr txBox="1"/>
           <p:nvPr/>
         </p:nvSpPr>
@@ -2661,7 +2970,7 @@
       </p:sp>
       <p:sp>
         <p:nvSpPr>
-          <p:cNvPr id="9" name="Shape 7"/>
+          <p:cNvPr id="11" name="Shape 9"/>
           <p:cNvSpPr/>
           <p:nvPr/>
         </p:nvSpPr>
@@ -2686,7 +2995,7 @@
       </p:sp>
       <p:sp>
         <p:nvSpPr>
-          <p:cNvPr id="10" name="Text 8"/>
+          <p:cNvPr id="12" name="Text 10"/>
           <p:cNvSpPr txBox="1"/>
           <p:nvPr/>
         </p:nvSpPr>
@@ -2722,7 +3031,7 @@
       </p:sp>
       <p:sp>
         <p:nvSpPr>
-          <p:cNvPr id="11" name="Text 9"/>
+          <p:cNvPr id="13" name="Text 11"/>
           <p:cNvSpPr txBox="1"/>
           <p:nvPr/>
         </p:nvSpPr>
@@ -2758,7 +3067,7 @@
       </p:sp>
       <p:sp>
         <p:nvSpPr>
-          <p:cNvPr id="12" name="Text 10"/>
+          <p:cNvPr id="14" name="Text 12"/>
           <p:cNvSpPr txBox="1"/>
           <p:nvPr/>
         </p:nvSpPr>
@@ -2842,6 +3151,538 @@
   <p:clrMapOvr>
     <a:masterClrMapping/>
   </p:clrMapOvr>
+  <p:transition spd="med">
+    <p:fade/>
+  </p:transition>
+</p:sld>
+</file>
+
+<file path=ppt/slides/slide11.xml><?xml version="1.0" encoding="utf-8"?>
+<p:sld xmlns:a="http://schemas.openxmlformats.org/drawingml/2006/main" xmlns:r="http://schemas.openxmlformats.org/officeDocument/2006/relationships" xmlns:p="http://schemas.openxmlformats.org/presentationml/2006/main">
+  <p:cSld name="Slide 11">
+    <p:spTree>
+      <p:nvGrpSpPr>
+        <p:cNvPr id="1" name=""/>
+        <p:cNvGrpSpPr/>
+        <p:nvPr/>
+      </p:nvGrpSpPr>
+      <p:grpSpPr>
+        <a:xfrm>
+          <a:off x="0" y="0"/>
+          <a:ext cx="0" cy="0"/>
+          <a:chOff x="0" y="0"/>
+          <a:chExt cx="0" cy="0"/>
+        </a:xfrm>
+      </p:grpSpPr>
+      <p:sp>
+        <p:nvSpPr>
+          <p:cNvPr id="2" name="Shape 0"/>
+          <p:cNvSpPr/>
+          <p:nvPr/>
+        </p:nvSpPr>
+        <p:spPr>
+          <a:xfrm>
+            <a:off x="-1645920" y="-1645920"/>
+            <a:ext cx="4206240" cy="4206240"/>
+          </a:xfrm>
+          <a:prstGeom prst="ellipse">
+            <a:avLst/>
+          </a:prstGeom>
+          <a:solidFill>
+            <a:srgbClr val="1F5F8B">
+              <a:alpha val="22000"/>
+            </a:srgbClr>
+          </a:solidFill>
+          <a:ln w="12700">
+            <a:solidFill>
+              <a:srgbClr val="1F5F8B"/>
+            </a:solidFill>
+            <a:prstDash val="solid"/>
+          </a:ln>
+        </p:spPr>
+      </p:sp>
+      <p:sp>
+        <p:nvSpPr>
+          <p:cNvPr id="3" name="Shape 1"/>
+          <p:cNvSpPr/>
+          <p:nvPr/>
+        </p:nvSpPr>
+        <p:spPr>
+          <a:xfrm>
+            <a:off x="9326880" y="4023360"/>
+            <a:ext cx="4023360" cy="4023360"/>
+          </a:xfrm>
+          <a:prstGeom prst="ellipse">
+            <a:avLst/>
+          </a:prstGeom>
+          <a:solidFill>
+            <a:srgbClr val="E03A3A">
+              <a:alpha val="16000"/>
+            </a:srgbClr>
+          </a:solidFill>
+          <a:ln w="12700">
+            <a:solidFill>
+              <a:srgbClr val="E03A3A"/>
+            </a:solidFill>
+            <a:prstDash val="solid"/>
+          </a:ln>
+        </p:spPr>
+      </p:sp>
+      <p:sp>
+        <p:nvSpPr>
+          <p:cNvPr id="4" name="Text 2"/>
+          <p:cNvSpPr txBox="1"/>
+          <p:nvPr/>
+        </p:nvSpPr>
+        <p:spPr>
+          <a:xfrm>
+            <a:off x="640080" y="1463040"/>
+            <a:ext cx="6858000" cy="1188720"/>
+          </a:xfrm>
+          <a:prstGeom prst="rect">
+            <a:avLst/>
+          </a:prstGeom>
+          <a:noFill/>
+          <a:ln/>
+        </p:spPr>
+        <p:txBody>
+          <a:bodyPr wrap="square" lIns="0" tIns="0" rIns="0" bIns="0" rtlCol="0" anchor="ctr"/>
+          <a:lstStyle/>
+          <a:p>
+            <a:pPr indent="0" marL="0">
+              <a:buNone/>
+            </a:pPr>
+            <a:r>
+              <a:rPr lang="en-US" sz="6000" b="1" dirty="0">
+                <a:solidFill>
+                  <a:schemeClr val="bg1"/>
+                </a:solidFill>
+                <a:latin typeface="Cambria" pitchFamily="34" charset="0"/>
+                <a:ea typeface="Cambria" pitchFamily="34" charset="-122"/>
+                <a:cs typeface="Cambria" pitchFamily="34" charset="-120"/>
+              </a:rPr>
+              <a:t>Questions?</a:t>
+            </a:r>
+            <a:endParaRPr lang="en-US" sz="6000" dirty="0"/>
+          </a:p>
+        </p:txBody>
+      </p:sp>
+      <p:sp>
+        <p:nvSpPr>
+          <p:cNvPr id="5" name="Text 3"/>
+          <p:cNvSpPr txBox="1"/>
+          <p:nvPr/>
+        </p:nvSpPr>
+        <p:spPr>
+          <a:xfrm>
+            <a:off x="640080" y="2834640"/>
+            <a:ext cx="6858000" cy="457200"/>
+          </a:xfrm>
+          <a:prstGeom prst="rect">
+            <a:avLst/>
+          </a:prstGeom>
+          <a:noFill/>
+          <a:ln/>
+        </p:spPr>
+        <p:txBody>
+          <a:bodyPr wrap="square" lIns="0" tIns="0" rIns="0" bIns="0" rtlCol="0" anchor="ctr"/>
+          <a:lstStyle/>
+          <a:p>
+            <a:pPr indent="0" marL="0">
+              <a:buNone/>
+            </a:pPr>
+            <a:r>
+              <a:rPr lang="en-US" sz="1800" dirty="0">
+                <a:solidFill>
+                  <a:srgbClr val="8A96A0"/>
+                </a:solidFill>
+              </a:rPr>
+              <a:t>Open the gate on your phone right now:</a:t>
+            </a:r>
+            <a:endParaRPr lang="en-US" sz="1800" dirty="0"/>
+          </a:p>
+        </p:txBody>
+      </p:sp>
+      <p:sp>
+        <p:nvSpPr>
+          <p:cNvPr id="6" name="Text 4"/>
+          <p:cNvSpPr txBox="1"/>
+          <p:nvPr/>
+        </p:nvSpPr>
+        <p:spPr>
+          <a:xfrm>
+            <a:off x="640080" y="3291840"/>
+            <a:ext cx="7040880" cy="548640"/>
+          </a:xfrm>
+          <a:prstGeom prst="rect">
+            <a:avLst/>
+          </a:prstGeom>
+          <a:noFill/>
+          <a:ln/>
+        </p:spPr>
+        <p:txBody>
+          <a:bodyPr wrap="square" lIns="0" tIns="0" rIns="0" bIns="0" rtlCol="0" anchor="ctr"/>
+          <a:lstStyle/>
+          <a:p>
+            <a:pPr indent="0" marL="0">
+              <a:buNone/>
+            </a:pPr>
+            <a:r>
+              <a:rPr lang="en-US" sz="1600" dirty="0">
+                <a:solidFill>
+                  <a:srgbClr val="F2B705"/>
+                </a:solidFill>
+                <a:latin typeface="Courier New" pitchFamily="34" charset="0"/>
+                <a:ea typeface="Courier New" pitchFamily="34" charset="-122"/>
+                <a:cs typeface="Courier New" pitchFamily="34" charset="-120"/>
+              </a:rPr>
+              <a:t>amir-kuldashev--load-safety-gate-web.modal.run</a:t>
+            </a:r>
+            <a:endParaRPr lang="en-US" sz="1600" dirty="0"/>
+          </a:p>
+        </p:txBody>
+      </p:sp>
+      <p:sp>
+        <p:nvSpPr>
+          <p:cNvPr id="7" name="Text 5"/>
+          <p:cNvSpPr txBox="1"/>
+          <p:nvPr/>
+        </p:nvSpPr>
+        <p:spPr>
+          <a:xfrm>
+            <a:off x="640080" y="3840480"/>
+            <a:ext cx="6858000" cy="457200"/>
+          </a:xfrm>
+          <a:prstGeom prst="rect">
+            <a:avLst/>
+          </a:prstGeom>
+          <a:noFill/>
+          <a:ln/>
+        </p:spPr>
+        <p:txBody>
+          <a:bodyPr wrap="square" lIns="0" tIns="0" rIns="0" bIns="0" rtlCol="0" anchor="ctr"/>
+          <a:lstStyle/>
+          <a:p>
+            <a:pPr indent="0" marL="0">
+              <a:buNone/>
+            </a:pPr>
+            <a:r>
+              <a:rPr lang="en-US" sz="1600" dirty="0">
+                <a:solidFill>
+                  <a:srgbClr val="8A96A0"/>
+                </a:solidFill>
+                <a:latin typeface="Courier New" pitchFamily="34" charset="0"/>
+                <a:ea typeface="Courier New" pitchFamily="34" charset="-122"/>
+                <a:cs typeface="Courier New" pitchFamily="34" charset="-120"/>
+              </a:rPr>
+              <a:t>github.com/Winner-121/Destroyerrrrs_Final_Stage</a:t>
+            </a:r>
+            <a:endParaRPr lang="en-US" sz="1600" dirty="0"/>
+          </a:p>
+        </p:txBody>
+      </p:sp>
+      <p:sp>
+        <p:nvSpPr>
+          <p:cNvPr id="8" name="Shape 6"/>
+          <p:cNvSpPr/>
+          <p:nvPr/>
+        </p:nvSpPr>
+        <p:spPr>
+          <a:xfrm>
+            <a:off x="640080" y="4754880"/>
+            <a:ext cx="1463040" cy="457200"/>
+          </a:xfrm>
+          <a:prstGeom prst="roundRect">
+            <a:avLst>
+              <a:gd name="adj" fmla="val 50000"/>
+            </a:avLst>
+          </a:prstGeom>
+          <a:solidFill>
+            <a:srgbClr val="2A8A4A"/>
+          </a:solidFill>
+          <a:ln w="12700">
+            <a:solidFill>
+              <a:srgbClr val="2A8A4A"/>
+            </a:solidFill>
+            <a:prstDash val="solid"/>
+          </a:ln>
+        </p:spPr>
+      </p:sp>
+      <p:sp>
+        <p:nvSpPr>
+          <p:cNvPr id="9" name="Text 7"/>
+          <p:cNvSpPr txBox="1"/>
+          <p:nvPr/>
+        </p:nvSpPr>
+        <p:spPr>
+          <a:xfrm>
+            <a:off x="640080" y="4754880"/>
+            <a:ext cx="1463040" cy="457200"/>
+          </a:xfrm>
+          <a:prstGeom prst="rect">
+            <a:avLst/>
+          </a:prstGeom>
+          <a:noFill/>
+          <a:ln/>
+        </p:spPr>
+        <p:txBody>
+          <a:bodyPr wrap="square" lIns="0" tIns="0" rIns="0" bIns="0" rtlCol="0" anchor="ctr"/>
+          <a:lstStyle/>
+          <a:p>
+            <a:pPr algn="ctr" indent="0" marL="0">
+              <a:buNone/>
+            </a:pPr>
+            <a:r>
+              <a:rPr lang="en-US" sz="1400" b="1" dirty="0">
+                <a:solidFill>
+                  <a:schemeClr val="bg1"/>
+                </a:solidFill>
+              </a:rPr>
+              <a:t>GO</a:t>
+            </a:r>
+            <a:endParaRPr lang="en-US" sz="1400" dirty="0"/>
+          </a:p>
+        </p:txBody>
+      </p:sp>
+      <p:sp>
+        <p:nvSpPr>
+          <p:cNvPr id="10" name="Shape 8"/>
+          <p:cNvSpPr/>
+          <p:nvPr/>
+        </p:nvSpPr>
+        <p:spPr>
+          <a:xfrm>
+            <a:off x="2286000" y="4754880"/>
+            <a:ext cx="1463040" cy="457200"/>
+          </a:xfrm>
+          <a:prstGeom prst="roundRect">
+            <a:avLst>
+              <a:gd name="adj" fmla="val 50000"/>
+            </a:avLst>
+          </a:prstGeom>
+          <a:solidFill>
+            <a:srgbClr val="C9781A"/>
+          </a:solidFill>
+          <a:ln w="12700">
+            <a:solidFill>
+              <a:srgbClr val="C9781A"/>
+            </a:solidFill>
+            <a:prstDash val="solid"/>
+          </a:ln>
+        </p:spPr>
+      </p:sp>
+      <p:sp>
+        <p:nvSpPr>
+          <p:cNvPr id="11" name="Text 9"/>
+          <p:cNvSpPr txBox="1"/>
+          <p:nvPr/>
+        </p:nvSpPr>
+        <p:spPr>
+          <a:xfrm>
+            <a:off x="2286000" y="4754880"/>
+            <a:ext cx="1463040" cy="457200"/>
+          </a:xfrm>
+          <a:prstGeom prst="rect">
+            <a:avLst/>
+          </a:prstGeom>
+          <a:noFill/>
+          <a:ln/>
+        </p:spPr>
+        <p:txBody>
+          <a:bodyPr wrap="square" lIns="0" tIns="0" rIns="0" bIns="0" rtlCol="0" anchor="ctr"/>
+          <a:lstStyle/>
+          <a:p>
+            <a:pPr algn="ctr" indent="0" marL="0">
+              <a:buNone/>
+            </a:pPr>
+            <a:r>
+              <a:rPr lang="en-US" sz="1400" b="1" dirty="0">
+                <a:solidFill>
+                  <a:schemeClr val="bg1"/>
+                </a:solidFill>
+              </a:rPr>
+              <a:t>WARN</a:t>
+            </a:r>
+            <a:endParaRPr lang="en-US" sz="1400" dirty="0"/>
+          </a:p>
+        </p:txBody>
+      </p:sp>
+      <p:sp>
+        <p:nvSpPr>
+          <p:cNvPr id="12" name="Shape 10"/>
+          <p:cNvSpPr/>
+          <p:nvPr/>
+        </p:nvSpPr>
+        <p:spPr>
+          <a:xfrm>
+            <a:off x="3931920" y="4754880"/>
+            <a:ext cx="1463040" cy="457200"/>
+          </a:xfrm>
+          <a:prstGeom prst="roundRect">
+            <a:avLst>
+              <a:gd name="adj" fmla="val 50000"/>
+            </a:avLst>
+          </a:prstGeom>
+          <a:solidFill>
+            <a:srgbClr val="E03A3A"/>
+          </a:solidFill>
+          <a:ln w="12700">
+            <a:solidFill>
+              <a:srgbClr val="E03A3A"/>
+            </a:solidFill>
+            <a:prstDash val="solid"/>
+          </a:ln>
+        </p:spPr>
+      </p:sp>
+      <p:sp>
+        <p:nvSpPr>
+          <p:cNvPr id="13" name="Text 11"/>
+          <p:cNvSpPr txBox="1"/>
+          <p:nvPr/>
+        </p:nvSpPr>
+        <p:spPr>
+          <a:xfrm>
+            <a:off x="3931920" y="4754880"/>
+            <a:ext cx="1463040" cy="457200"/>
+          </a:xfrm>
+          <a:prstGeom prst="rect">
+            <a:avLst/>
+          </a:prstGeom>
+          <a:noFill/>
+          <a:ln/>
+        </p:spPr>
+        <p:txBody>
+          <a:bodyPr wrap="square" lIns="0" tIns="0" rIns="0" bIns="0" rtlCol="0" anchor="ctr"/>
+          <a:lstStyle/>
+          <a:p>
+            <a:pPr algn="ctr" indent="0" marL="0">
+              <a:buNone/>
+            </a:pPr>
+            <a:r>
+              <a:rPr lang="en-US" sz="1400" b="1" dirty="0">
+                <a:solidFill>
+                  <a:schemeClr val="bg1"/>
+                </a:solidFill>
+              </a:rPr>
+              <a:t>NO-GO</a:t>
+            </a:r>
+            <a:endParaRPr lang="en-US" sz="1400" dirty="0"/>
+          </a:p>
+        </p:txBody>
+      </p:sp>
+      <p:pic>
+        <p:nvPicPr>
+          <p:cNvPr id="14" name="Image 0" descr="dancing_cat.gif">    </p:cNvPr>
+          <p:cNvPicPr>
+            <a:picLocks noChangeAspect="1"/>
+          </p:cNvPicPr>
+          <p:nvPr/>
+        </p:nvPicPr>
+        <p:blipFill>
+          <a:blip r:embed="rId1"/>
+          <a:stretch>
+            <a:fillRect/>
+          </a:stretch>
+        </p:blipFill>
+        <p:spPr>
+          <a:xfrm>
+            <a:off x="7772400" y="1280160"/>
+            <a:ext cx="4023360" cy="4023360"/>
+          </a:xfrm>
+          <a:prstGeom prst="rect">
+            <a:avLst/>
+          </a:prstGeom>
+        </p:spPr>
+      </p:pic>
+      <p:sp>
+        <p:nvSpPr>
+          <p:cNvPr id="15" name="Text 12"/>
+          <p:cNvSpPr txBox="1"/>
+          <p:nvPr/>
+        </p:nvSpPr>
+        <p:spPr>
+          <a:xfrm>
+            <a:off x="7772400" y="5394960"/>
+            <a:ext cx="4023360" cy="365760"/>
+          </a:xfrm>
+          <a:prstGeom prst="rect">
+            <a:avLst/>
+          </a:prstGeom>
+          <a:noFill/>
+          <a:ln/>
+        </p:spPr>
+        <p:txBody>
+          <a:bodyPr wrap="square" lIns="0" tIns="0" rIns="0" bIns="0" rtlCol="0" anchor="ctr"/>
+          <a:lstStyle/>
+          <a:p>
+            <a:pPr algn="ctr" indent="0" marL="0">
+              <a:buNone/>
+            </a:pPr>
+            <a:r>
+              <a:rPr lang="en-US" sz="1400" dirty="0">
+                <a:solidFill>
+                  <a:srgbClr val="8A96A0"/>
+                </a:solidFill>
+              </a:rPr>
+              <a:t>Team Destroyerrrrs, thank you</a:t>
+            </a:r>
+            <a:endParaRPr lang="en-US" sz="1400" dirty="0"/>
+          </a:p>
+        </p:txBody>
+      </p:sp>
+      <p:sp>
+        <p:nvSpPr>
+          <p:cNvPr id="25" name="Slide Number Placeholder 0"/>
+          <p:cNvSpPr>
+            <a:spLocks noGrp="1"/>
+          </p:cNvSpPr>
+          <p:nvPr>
+            <p:ph type="sldNum" sz="quarter" idx="4294967295"/>
+          </p:nvPr>
+        </p:nvSpPr>
+        <p:spPr>
+          <a:xfrm>
+            <a:off x="11247120" y="6446520"/>
+            <a:ext cx="548640" cy="274320"/>
+          </a:xfrm>
+          <a:prstGeom prst="rect">
+            <a:avLst/>
+          </a:prstGeom>
+          <a:extLst>
+            <a:ext uri="{C572A759-6A51-4108-AA02-DFA0A04FC94B}">
+              <ma14:wrappingTextBoxFlag xmlns:ma14="http://schemas.microsoft.com/office/mac/drawingml/2011/main" val="0"/>
+            </a:ext>
+          </a:extLst>
+        </p:spPr>
+        <p:txBody>
+          <a:bodyPr/>
+          <a:lstStyle>
+            <a:lvl1pPr>
+              <a:defRPr sz="1000">
+                <a:solidFill>
+                  <a:srgbClr val="8A96A0"/>
+                </a:solidFill>
+              </a:defRPr>
+            </a:lvl1pPr>
+          </a:lstStyle>
+          <a:p>
+            <a:pPr algn="l"/>
+            <a:fld id="{F7021451-1387-4CA6-816F-3879F97B5CBC}" type="slidenum">
+              <a:rPr b="0" lang="en-US"/>
+              <a:t>11</a:t>
+            </a:fld>
+            <a:endParaRPr lang="en-US"/>
+          </a:p>
+        </p:txBody>
+      </p:sp>
+    </p:spTree>
+  </p:cSld>
+  <p:clrMapOvr>
+    <a:masterClrMapping/>
+  </p:clrMapOvr>
+  <p:transition spd="med">
+    <p:fade/>
+  </p:transition>
 </p:sld>
 </file>
 
@@ -2864,7 +3705,55 @@
       </p:grpSpPr>
       <p:sp>
         <p:nvSpPr>
-          <p:cNvPr id="2" name="Text 0"/>
+          <p:cNvPr id="2" name="Shape 0"/>
+          <p:cNvSpPr/>
+          <p:nvPr/>
+        </p:nvSpPr>
+        <p:spPr>
+          <a:xfrm>
+            <a:off x="457200" y="411480"/>
+            <a:ext cx="109728" cy="548640"/>
+          </a:xfrm>
+          <a:prstGeom prst="rect">
+            <a:avLst/>
+          </a:prstGeom>
+          <a:solidFill>
+            <a:srgbClr val="E03A3A"/>
+          </a:solidFill>
+          <a:ln w="12700">
+            <a:solidFill>
+              <a:srgbClr val="E03A3A"/>
+            </a:solidFill>
+            <a:prstDash val="solid"/>
+          </a:ln>
+        </p:spPr>
+      </p:sp>
+      <p:sp>
+        <p:nvSpPr>
+          <p:cNvPr id="3" name="Shape 1"/>
+          <p:cNvSpPr/>
+          <p:nvPr/>
+        </p:nvSpPr>
+        <p:spPr>
+          <a:xfrm>
+            <a:off x="457200" y="1143000"/>
+            <a:ext cx="11247120" cy="0"/>
+          </a:xfrm>
+          <a:prstGeom prst="line">
+            <a:avLst/>
+          </a:prstGeom>
+          <a:noFill/>
+          <a:ln w="19050">
+            <a:solidFill>
+              <a:srgbClr val="EEF0EC"/>
+            </a:solidFill>
+            <a:prstDash val="solid"/>
+          </a:ln>
+        </p:spPr>
+      </p:sp>
+      <p:sp>
+        <p:nvSpPr>
+          <p:cNvPr id="4" name="Text 0"/>
           <p:cNvSpPr/>
           <p:nvPr>
             <p:ph idx="100" type="title" hasCustomPrompt="1"/>
@@ -2872,8 +3761,8 @@
         </p:nvSpPr>
         <p:spPr>
           <a:xfrm>
-            <a:off x="457200" y="320040"/>
-            <a:ext cx="11247120" cy="731520"/>
+            <a:off x="685800" y="320040"/>
+            <a:ext cx="11018520" cy="731520"/>
           </a:xfrm>
           <a:prstGeom prst="rect">
             <a:avLst/>
@@ -2902,7 +3791,7 @@
       </p:sp>
       <p:sp>
         <p:nvSpPr>
-          <p:cNvPr id="3" name="Shape 1"/>
+          <p:cNvPr id="5" name="Shape 3"/>
           <p:cNvSpPr/>
           <p:nvPr/>
         </p:nvSpPr>
@@ -2911,8 +3800,10 @@
             <a:off x="457200" y="1188720"/>
             <a:ext cx="5486400" cy="1188720"/>
           </a:xfrm>
-          <a:prstGeom prst="rect">
-            <a:avLst/>
+          <a:prstGeom prst="roundRect">
+            <a:avLst>
+              <a:gd name="adj" fmla="val 9231"/>
+            </a:avLst>
           </a:prstGeom>
           <a:solidFill>
             <a:srgbClr val="EEF0EC"/>
@@ -2923,20 +3814,27 @@
             </a:solidFill>
             <a:prstDash val="solid"/>
           </a:ln>
-        </p:spPr>
-      </p:sp>
-      <p:sp>
-        <p:nvSpPr>
-          <p:cNvPr id="4" name="Shape 2"/>
+          <a:effectLst>
+            <a:outerShdw sx="100000" sy="100000" kx="0" ky="0" algn="bl" rotWithShape="0" blurRad="76200" dist="25400" dir="3600000">
+              <a:srgbClr val="000000">
+                <a:alpha val="18000"/>
+              </a:srgbClr>
+            </a:outerShdw>
+          </a:effectLst>
+        </p:spPr>
+      </p:sp>
+      <p:sp>
+        <p:nvSpPr>
+          <p:cNvPr id="6" name="Shape 4"/>
           <p:cNvSpPr/>
           <p:nvPr/>
         </p:nvSpPr>
         <p:spPr>
           <a:xfrm>
-            <a:off x="640080" y="1371600"/>
-            <a:ext cx="384048" cy="384048"/>
-          </a:xfrm>
-          <a:prstGeom prst="ellipse">
+            <a:off x="457200" y="1417320"/>
+            <a:ext cx="64008" cy="731520"/>
+          </a:xfrm>
+          <a:prstGeom prst="rect">
             <a:avLst/>
           </a:prstGeom>
           <a:solidFill>
@@ -2952,7 +3850,32 @@
       </p:sp>
       <p:sp>
         <p:nvSpPr>
-          <p:cNvPr id="5" name="Text 3"/>
+          <p:cNvPr id="7" name="Shape 5"/>
+          <p:cNvSpPr/>
+          <p:nvPr/>
+        </p:nvSpPr>
+        <p:spPr>
+          <a:xfrm>
+            <a:off x="640080" y="1371600"/>
+            <a:ext cx="384048" cy="384048"/>
+          </a:xfrm>
+          <a:prstGeom prst="ellipse">
+            <a:avLst/>
+          </a:prstGeom>
+          <a:solidFill>
+            <a:srgbClr val="1F5F8B"/>
+          </a:solidFill>
+          <a:ln w="12700">
+            <a:solidFill>
+              <a:srgbClr val="1F5F8B"/>
+            </a:solidFill>
+            <a:prstDash val="solid"/>
+          </a:ln>
+        </p:spPr>
+      </p:sp>
+      <p:sp>
+        <p:nvSpPr>
+          <p:cNvPr id="8" name="Text 6"/>
           <p:cNvSpPr txBox="1"/>
           <p:nvPr/>
         </p:nvSpPr>
@@ -2988,7 +3911,7 @@
       </p:sp>
       <p:sp>
         <p:nvSpPr>
-          <p:cNvPr id="6" name="Text 4"/>
+          <p:cNvPr id="9" name="Text 7"/>
           <p:cNvSpPr txBox="1"/>
           <p:nvPr/>
         </p:nvSpPr>
@@ -3024,7 +3947,7 @@
       </p:sp>
       <p:sp>
         <p:nvSpPr>
-          <p:cNvPr id="7" name="Shape 5"/>
+          <p:cNvPr id="10" name="Shape 8"/>
           <p:cNvSpPr/>
           <p:nvPr/>
         </p:nvSpPr>
@@ -3033,8 +3956,10 @@
             <a:off x="457200" y="2487168"/>
             <a:ext cx="5486400" cy="1188720"/>
           </a:xfrm>
-          <a:prstGeom prst="rect">
-            <a:avLst/>
+          <a:prstGeom prst="roundRect">
+            <a:avLst>
+              <a:gd name="adj" fmla="val 9231"/>
+            </a:avLst>
           </a:prstGeom>
           <a:solidFill>
             <a:srgbClr val="EEF0EC"/>
@@ -3045,20 +3970,27 @@
             </a:solidFill>
             <a:prstDash val="solid"/>
           </a:ln>
-        </p:spPr>
-      </p:sp>
-      <p:sp>
-        <p:nvSpPr>
-          <p:cNvPr id="8" name="Shape 6"/>
+          <a:effectLst>
+            <a:outerShdw sx="100000" sy="100000" kx="0" ky="0" algn="bl" rotWithShape="0" blurRad="967740000" dist="322580000" dir="216000000000">
+              <a:srgbClr val="000000">
+                <a:alpha val="1800000000"/>
+              </a:srgbClr>
+            </a:outerShdw>
+          </a:effectLst>
+        </p:spPr>
+      </p:sp>
+      <p:sp>
+        <p:nvSpPr>
+          <p:cNvPr id="11" name="Shape 9"/>
           <p:cNvSpPr/>
           <p:nvPr/>
         </p:nvSpPr>
         <p:spPr>
           <a:xfrm>
-            <a:off x="640080" y="2670048"/>
-            <a:ext cx="384048" cy="384048"/>
-          </a:xfrm>
-          <a:prstGeom prst="ellipse">
+            <a:off x="457200" y="2715768"/>
+            <a:ext cx="64008" cy="731520"/>
+          </a:xfrm>
+          <a:prstGeom prst="rect">
             <a:avLst/>
           </a:prstGeom>
           <a:solidFill>
@@ -3074,7 +4006,32 @@
       </p:sp>
       <p:sp>
         <p:nvSpPr>
-          <p:cNvPr id="9" name="Text 7"/>
+          <p:cNvPr id="12" name="Shape 10"/>
+          <p:cNvSpPr/>
+          <p:nvPr/>
+        </p:nvSpPr>
+        <p:spPr>
+          <a:xfrm>
+            <a:off x="640080" y="2670048"/>
+            <a:ext cx="384048" cy="384048"/>
+          </a:xfrm>
+          <a:prstGeom prst="ellipse">
+            <a:avLst/>
+          </a:prstGeom>
+          <a:solidFill>
+            <a:srgbClr val="E03A3A"/>
+          </a:solidFill>
+          <a:ln w="12700">
+            <a:solidFill>
+              <a:srgbClr val="E03A3A"/>
+            </a:solidFill>
+            <a:prstDash val="solid"/>
+          </a:ln>
+        </p:spPr>
+      </p:sp>
+      <p:sp>
+        <p:nvSpPr>
+          <p:cNvPr id="13" name="Text 11"/>
           <p:cNvSpPr txBox="1"/>
           <p:nvPr/>
         </p:nvSpPr>
@@ -3110,7 +4067,7 @@
       </p:sp>
       <p:sp>
         <p:nvSpPr>
-          <p:cNvPr id="10" name="Text 8"/>
+          <p:cNvPr id="14" name="Text 12"/>
           <p:cNvSpPr txBox="1"/>
           <p:nvPr/>
         </p:nvSpPr>
@@ -3146,7 +4103,7 @@
       </p:sp>
       <p:sp>
         <p:nvSpPr>
-          <p:cNvPr id="11" name="Shape 9"/>
+          <p:cNvPr id="15" name="Shape 13"/>
           <p:cNvSpPr/>
           <p:nvPr/>
         </p:nvSpPr>
@@ -3155,8 +4112,10 @@
             <a:off x="457200" y="3785616"/>
             <a:ext cx="5486400" cy="1188720"/>
           </a:xfrm>
-          <a:prstGeom prst="rect">
-            <a:avLst/>
+          <a:prstGeom prst="roundRect">
+            <a:avLst>
+              <a:gd name="adj" fmla="val 9231"/>
+            </a:avLst>
           </a:prstGeom>
           <a:solidFill>
             <a:srgbClr val="EEF0EC"/>
@@ -3167,20 +4126,27 @@
             </a:solidFill>
             <a:prstDash val="solid"/>
           </a:ln>
-        </p:spPr>
-      </p:sp>
-      <p:sp>
-        <p:nvSpPr>
-          <p:cNvPr id="12" name="Shape 10"/>
+          <a:effectLst>
+            <a:outerShdw sx="100000" sy="100000" kx="0" ky="0" algn="bl" rotWithShape="0" blurRad="12290298000000" dist="4096766000000" dir="12960000000000000">
+              <a:srgbClr val="000000">
+                <a:alpha val="180000000000000"/>
+              </a:srgbClr>
+            </a:outerShdw>
+          </a:effectLst>
+        </p:spPr>
+      </p:sp>
+      <p:sp>
+        <p:nvSpPr>
+          <p:cNvPr id="16" name="Shape 14"/>
           <p:cNvSpPr/>
           <p:nvPr/>
         </p:nvSpPr>
         <p:spPr>
           <a:xfrm>
-            <a:off x="640080" y="3968496"/>
-            <a:ext cx="384048" cy="384048"/>
-          </a:xfrm>
-          <a:prstGeom prst="ellipse">
+            <a:off x="457200" y="4014216"/>
+            <a:ext cx="64008" cy="731520"/>
+          </a:xfrm>
+          <a:prstGeom prst="rect">
             <a:avLst/>
           </a:prstGeom>
           <a:solidFill>
@@ -3196,7 +4162,32 @@
       </p:sp>
       <p:sp>
         <p:nvSpPr>
-          <p:cNvPr id="13" name="Text 11"/>
+          <p:cNvPr id="17" name="Shape 15"/>
+          <p:cNvSpPr/>
+          <p:nvPr/>
+        </p:nvSpPr>
+        <p:spPr>
+          <a:xfrm>
+            <a:off x="640080" y="3968496"/>
+            <a:ext cx="384048" cy="384048"/>
+          </a:xfrm>
+          <a:prstGeom prst="ellipse">
+            <a:avLst/>
+          </a:prstGeom>
+          <a:solidFill>
+            <a:srgbClr val="2A8A4A"/>
+          </a:solidFill>
+          <a:ln w="12700">
+            <a:solidFill>
+              <a:srgbClr val="2A8A4A"/>
+            </a:solidFill>
+            <a:prstDash val="solid"/>
+          </a:ln>
+        </p:spPr>
+      </p:sp>
+      <p:sp>
+        <p:nvSpPr>
+          <p:cNvPr id="18" name="Text 16"/>
           <p:cNvSpPr txBox="1"/>
           <p:nvPr/>
         </p:nvSpPr>
@@ -3232,7 +4223,7 @@
       </p:sp>
       <p:sp>
         <p:nvSpPr>
-          <p:cNvPr id="14" name="Text 12"/>
+          <p:cNvPr id="19" name="Text 17"/>
           <p:cNvSpPr txBox="1"/>
           <p:nvPr/>
         </p:nvSpPr>
@@ -3268,7 +4259,7 @@
       </p:sp>
       <p:sp>
         <p:nvSpPr>
-          <p:cNvPr id="15" name="Shape 13"/>
+          <p:cNvPr id="20" name="Shape 18"/>
           <p:cNvSpPr/>
           <p:nvPr/>
         </p:nvSpPr>
@@ -3277,8 +4268,10 @@
             <a:off x="457200" y="5084064"/>
             <a:ext cx="5486400" cy="1188720"/>
           </a:xfrm>
-          <a:prstGeom prst="rect">
-            <a:avLst/>
+          <a:prstGeom prst="roundRect">
+            <a:avLst>
+              <a:gd name="adj" fmla="val 9231"/>
+            </a:avLst>
           </a:prstGeom>
           <a:solidFill>
             <a:srgbClr val="EEF0EC"/>
@@ -3289,20 +4282,27 @@
             </a:solidFill>
             <a:prstDash val="solid"/>
           </a:ln>
-        </p:spPr>
-      </p:sp>
-      <p:sp>
-        <p:nvSpPr>
-          <p:cNvPr id="16" name="Shape 14"/>
+          <a:effectLst>
+            <a:outerShdw sx="100000" sy="100000" kx="0" ky="0" algn="bl" rotWithShape="0" blurRad="156086784600000000" dist="52028928200000000" dir="777600000000000000000">
+              <a:srgbClr val="000000">
+                <a:alpha val="18000000000000000000"/>
+              </a:srgbClr>
+            </a:outerShdw>
+          </a:effectLst>
+        </p:spPr>
+      </p:sp>
+      <p:sp>
+        <p:nvSpPr>
+          <p:cNvPr id="21" name="Shape 19"/>
           <p:cNvSpPr/>
           <p:nvPr/>
         </p:nvSpPr>
         <p:spPr>
           <a:xfrm>
-            <a:off x="640080" y="5266944"/>
-            <a:ext cx="384048" cy="384048"/>
-          </a:xfrm>
-          <a:prstGeom prst="ellipse">
+            <a:off x="457200" y="5312664"/>
+            <a:ext cx="64008" cy="731520"/>
+          </a:xfrm>
+          <a:prstGeom prst="rect">
             <a:avLst/>
           </a:prstGeom>
           <a:solidFill>
@@ -3318,7 +4318,32 @@
       </p:sp>
       <p:sp>
         <p:nvSpPr>
-          <p:cNvPr id="17" name="Text 15"/>
+          <p:cNvPr id="22" name="Shape 20"/>
+          <p:cNvSpPr/>
+          <p:nvPr/>
+        </p:nvSpPr>
+        <p:spPr>
+          <a:xfrm>
+            <a:off x="640080" y="5266944"/>
+            <a:ext cx="384048" cy="384048"/>
+          </a:xfrm>
+          <a:prstGeom prst="ellipse">
+            <a:avLst/>
+          </a:prstGeom>
+          <a:solidFill>
+            <a:srgbClr val="F2B705"/>
+          </a:solidFill>
+          <a:ln w="12700">
+            <a:solidFill>
+              <a:srgbClr val="F2B705"/>
+            </a:solidFill>
+            <a:prstDash val="solid"/>
+          </a:ln>
+        </p:spPr>
+      </p:sp>
+      <p:sp>
+        <p:nvSpPr>
+          <p:cNvPr id="23" name="Text 21"/>
           <p:cNvSpPr txBox="1"/>
           <p:nvPr/>
         </p:nvSpPr>
@@ -3354,7 +4379,7 @@
       </p:sp>
       <p:sp>
         <p:nvSpPr>
-          <p:cNvPr id="18" name="Text 16"/>
+          <p:cNvPr id="24" name="Text 22"/>
           <p:cNvSpPr txBox="1"/>
           <p:nvPr/>
         </p:nvSpPr>
@@ -3390,7 +4415,7 @@
       </p:sp>
       <p:pic>
         <p:nvPicPr>
-          <p:cNvPr id="19" name="Image 0" descr="../eval/out/raw/car_carrier/car_carrier_1967_79_Saviem_SG2_fl_jpg.jpg">    </p:cNvPr>
+          <p:cNvPr id="25" name="Image 0" descr="../eval/out/raw/car_carrier/car_carrier_1967_79_Saviem_SG2_fl_jpg.jpg">    </p:cNvPr>
           <p:cNvPicPr>
             <a:picLocks noChangeAspect="1"/>
           </p:cNvPicPr>
@@ -3413,7 +4438,7 @@
       </p:pic>
       <p:sp>
         <p:nvSpPr>
-          <p:cNvPr id="20" name="Text 17"/>
+          <p:cNvPr id="26" name="Text 23"/>
           <p:cNvSpPr txBox="1"/>
           <p:nvPr/>
         </p:nvSpPr>
@@ -3497,6 +4522,9 @@
   <p:clrMapOvr>
     <a:masterClrMapping/>
   </p:clrMapOvr>
+  <p:transition spd="med">
+    <p:fade/>
+  </p:transition>
 </p:sld>
 </file>
 
@@ -3519,7 +4547,61 @@
       </p:grpSpPr>
       <p:sp>
         <p:nvSpPr>
-          <p:cNvPr id="2" name="Text 0"/>
+          <p:cNvPr id="2" name="Shape 0"/>
+          <p:cNvSpPr/>
+          <p:nvPr/>
+        </p:nvSpPr>
+        <p:spPr>
+          <a:xfrm>
+            <a:off x="-1645920" y="-1645920"/>
+            <a:ext cx="4206240" cy="4206240"/>
+          </a:xfrm>
+          <a:prstGeom prst="ellipse">
+            <a:avLst/>
+          </a:prstGeom>
+          <a:solidFill>
+            <a:srgbClr val="1F5F8B">
+              <a:alpha val="22000"/>
+            </a:srgbClr>
+          </a:solidFill>
+          <a:ln w="12700">
+            <a:solidFill>
+              <a:srgbClr val="1F5F8B"/>
+            </a:solidFill>
+            <a:prstDash val="solid"/>
+          </a:ln>
+        </p:spPr>
+      </p:sp>
+      <p:sp>
+        <p:nvSpPr>
+          <p:cNvPr id="3" name="Shape 1"/>
+          <p:cNvSpPr/>
+          <p:nvPr/>
+        </p:nvSpPr>
+        <p:spPr>
+          <a:xfrm>
+            <a:off x="9326880" y="4023360"/>
+            <a:ext cx="4023360" cy="4023360"/>
+          </a:xfrm>
+          <a:prstGeom prst="ellipse">
+            <a:avLst/>
+          </a:prstGeom>
+          <a:solidFill>
+            <a:srgbClr val="E03A3A">
+              <a:alpha val="16000"/>
+            </a:srgbClr>
+          </a:solidFill>
+          <a:ln w="12700">
+            <a:solidFill>
+              <a:srgbClr val="E03A3A"/>
+            </a:solidFill>
+            <a:prstDash val="solid"/>
+          </a:ln>
+        </p:spPr>
+      </p:sp>
+      <p:sp>
+        <p:nvSpPr>
+          <p:cNvPr id="4" name="Text 2"/>
           <p:cNvSpPr txBox="1"/>
           <p:nvPr/>
         </p:nvSpPr>
@@ -3558,7 +4640,7 @@
       </p:sp>
       <p:sp>
         <p:nvSpPr>
-          <p:cNvPr id="3" name="Text 1"/>
+          <p:cNvPr id="5" name="Text 3"/>
           <p:cNvSpPr txBox="1"/>
           <p:nvPr/>
         </p:nvSpPr>
@@ -3597,7 +4679,7 @@
       </p:sp>
       <p:sp>
         <p:nvSpPr>
-          <p:cNvPr id="4" name="Text 2"/>
+          <p:cNvPr id="6" name="Text 4"/>
           <p:cNvSpPr txBox="1"/>
           <p:nvPr/>
         </p:nvSpPr>
@@ -3633,7 +4715,7 @@
       </p:sp>
       <p:sp>
         <p:nvSpPr>
-          <p:cNvPr id="5" name="Text 3"/>
+          <p:cNvPr id="7" name="Text 5"/>
           <p:cNvSpPr txBox="1"/>
           <p:nvPr/>
         </p:nvSpPr>
@@ -3763,7 +4845,7 @@
       </p:sp>
       <p:pic>
         <p:nvPicPr>
-          <p:cNvPr id="6" name="Image 0" descr="../eval/out/dbg_9.jpg">    </p:cNvPr>
+          <p:cNvPr id="8" name="Image 0" descr="../eval/out/dbg_9.jpg">    </p:cNvPr>
           <p:cNvPicPr>
             <a:picLocks noChangeAspect="1"/>
           </p:cNvPicPr>
@@ -3834,6 +4916,9 @@
   <p:clrMapOvr>
     <a:masterClrMapping/>
   </p:clrMapOvr>
+  <p:transition spd="med">
+    <p:fade/>
+  </p:transition>
 </p:sld>
 </file>
 
@@ -3856,7 +4941,55 @@
       </p:grpSpPr>
       <p:sp>
         <p:nvSpPr>
-          <p:cNvPr id="2" name="Text 0"/>
+          <p:cNvPr id="2" name="Shape 0"/>
+          <p:cNvSpPr/>
+          <p:nvPr/>
+        </p:nvSpPr>
+        <p:spPr>
+          <a:xfrm>
+            <a:off x="457200" y="411480"/>
+            <a:ext cx="109728" cy="548640"/>
+          </a:xfrm>
+          <a:prstGeom prst="rect">
+            <a:avLst/>
+          </a:prstGeom>
+          <a:solidFill>
+            <a:srgbClr val="1F5F8B"/>
+          </a:solidFill>
+          <a:ln w="12700">
+            <a:solidFill>
+              <a:srgbClr val="1F5F8B"/>
+            </a:solidFill>
+            <a:prstDash val="solid"/>
+          </a:ln>
+        </p:spPr>
+      </p:sp>
+      <p:sp>
+        <p:nvSpPr>
+          <p:cNvPr id="3" name="Shape 1"/>
+          <p:cNvSpPr/>
+          <p:nvPr/>
+        </p:nvSpPr>
+        <p:spPr>
+          <a:xfrm>
+            <a:off x="457200" y="1143000"/>
+            <a:ext cx="11247120" cy="0"/>
+          </a:xfrm>
+          <a:prstGeom prst="line">
+            <a:avLst/>
+          </a:prstGeom>
+          <a:noFill/>
+          <a:ln w="19050">
+            <a:solidFill>
+              <a:srgbClr val="EEF0EC"/>
+            </a:solidFill>
+            <a:prstDash val="solid"/>
+          </a:ln>
+        </p:spPr>
+      </p:sp>
+      <p:sp>
+        <p:nvSpPr>
+          <p:cNvPr id="4" name="Text 0"/>
           <p:cNvSpPr/>
           <p:nvPr>
             <p:ph idx="100" type="title" hasCustomPrompt="1"/>
@@ -3864,8 +4997,8 @@
         </p:nvSpPr>
         <p:spPr>
           <a:xfrm>
-            <a:off x="457200" y="320040"/>
-            <a:ext cx="11247120" cy="731520"/>
+            <a:off x="685800" y="320040"/>
+            <a:ext cx="11018520" cy="731520"/>
           </a:xfrm>
           <a:prstGeom prst="rect">
             <a:avLst/>
@@ -3894,7 +5027,7 @@
       </p:sp>
       <p:sp>
         <p:nvSpPr>
-          <p:cNvPr id="3" name="Shape 1"/>
+          <p:cNvPr id="5" name="Shape 3"/>
           <p:cNvSpPr/>
           <p:nvPr/>
         </p:nvSpPr>
@@ -3919,7 +5052,7 @@
       </p:sp>
       <p:sp>
         <p:nvSpPr>
-          <p:cNvPr id="4" name="Shape 2"/>
+          <p:cNvPr id="6" name="Shape 4"/>
           <p:cNvSpPr/>
           <p:nvPr/>
         </p:nvSpPr>
@@ -3944,7 +5077,7 @@
       </p:sp>
       <p:sp>
         <p:nvSpPr>
-          <p:cNvPr id="5" name="Text 3"/>
+          <p:cNvPr id="7" name="Text 5"/>
           <p:cNvSpPr txBox="1"/>
           <p:nvPr/>
         </p:nvSpPr>
@@ -3980,7 +5113,7 @@
       </p:sp>
       <p:sp>
         <p:nvSpPr>
-          <p:cNvPr id="6" name="Text 4"/>
+          <p:cNvPr id="8" name="Text 6"/>
           <p:cNvSpPr txBox="1"/>
           <p:nvPr/>
         </p:nvSpPr>
@@ -4016,7 +5149,7 @@
       </p:sp>
       <p:sp>
         <p:nvSpPr>
-          <p:cNvPr id="7" name="Text 5"/>
+          <p:cNvPr id="9" name="Text 7"/>
           <p:cNvSpPr txBox="1"/>
           <p:nvPr/>
         </p:nvSpPr>
@@ -4052,7 +5185,7 @@
       </p:sp>
       <p:sp>
         <p:nvSpPr>
-          <p:cNvPr id="8" name="Shape 6"/>
+          <p:cNvPr id="10" name="Shape 8"/>
           <p:cNvSpPr/>
           <p:nvPr/>
         </p:nvSpPr>
@@ -4077,7 +5210,7 @@
       </p:sp>
       <p:sp>
         <p:nvSpPr>
-          <p:cNvPr id="9" name="Shape 7"/>
+          <p:cNvPr id="11" name="Shape 9"/>
           <p:cNvSpPr/>
           <p:nvPr/>
         </p:nvSpPr>
@@ -4102,7 +5235,7 @@
       </p:sp>
       <p:sp>
         <p:nvSpPr>
-          <p:cNvPr id="10" name="Shape 8"/>
+          <p:cNvPr id="12" name="Shape 10"/>
           <p:cNvSpPr/>
           <p:nvPr/>
         </p:nvSpPr>
@@ -4127,7 +5260,7 @@
       </p:sp>
       <p:sp>
         <p:nvSpPr>
-          <p:cNvPr id="11" name="Text 9"/>
+          <p:cNvPr id="13" name="Text 11"/>
           <p:cNvSpPr txBox="1"/>
           <p:nvPr/>
         </p:nvSpPr>
@@ -4163,7 +5296,7 @@
       </p:sp>
       <p:sp>
         <p:nvSpPr>
-          <p:cNvPr id="12" name="Text 10"/>
+          <p:cNvPr id="14" name="Text 12"/>
           <p:cNvSpPr txBox="1"/>
           <p:nvPr/>
         </p:nvSpPr>
@@ -4199,7 +5332,7 @@
       </p:sp>
       <p:sp>
         <p:nvSpPr>
-          <p:cNvPr id="13" name="Text 11"/>
+          <p:cNvPr id="15" name="Text 13"/>
           <p:cNvSpPr txBox="1"/>
           <p:nvPr/>
         </p:nvSpPr>
@@ -4235,7 +5368,7 @@
       </p:sp>
       <p:sp>
         <p:nvSpPr>
-          <p:cNvPr id="14" name="Shape 12"/>
+          <p:cNvPr id="16" name="Shape 14"/>
           <p:cNvSpPr/>
           <p:nvPr/>
         </p:nvSpPr>
@@ -4260,7 +5393,7 @@
       </p:sp>
       <p:sp>
         <p:nvSpPr>
-          <p:cNvPr id="15" name="Shape 13"/>
+          <p:cNvPr id="17" name="Shape 15"/>
           <p:cNvSpPr/>
           <p:nvPr/>
         </p:nvSpPr>
@@ -4285,7 +5418,7 @@
       </p:sp>
       <p:sp>
         <p:nvSpPr>
-          <p:cNvPr id="16" name="Shape 14"/>
+          <p:cNvPr id="18" name="Shape 16"/>
           <p:cNvSpPr/>
           <p:nvPr/>
         </p:nvSpPr>
@@ -4310,7 +5443,7 @@
       </p:sp>
       <p:sp>
         <p:nvSpPr>
-          <p:cNvPr id="17" name="Text 15"/>
+          <p:cNvPr id="19" name="Text 17"/>
           <p:cNvSpPr txBox="1"/>
           <p:nvPr/>
         </p:nvSpPr>
@@ -4346,7 +5479,7 @@
       </p:sp>
       <p:sp>
         <p:nvSpPr>
-          <p:cNvPr id="18" name="Text 16"/>
+          <p:cNvPr id="20" name="Text 18"/>
           <p:cNvSpPr txBox="1"/>
           <p:nvPr/>
         </p:nvSpPr>
@@ -4382,7 +5515,7 @@
       </p:sp>
       <p:sp>
         <p:nvSpPr>
-          <p:cNvPr id="19" name="Text 17"/>
+          <p:cNvPr id="21" name="Text 19"/>
           <p:cNvSpPr txBox="1"/>
           <p:nvPr/>
         </p:nvSpPr>
@@ -4418,7 +5551,7 @@
       </p:sp>
       <p:sp>
         <p:nvSpPr>
-          <p:cNvPr id="20" name="Shape 18"/>
+          <p:cNvPr id="22" name="Shape 20"/>
           <p:cNvSpPr/>
           <p:nvPr/>
         </p:nvSpPr>
@@ -4443,7 +5576,7 @@
       </p:sp>
       <p:sp>
         <p:nvSpPr>
-          <p:cNvPr id="21" name="Shape 19"/>
+          <p:cNvPr id="23" name="Shape 21"/>
           <p:cNvSpPr/>
           <p:nvPr/>
         </p:nvSpPr>
@@ -4468,7 +5601,7 @@
       </p:sp>
       <p:sp>
         <p:nvSpPr>
-          <p:cNvPr id="22" name="Shape 20"/>
+          <p:cNvPr id="24" name="Shape 22"/>
           <p:cNvSpPr/>
           <p:nvPr/>
         </p:nvSpPr>
@@ -4493,7 +5626,7 @@
       </p:sp>
       <p:sp>
         <p:nvSpPr>
-          <p:cNvPr id="23" name="Text 21"/>
+          <p:cNvPr id="25" name="Text 23"/>
           <p:cNvSpPr txBox="1"/>
           <p:nvPr/>
         </p:nvSpPr>
@@ -4529,7 +5662,7 @@
       </p:sp>
       <p:sp>
         <p:nvSpPr>
-          <p:cNvPr id="24" name="Text 22"/>
+          <p:cNvPr id="26" name="Text 24"/>
           <p:cNvSpPr txBox="1"/>
           <p:nvPr/>
         </p:nvSpPr>
@@ -4565,7 +5698,7 @@
       </p:sp>
       <p:sp>
         <p:nvSpPr>
-          <p:cNvPr id="25" name="Text 23"/>
+          <p:cNvPr id="27" name="Text 25"/>
           <p:cNvSpPr txBox="1"/>
           <p:nvPr/>
         </p:nvSpPr>
@@ -4601,7 +5734,7 @@
       </p:sp>
       <p:sp>
         <p:nvSpPr>
-          <p:cNvPr id="26" name="Shape 24"/>
+          <p:cNvPr id="28" name="Shape 26"/>
           <p:cNvSpPr/>
           <p:nvPr/>
         </p:nvSpPr>
@@ -4626,7 +5759,7 @@
       </p:sp>
       <p:sp>
         <p:nvSpPr>
-          <p:cNvPr id="27" name="Shape 25"/>
+          <p:cNvPr id="29" name="Shape 27"/>
           <p:cNvSpPr/>
           <p:nvPr/>
         </p:nvSpPr>
@@ -4651,7 +5784,7 @@
       </p:sp>
       <p:sp>
         <p:nvSpPr>
-          <p:cNvPr id="28" name="Shape 26"/>
+          <p:cNvPr id="30" name="Shape 28"/>
           <p:cNvSpPr/>
           <p:nvPr/>
         </p:nvSpPr>
@@ -4676,7 +5809,7 @@
       </p:sp>
       <p:sp>
         <p:nvSpPr>
-          <p:cNvPr id="29" name="Text 27"/>
+          <p:cNvPr id="31" name="Text 29"/>
           <p:cNvSpPr txBox="1"/>
           <p:nvPr/>
         </p:nvSpPr>
@@ -4712,7 +5845,7 @@
       </p:sp>
       <p:sp>
         <p:nvSpPr>
-          <p:cNvPr id="30" name="Text 28"/>
+          <p:cNvPr id="32" name="Text 30"/>
           <p:cNvSpPr txBox="1"/>
           <p:nvPr/>
         </p:nvSpPr>
@@ -4748,7 +5881,7 @@
       </p:sp>
       <p:sp>
         <p:nvSpPr>
-          <p:cNvPr id="31" name="Text 29"/>
+          <p:cNvPr id="33" name="Text 31"/>
           <p:cNvSpPr txBox="1"/>
           <p:nvPr/>
         </p:nvSpPr>
@@ -4784,7 +5917,7 @@
       </p:sp>
       <p:sp>
         <p:nvSpPr>
-          <p:cNvPr id="32" name="Shape 30"/>
+          <p:cNvPr id="34" name="Shape 32"/>
           <p:cNvSpPr/>
           <p:nvPr/>
         </p:nvSpPr>
@@ -4809,7 +5942,7 @@
       </p:sp>
       <p:sp>
         <p:nvSpPr>
-          <p:cNvPr id="33" name="Shape 31"/>
+          <p:cNvPr id="35" name="Shape 33"/>
           <p:cNvSpPr/>
           <p:nvPr/>
         </p:nvSpPr>
@@ -4834,7 +5967,7 @@
       </p:sp>
       <p:sp>
         <p:nvSpPr>
-          <p:cNvPr id="34" name="Shape 32"/>
+          <p:cNvPr id="36" name="Shape 34"/>
           <p:cNvSpPr/>
           <p:nvPr/>
         </p:nvSpPr>
@@ -4859,7 +5992,7 @@
       </p:sp>
       <p:sp>
         <p:nvSpPr>
-          <p:cNvPr id="35" name="Text 33"/>
+          <p:cNvPr id="37" name="Text 35"/>
           <p:cNvSpPr txBox="1"/>
           <p:nvPr/>
         </p:nvSpPr>
@@ -4895,7 +6028,7 @@
       </p:sp>
       <p:sp>
         <p:nvSpPr>
-          <p:cNvPr id="36" name="Text 34"/>
+          <p:cNvPr id="38" name="Text 36"/>
           <p:cNvSpPr txBox="1"/>
           <p:nvPr/>
         </p:nvSpPr>
@@ -4931,7 +6064,7 @@
       </p:sp>
       <p:sp>
         <p:nvSpPr>
-          <p:cNvPr id="37" name="Text 35"/>
+          <p:cNvPr id="39" name="Text 37"/>
           <p:cNvSpPr txBox="1"/>
           <p:nvPr/>
         </p:nvSpPr>
@@ -4967,7 +6100,7 @@
       </p:sp>
       <p:sp>
         <p:nvSpPr>
-          <p:cNvPr id="38" name="Shape 36"/>
+          <p:cNvPr id="40" name="Shape 38"/>
           <p:cNvSpPr/>
           <p:nvPr/>
         </p:nvSpPr>
@@ -4976,8 +6109,10 @@
             <a:off x="457200" y="4754880"/>
             <a:ext cx="5486400" cy="1463040"/>
           </a:xfrm>
-          <a:prstGeom prst="rect">
-            <a:avLst/>
+          <a:prstGeom prst="roundRect">
+            <a:avLst>
+              <a:gd name="adj" fmla="val 7500"/>
+            </a:avLst>
           </a:prstGeom>
           <a:solidFill>
             <a:srgbClr val="EEF0EC"/>
@@ -4988,20 +6123,27 @@
             </a:solidFill>
             <a:prstDash val="solid"/>
           </a:ln>
-        </p:spPr>
-      </p:sp>
-      <p:sp>
-        <p:nvSpPr>
-          <p:cNvPr id="39" name="Shape 37"/>
+          <a:effectLst>
+            <a:outerShdw sx="100000" sy="100000" kx="0" ky="0" algn="bl" rotWithShape="0" blurRad="1.98230216442e+21" dist="660767388140000000000" dir="4.6656e+25">
+              <a:srgbClr val="000000">
+                <a:alpha val="1.8e+24"/>
+              </a:srgbClr>
+            </a:outerShdw>
+          </a:effectLst>
+        </p:spPr>
+      </p:sp>
+      <p:sp>
+        <p:nvSpPr>
+          <p:cNvPr id="41" name="Shape 39"/>
           <p:cNvSpPr/>
           <p:nvPr/>
         </p:nvSpPr>
         <p:spPr>
           <a:xfrm>
-            <a:off x="640080" y="4937760"/>
-            <a:ext cx="384048" cy="384048"/>
-          </a:xfrm>
-          <a:prstGeom prst="ellipse">
+            <a:off x="457200" y="4983480"/>
+            <a:ext cx="64008" cy="1005840"/>
+          </a:xfrm>
+          <a:prstGeom prst="rect">
             <a:avLst/>
           </a:prstGeom>
           <a:solidFill>
@@ -5017,7 +6159,32 @@
       </p:sp>
       <p:sp>
         <p:nvSpPr>
-          <p:cNvPr id="40" name="Text 38"/>
+          <p:cNvPr id="42" name="Shape 40"/>
+          <p:cNvSpPr/>
+          <p:nvPr/>
+        </p:nvSpPr>
+        <p:spPr>
+          <a:xfrm>
+            <a:off x="640080" y="4937760"/>
+            <a:ext cx="384048" cy="384048"/>
+          </a:xfrm>
+          <a:prstGeom prst="ellipse">
+            <a:avLst/>
+          </a:prstGeom>
+          <a:solidFill>
+            <a:srgbClr val="F2B705"/>
+          </a:solidFill>
+          <a:ln w="12700">
+            <a:solidFill>
+              <a:srgbClr val="F2B705"/>
+            </a:solidFill>
+            <a:prstDash val="solid"/>
+          </a:ln>
+        </p:spPr>
+      </p:sp>
+      <p:sp>
+        <p:nvSpPr>
+          <p:cNvPr id="43" name="Text 41"/>
           <p:cNvSpPr txBox="1"/>
           <p:nvPr/>
         </p:nvSpPr>
@@ -5053,7 +6220,7 @@
       </p:sp>
       <p:sp>
         <p:nvSpPr>
-          <p:cNvPr id="41" name="Text 39"/>
+          <p:cNvPr id="44" name="Text 42"/>
           <p:cNvSpPr txBox="1"/>
           <p:nvPr/>
         </p:nvSpPr>
@@ -5089,7 +6256,7 @@
       </p:sp>
       <p:sp>
         <p:nvSpPr>
-          <p:cNvPr id="42" name="Shape 40"/>
+          <p:cNvPr id="45" name="Shape 43"/>
           <p:cNvSpPr/>
           <p:nvPr/>
         </p:nvSpPr>
@@ -5098,8 +6265,10 @@
             <a:off x="6217920" y="4754880"/>
             <a:ext cx="5486400" cy="1463040"/>
           </a:xfrm>
-          <a:prstGeom prst="rect">
-            <a:avLst/>
+          <a:prstGeom prst="roundRect">
+            <a:avLst>
+              <a:gd name="adj" fmla="val 7500"/>
+            </a:avLst>
           </a:prstGeom>
           <a:solidFill>
             <a:srgbClr val="EEF0EC"/>
@@ -5110,20 +6279,27 @@
             </a:solidFill>
             <a:prstDash val="solid"/>
           </a:ln>
-        </p:spPr>
-      </p:sp>
-      <p:sp>
-        <p:nvSpPr>
-          <p:cNvPr id="43" name="Shape 41"/>
+          <a:effectLst>
+            <a:outerShdw sx="100000" sy="100000" kx="0" ky="0" algn="bl" rotWithShape="0" blurRad="2.5175237488134e+25" dist="8.391745829378e+24" dir="2.79936e+30">
+              <a:srgbClr val="000000">
+                <a:alpha val="1.8e+29"/>
+              </a:srgbClr>
+            </a:outerShdw>
+          </a:effectLst>
+        </p:spPr>
+      </p:sp>
+      <p:sp>
+        <p:nvSpPr>
+          <p:cNvPr id="46" name="Shape 44"/>
           <p:cNvSpPr/>
           <p:nvPr/>
         </p:nvSpPr>
         <p:spPr>
           <a:xfrm>
-            <a:off x="6400800" y="4937760"/>
-            <a:ext cx="384048" cy="384048"/>
-          </a:xfrm>
-          <a:prstGeom prst="ellipse">
+            <a:off x="6217920" y="4983480"/>
+            <a:ext cx="64008" cy="1005840"/>
+          </a:xfrm>
+          <a:prstGeom prst="rect">
             <a:avLst/>
           </a:prstGeom>
           <a:solidFill>
@@ -5139,7 +6315,32 @@
       </p:sp>
       <p:sp>
         <p:nvSpPr>
-          <p:cNvPr id="44" name="Text 42"/>
+          <p:cNvPr id="47" name="Shape 45"/>
+          <p:cNvSpPr/>
+          <p:nvPr/>
+        </p:nvSpPr>
+        <p:spPr>
+          <a:xfrm>
+            <a:off x="6400800" y="4937760"/>
+            <a:ext cx="384048" cy="384048"/>
+          </a:xfrm>
+          <a:prstGeom prst="ellipse">
+            <a:avLst/>
+          </a:prstGeom>
+          <a:solidFill>
+            <a:srgbClr val="8A96A0"/>
+          </a:solidFill>
+          <a:ln w="12700">
+            <a:solidFill>
+              <a:srgbClr val="8A96A0"/>
+            </a:solidFill>
+            <a:prstDash val="solid"/>
+          </a:ln>
+        </p:spPr>
+      </p:sp>
+      <p:sp>
+        <p:nvSpPr>
+          <p:cNvPr id="48" name="Text 46"/>
           <p:cNvSpPr txBox="1"/>
           <p:nvPr/>
         </p:nvSpPr>
@@ -5175,7 +6376,7 @@
       </p:sp>
       <p:sp>
         <p:nvSpPr>
-          <p:cNvPr id="45" name="Text 43"/>
+          <p:cNvPr id="49" name="Text 47"/>
           <p:cNvSpPr txBox="1"/>
           <p:nvPr/>
         </p:nvSpPr>
@@ -5259,6 +6460,9 @@
   <p:clrMapOvr>
     <a:masterClrMapping/>
   </p:clrMapOvr>
+  <p:transition spd="med">
+    <p:fade/>
+  </p:transition>
 </p:sld>
 </file>
 
@@ -5281,7 +6485,55 @@
       </p:grpSpPr>
       <p:sp>
         <p:nvSpPr>
-          <p:cNvPr id="2" name="Text 0"/>
+          <p:cNvPr id="2" name="Shape 0"/>
+          <p:cNvSpPr/>
+          <p:nvPr/>
+        </p:nvSpPr>
+        <p:spPr>
+          <a:xfrm>
+            <a:off x="457200" y="411480"/>
+            <a:ext cx="109728" cy="548640"/>
+          </a:xfrm>
+          <a:prstGeom prst="rect">
+            <a:avLst/>
+          </a:prstGeom>
+          <a:solidFill>
+            <a:srgbClr val="1F5F8B"/>
+          </a:solidFill>
+          <a:ln w="12700">
+            <a:solidFill>
+              <a:srgbClr val="1F5F8B"/>
+            </a:solidFill>
+            <a:prstDash val="solid"/>
+          </a:ln>
+        </p:spPr>
+      </p:sp>
+      <p:sp>
+        <p:nvSpPr>
+          <p:cNvPr id="3" name="Shape 1"/>
+          <p:cNvSpPr/>
+          <p:nvPr/>
+        </p:nvSpPr>
+        <p:spPr>
+          <a:xfrm>
+            <a:off x="457200" y="1143000"/>
+            <a:ext cx="11247120" cy="0"/>
+          </a:xfrm>
+          <a:prstGeom prst="line">
+            <a:avLst/>
+          </a:prstGeom>
+          <a:noFill/>
+          <a:ln w="19050">
+            <a:solidFill>
+              <a:srgbClr val="EEF0EC"/>
+            </a:solidFill>
+            <a:prstDash val="solid"/>
+          </a:ln>
+        </p:spPr>
+      </p:sp>
+      <p:sp>
+        <p:nvSpPr>
+          <p:cNvPr id="4" name="Text 0"/>
           <p:cNvSpPr/>
           <p:nvPr>
             <p:ph idx="100" type="title" hasCustomPrompt="1"/>
@@ -5289,8 +6541,8 @@
         </p:nvSpPr>
         <p:spPr>
           <a:xfrm>
-            <a:off x="457200" y="320040"/>
-            <a:ext cx="11247120" cy="731520"/>
+            <a:off x="685800" y="320040"/>
+            <a:ext cx="11018520" cy="731520"/>
           </a:xfrm>
           <a:prstGeom prst="rect">
             <a:avLst/>
@@ -5319,7 +6571,7 @@
       </p:sp>
       <p:pic>
         <p:nvPicPr>
-          <p:cNvPr id="3" name="Image 0" descr="../eval/out/flatbed_13_08_09_hongkong_by_RalfR_016_jpg.jpg">    </p:cNvPr>
+          <p:cNvPr id="5" name="Image 0" descr="../eval/out/flatbed_13_08_09_hongkong_by_RalfR_016_jpg.jpg">    </p:cNvPr>
           <p:cNvPicPr>
             <a:picLocks noChangeAspect="1"/>
           </p:cNvPicPr>
@@ -5342,7 +6594,7 @@
       </p:pic>
       <p:sp>
         <p:nvSpPr>
-          <p:cNvPr id="4" name="Text 1"/>
+          <p:cNvPr id="6" name="Text 3"/>
           <p:cNvSpPr txBox="1"/>
           <p:nvPr/>
         </p:nvSpPr>
@@ -5378,7 +6630,7 @@
       </p:sp>
       <p:sp>
         <p:nvSpPr>
-          <p:cNvPr id="5" name="Text 2"/>
+          <p:cNvPr id="7" name="Text 4"/>
           <p:cNvSpPr txBox="1"/>
           <p:nvPr/>
         </p:nvSpPr>
@@ -5414,7 +6666,7 @@
       </p:sp>
       <p:pic>
         <p:nvPicPr>
-          <p:cNvPr id="6" name="Image 1" descr="../eval/out/car_carrier_Ram_3500_DS_Towing_BMW_X5_F15_JPG.jpg">    </p:cNvPr>
+          <p:cNvPr id="8" name="Image 1" descr="../eval/out/car_carrier_Ram_3500_DS_Towing_BMW_X5_F15_JPG.jpg">    </p:cNvPr>
           <p:cNvPicPr>
             <a:picLocks noChangeAspect="1"/>
           </p:cNvPicPr>
@@ -5437,7 +6689,7 @@
       </p:pic>
       <p:sp>
         <p:nvSpPr>
-          <p:cNvPr id="7" name="Text 3"/>
+          <p:cNvPr id="9" name="Text 5"/>
           <p:cNvSpPr txBox="1"/>
           <p:nvPr/>
         </p:nvSpPr>
@@ -5473,7 +6725,7 @@
       </p:sp>
       <p:sp>
         <p:nvSpPr>
-          <p:cNvPr id="8" name="Text 4"/>
+          <p:cNvPr id="10" name="Text 6"/>
           <p:cNvSpPr txBox="1"/>
           <p:nvPr/>
         </p:nvSpPr>
@@ -5509,7 +6761,7 @@
       </p:sp>
       <p:pic>
         <p:nvPicPr>
-          <p:cNvPr id="9" name="Image 2" descr="../eval/out/oversized_Abnormal_Load_Front_End_Loader_Mammoet_Near_Ogies_15_3_2012.jpg">    </p:cNvPr>
+          <p:cNvPr id="11" name="Image 2" descr="../eval/out/oversized_Abnormal_Load_Front_End_Loader_Mammoet_Near_Ogies_15_3_2012.jpg">    </p:cNvPr>
           <p:cNvPicPr>
             <a:picLocks noChangeAspect="1"/>
           </p:cNvPicPr>
@@ -5532,7 +6784,7 @@
       </p:pic>
       <p:sp>
         <p:nvSpPr>
-          <p:cNvPr id="10" name="Text 5"/>
+          <p:cNvPr id="12" name="Text 7"/>
           <p:cNvSpPr txBox="1"/>
           <p:nvPr/>
         </p:nvSpPr>
@@ -5568,7 +6820,7 @@
       </p:sp>
       <p:sp>
         <p:nvSpPr>
-          <p:cNvPr id="11" name="Text 6"/>
+          <p:cNvPr id="13" name="Text 8"/>
           <p:cNvSpPr txBox="1"/>
           <p:nvPr/>
         </p:nvSpPr>
@@ -5604,7 +6856,7 @@
       </p:sp>
       <p:sp>
         <p:nvSpPr>
-          <p:cNvPr id="12" name="Text 7"/>
+          <p:cNvPr id="14" name="Text 9"/>
           <p:cNvSpPr txBox="1"/>
           <p:nvPr/>
         </p:nvSpPr>
@@ -5640,7 +6892,7 @@
       </p:sp>
       <p:sp>
         <p:nvSpPr>
-          <p:cNvPr id="13" name="Text 8"/>
+          <p:cNvPr id="15" name="Text 10"/>
           <p:cNvSpPr txBox="1"/>
           <p:nvPr/>
         </p:nvSpPr>
@@ -5724,6 +6976,9 @@
   <p:clrMapOvr>
     <a:masterClrMapping/>
   </p:clrMapOvr>
+  <p:transition spd="med">
+    <p:fade/>
+  </p:transition>
 </p:sld>
 </file>
 
@@ -5746,7 +7001,55 @@
       </p:grpSpPr>
       <p:sp>
         <p:nvSpPr>
-          <p:cNvPr id="2" name="Text 0"/>
+          <p:cNvPr id="2" name="Shape 0"/>
+          <p:cNvSpPr/>
+          <p:nvPr/>
+        </p:nvSpPr>
+        <p:spPr>
+          <a:xfrm>
+            <a:off x="457200" y="411480"/>
+            <a:ext cx="109728" cy="548640"/>
+          </a:xfrm>
+          <a:prstGeom prst="rect">
+            <a:avLst/>
+          </a:prstGeom>
+          <a:solidFill>
+            <a:srgbClr val="1F5F8B"/>
+          </a:solidFill>
+          <a:ln w="12700">
+            <a:solidFill>
+              <a:srgbClr val="1F5F8B"/>
+            </a:solidFill>
+            <a:prstDash val="solid"/>
+          </a:ln>
+        </p:spPr>
+      </p:sp>
+      <p:sp>
+        <p:nvSpPr>
+          <p:cNvPr id="3" name="Shape 1"/>
+          <p:cNvSpPr/>
+          <p:nvPr/>
+        </p:nvSpPr>
+        <p:spPr>
+          <a:xfrm>
+            <a:off x="457200" y="1143000"/>
+            <a:ext cx="11247120" cy="0"/>
+          </a:xfrm>
+          <a:prstGeom prst="line">
+            <a:avLst/>
+          </a:prstGeom>
+          <a:noFill/>
+          <a:ln w="19050">
+            <a:solidFill>
+              <a:srgbClr val="EEF0EC"/>
+            </a:solidFill>
+            <a:prstDash val="solid"/>
+          </a:ln>
+        </p:spPr>
+      </p:sp>
+      <p:sp>
+        <p:nvSpPr>
+          <p:cNvPr id="4" name="Text 0"/>
           <p:cNvSpPr/>
           <p:nvPr>
             <p:ph idx="100" type="title" hasCustomPrompt="1"/>
@@ -5754,8 +7057,8 @@
         </p:nvSpPr>
         <p:spPr>
           <a:xfrm>
-            <a:off x="457200" y="320040"/>
-            <a:ext cx="11247120" cy="731520"/>
+            <a:off x="685800" y="320040"/>
+            <a:ext cx="11018520" cy="731520"/>
           </a:xfrm>
           <a:prstGeom prst="rect">
             <a:avLst/>
@@ -7936,7 +9239,7 @@
       </p:graphicFrame>
       <p:sp>
         <p:nvSpPr>
-          <p:cNvPr id="4" name="Text 1"/>
+          <p:cNvPr id="6" name="Text 3"/>
           <p:cNvSpPr txBox="1"/>
           <p:nvPr/>
         </p:nvSpPr>
@@ -9412,7 +10715,7 @@
       </p:graphicFrame>
       <p:sp>
         <p:nvSpPr>
-          <p:cNvPr id="6" name="Text 2"/>
+          <p:cNvPr id="8" name="Text 4"/>
           <p:cNvSpPr txBox="1"/>
           <p:nvPr/>
         </p:nvSpPr>
@@ -9448,7 +10751,7 @@
       </p:sp>
       <p:sp>
         <p:nvSpPr>
-          <p:cNvPr id="7" name="Text 3"/>
+          <p:cNvPr id="9" name="Text 5"/>
           <p:cNvSpPr txBox="1"/>
           <p:nvPr/>
         </p:nvSpPr>
@@ -9487,7 +10790,7 @@
       </p:sp>
       <p:sp>
         <p:nvSpPr>
-          <p:cNvPr id="8" name="Text 4"/>
+          <p:cNvPr id="10" name="Text 6"/>
           <p:cNvSpPr txBox="1"/>
           <p:nvPr/>
         </p:nvSpPr>
@@ -9523,7 +10826,7 @@
       </p:sp>
       <p:sp>
         <p:nvSpPr>
-          <p:cNvPr id="9" name="Text 5"/>
+          <p:cNvPr id="11" name="Text 7"/>
           <p:cNvSpPr txBox="1"/>
           <p:nvPr/>
         </p:nvSpPr>
@@ -9562,7 +10865,7 @@
       </p:sp>
       <p:sp>
         <p:nvSpPr>
-          <p:cNvPr id="10" name="Text 6"/>
+          <p:cNvPr id="12" name="Text 8"/>
           <p:cNvSpPr txBox="1"/>
           <p:nvPr/>
         </p:nvSpPr>
@@ -9598,7 +10901,7 @@
       </p:sp>
       <p:sp>
         <p:nvSpPr>
-          <p:cNvPr id="11" name="Text 7"/>
+          <p:cNvPr id="13" name="Text 9"/>
           <p:cNvSpPr txBox="1"/>
           <p:nvPr/>
         </p:nvSpPr>
@@ -9637,7 +10940,7 @@
       </p:sp>
       <p:sp>
         <p:nvSpPr>
-          <p:cNvPr id="12" name="Text 8"/>
+          <p:cNvPr id="14" name="Text 10"/>
           <p:cNvSpPr txBox="1"/>
           <p:nvPr/>
         </p:nvSpPr>
@@ -9673,7 +10976,7 @@
       </p:sp>
       <p:sp>
         <p:nvSpPr>
-          <p:cNvPr id="13" name="Text 9"/>
+          <p:cNvPr id="15" name="Text 11"/>
           <p:cNvSpPr txBox="1"/>
           <p:nvPr/>
         </p:nvSpPr>
@@ -9712,7 +11015,7 @@
       </p:sp>
       <p:sp>
         <p:nvSpPr>
-          <p:cNvPr id="14" name="Text 10"/>
+          <p:cNvPr id="16" name="Text 12"/>
           <p:cNvSpPr txBox="1"/>
           <p:nvPr/>
         </p:nvSpPr>
@@ -9796,6 +11099,9 @@
   <p:clrMapOvr>
     <a:masterClrMapping/>
   </p:clrMapOvr>
+  <p:transition spd="med">
+    <p:fade/>
+  </p:transition>
 </p:sld>
 </file>
 
@@ -9818,7 +11124,55 @@
       </p:grpSpPr>
       <p:sp>
         <p:nvSpPr>
-          <p:cNvPr id="2" name="Text 0"/>
+          <p:cNvPr id="2" name="Shape 0"/>
+          <p:cNvSpPr/>
+          <p:nvPr/>
+        </p:nvSpPr>
+        <p:spPr>
+          <a:xfrm>
+            <a:off x="457200" y="411480"/>
+            <a:ext cx="109728" cy="548640"/>
+          </a:xfrm>
+          <a:prstGeom prst="rect">
+            <a:avLst/>
+          </a:prstGeom>
+          <a:solidFill>
+            <a:srgbClr val="1F5F8B"/>
+          </a:solidFill>
+          <a:ln w="12700">
+            <a:solidFill>
+              <a:srgbClr val="1F5F8B"/>
+            </a:solidFill>
+            <a:prstDash val="solid"/>
+          </a:ln>
+        </p:spPr>
+      </p:sp>
+      <p:sp>
+        <p:nvSpPr>
+          <p:cNvPr id="3" name="Shape 1"/>
+          <p:cNvSpPr/>
+          <p:nvPr/>
+        </p:nvSpPr>
+        <p:spPr>
+          <a:xfrm>
+            <a:off x="457200" y="1143000"/>
+            <a:ext cx="11247120" cy="0"/>
+          </a:xfrm>
+          <a:prstGeom prst="line">
+            <a:avLst/>
+          </a:prstGeom>
+          <a:noFill/>
+          <a:ln w="19050">
+            <a:solidFill>
+              <a:srgbClr val="EEF0EC"/>
+            </a:solidFill>
+            <a:prstDash val="solid"/>
+          </a:ln>
+        </p:spPr>
+      </p:sp>
+      <p:sp>
+        <p:nvSpPr>
+          <p:cNvPr id="4" name="Text 0"/>
           <p:cNvSpPr/>
           <p:nvPr>
             <p:ph idx="100" type="title" hasCustomPrompt="1"/>
@@ -9826,8 +11180,8 @@
         </p:nvSpPr>
         <p:spPr>
           <a:xfrm>
-            <a:off x="457200" y="320040"/>
-            <a:ext cx="11247120" cy="731520"/>
+            <a:off x="685800" y="320040"/>
+            <a:ext cx="11018520" cy="731520"/>
           </a:xfrm>
           <a:prstGeom prst="rect">
             <a:avLst/>
@@ -9856,7 +11210,7 @@
       </p:sp>
       <p:pic>
         <p:nvPicPr>
-          <p:cNvPr id="3" name="Image 0" descr="../eval/out/raw/overloaded/overloaded_1931_jpg.jpg">    </p:cNvPr>
+          <p:cNvPr id="5" name="Image 0" descr="../eval/out/raw/overloaded/overloaded_1931_jpg.jpg">    </p:cNvPr>
           <p:cNvPicPr>
             <a:picLocks noChangeAspect="1"/>
           </p:cNvPicPr>
@@ -9879,7 +11233,7 @@
       </p:pic>
       <p:sp>
         <p:nvSpPr>
-          <p:cNvPr id="4" name="Text 1"/>
+          <p:cNvPr id="6" name="Text 3"/>
           <p:cNvSpPr txBox="1"/>
           <p:nvPr/>
         </p:nvSpPr>
@@ -9915,7 +11269,7 @@
       </p:sp>
       <p:pic>
         <p:nvPicPr>
-          <p:cNvPr id="5" name="Image 1" descr="../eval/out/raw/car_carrier/car_carrier_080625_A_3715G_225_2668149320_jpg.jpg">    </p:cNvPr>
+          <p:cNvPr id="7" name="Image 1" descr="../eval/out/raw/car_carrier/car_carrier_080625_A_3715G_225_2668149320_jpg.jpg">    </p:cNvPr>
           <p:cNvPicPr>
             <a:picLocks noChangeAspect="1"/>
           </p:cNvPicPr>
@@ -9938,7 +11292,7 @@
       </p:pic>
       <p:sp>
         <p:nvSpPr>
-          <p:cNvPr id="6" name="Text 2"/>
+          <p:cNvPr id="8" name="Text 4"/>
           <p:cNvSpPr txBox="1"/>
           <p:nvPr/>
         </p:nvSpPr>
@@ -9974,7 +11328,7 @@
       </p:sp>
       <p:pic>
         <p:nvPicPr>
-          <p:cNvPr id="7" name="Image 2" descr="../eval/out/raw/night/night_Anime_billboards_in_Akihabara_2012_09_18_jpg.jpg">    </p:cNvPr>
+          <p:cNvPr id="9" name="Image 2" descr="../eval/out/raw/night/night_Anime_billboards_in_Akihabara_2012_09_18_jpg.jpg">    </p:cNvPr>
           <p:cNvPicPr>
             <a:picLocks noChangeAspect="1"/>
           </p:cNvPicPr>
@@ -9997,7 +11351,7 @@
       </p:pic>
       <p:sp>
         <p:nvSpPr>
-          <p:cNvPr id="8" name="Text 3"/>
+          <p:cNvPr id="10" name="Text 5"/>
           <p:cNvSpPr txBox="1"/>
           <p:nvPr/>
         </p:nvSpPr>
@@ -10033,7 +11387,7 @@
       </p:sp>
       <p:sp>
         <p:nvSpPr>
-          <p:cNvPr id="9" name="Shape 4"/>
+          <p:cNvPr id="11" name="Shape 6"/>
           <p:cNvSpPr/>
           <p:nvPr/>
         </p:nvSpPr>
@@ -10042,8 +11396,10 @@
             <a:off x="457200" y="5394960"/>
             <a:ext cx="11247120" cy="868680"/>
           </a:xfrm>
-          <a:prstGeom prst="rect">
-            <a:avLst/>
+          <a:prstGeom prst="roundRect">
+            <a:avLst>
+              <a:gd name="adj" fmla="val 12632"/>
+            </a:avLst>
           </a:prstGeom>
           <a:solidFill>
             <a:srgbClr val="EEF0EC"/>
@@ -10054,20 +11410,27 @@
             </a:solidFill>
             <a:prstDash val="solid"/>
           </a:ln>
-        </p:spPr>
-      </p:sp>
-      <p:sp>
-        <p:nvSpPr>
-          <p:cNvPr id="10" name="Shape 5"/>
+          <a:effectLst>
+            <a:outerShdw sx="100000" sy="100000" kx="0" ky="0" algn="bl" rotWithShape="0" blurRad="3.197255160993018e+29" dist="1.0657517203310059e+29" dir="1.6796159999999998e+35">
+              <a:srgbClr val="000000">
+                <a:alpha val="1.7999999999999998e+34"/>
+              </a:srgbClr>
+            </a:outerShdw>
+          </a:effectLst>
+        </p:spPr>
+      </p:sp>
+      <p:sp>
+        <p:nvSpPr>
+          <p:cNvPr id="12" name="Shape 7"/>
           <p:cNvSpPr/>
           <p:nvPr/>
         </p:nvSpPr>
         <p:spPr>
           <a:xfrm>
-            <a:off x="640080" y="5577840"/>
-            <a:ext cx="384048" cy="384048"/>
-          </a:xfrm>
-          <a:prstGeom prst="ellipse">
+            <a:off x="457200" y="5623560"/>
+            <a:ext cx="64008" cy="411480"/>
+          </a:xfrm>
+          <a:prstGeom prst="rect">
             <a:avLst/>
           </a:prstGeom>
           <a:solidFill>
@@ -10083,7 +11446,32 @@
       </p:sp>
       <p:sp>
         <p:nvSpPr>
-          <p:cNvPr id="11" name="Text 6"/>
+          <p:cNvPr id="13" name="Shape 8"/>
+          <p:cNvSpPr/>
+          <p:nvPr/>
+        </p:nvSpPr>
+        <p:spPr>
+          <a:xfrm>
+            <a:off x="640080" y="5577840"/>
+            <a:ext cx="384048" cy="384048"/>
+          </a:xfrm>
+          <a:prstGeom prst="ellipse">
+            <a:avLst/>
+          </a:prstGeom>
+          <a:solidFill>
+            <a:srgbClr val="C9781A"/>
+          </a:solidFill>
+          <a:ln w="12700">
+            <a:solidFill>
+              <a:srgbClr val="C9781A"/>
+            </a:solidFill>
+            <a:prstDash val="solid"/>
+          </a:ln>
+        </p:spPr>
+      </p:sp>
+      <p:sp>
+        <p:nvSpPr>
+          <p:cNvPr id="14" name="Text 9"/>
           <p:cNvSpPr txBox="1"/>
           <p:nvPr/>
         </p:nvSpPr>
@@ -10119,7 +11507,7 @@
       </p:sp>
       <p:sp>
         <p:nvSpPr>
-          <p:cNvPr id="12" name="Text 7"/>
+          <p:cNvPr id="15" name="Text 10"/>
           <p:cNvSpPr txBox="1"/>
           <p:nvPr/>
         </p:nvSpPr>
@@ -10203,6 +11591,9 @@
   <p:clrMapOvr>
     <a:masterClrMapping/>
   </p:clrMapOvr>
+  <p:transition spd="med">
+    <p:fade/>
+  </p:transition>
 </p:sld>
 </file>
 
@@ -10225,7 +11616,88 @@
       </p:grpSpPr>
       <p:sp>
         <p:nvSpPr>
-          <p:cNvPr id="2" name="Text 0"/>
+          <p:cNvPr id="2" name="Shape 0"/>
+          <p:cNvSpPr/>
+          <p:nvPr/>
+        </p:nvSpPr>
+        <p:spPr>
+          <a:xfrm>
+            <a:off x="8778240" y="-1463040"/>
+            <a:ext cx="4754880" cy="4754880"/>
+          </a:xfrm>
+          <a:prstGeom prst="ellipse">
+            <a:avLst/>
+          </a:prstGeom>
+          <a:solidFill>
+            <a:srgbClr val="1F5F8B">
+              <a:alpha val="28000"/>
+            </a:srgbClr>
+          </a:solidFill>
+          <a:ln w="12700">
+            <a:solidFill>
+              <a:srgbClr val="1F5F8B"/>
+            </a:solidFill>
+            <a:prstDash val="solid"/>
+          </a:ln>
+        </p:spPr>
+      </p:sp>
+      <p:sp>
+        <p:nvSpPr>
+          <p:cNvPr id="3" name="Shape 1"/>
+          <p:cNvSpPr/>
+          <p:nvPr/>
+        </p:nvSpPr>
+        <p:spPr>
+          <a:xfrm>
+            <a:off x="-1280160" y="4206240"/>
+            <a:ext cx="3657600" cy="3657600"/>
+          </a:xfrm>
+          <a:prstGeom prst="ellipse">
+            <a:avLst/>
+          </a:prstGeom>
+          <a:solidFill>
+            <a:srgbClr val="F2B705">
+              <a:alpha val="16000"/>
+            </a:srgbClr>
+          </a:solidFill>
+          <a:ln w="12700">
+            <a:solidFill>
+              <a:srgbClr val="F2B705"/>
+            </a:solidFill>
+            <a:prstDash val="solid"/>
+          </a:ln>
+        </p:spPr>
+      </p:sp>
+      <p:sp>
+        <p:nvSpPr>
+          <p:cNvPr id="4" name="Shape 2"/>
+          <p:cNvSpPr/>
+          <p:nvPr/>
+        </p:nvSpPr>
+        <p:spPr>
+          <a:xfrm>
+            <a:off x="10607040" y="4937760"/>
+            <a:ext cx="2377440" cy="2377440"/>
+          </a:xfrm>
+          <a:prstGeom prst="ellipse">
+            <a:avLst/>
+          </a:prstGeom>
+          <a:solidFill>
+            <a:srgbClr val="2A8A4A">
+              <a:alpha val="20000"/>
+            </a:srgbClr>
+          </a:solidFill>
+          <a:ln w="12700">
+            <a:solidFill>
+              <a:srgbClr val="2A8A4A"/>
+            </a:solidFill>
+            <a:prstDash val="solid"/>
+          </a:ln>
+        </p:spPr>
+      </p:sp>
+      <p:sp>
+        <p:nvSpPr>
+          <p:cNvPr id="5" name="Text 3"/>
           <p:cNvSpPr txBox="1"/>
           <p:nvPr/>
         </p:nvSpPr>
@@ -10264,7 +11736,7 @@
       </p:sp>
       <p:sp>
         <p:nvSpPr>
-          <p:cNvPr id="3" name="Text 1"/>
+          <p:cNvPr id="6" name="Text 4"/>
           <p:cNvSpPr txBox="1"/>
           <p:nvPr/>
         </p:nvSpPr>
@@ -10300,7 +11772,7 @@
       </p:sp>
       <p:sp>
         <p:nvSpPr>
-          <p:cNvPr id="4" name="Text 2"/>
+          <p:cNvPr id="7" name="Text 5"/>
           <p:cNvSpPr txBox="1"/>
           <p:nvPr/>
         </p:nvSpPr>
@@ -10376,7 +11848,7 @@
       </p:sp>
       <p:sp>
         <p:nvSpPr>
-          <p:cNvPr id="5" name="Text 3"/>
+          <p:cNvPr id="8" name="Text 6"/>
           <p:cNvSpPr txBox="1"/>
           <p:nvPr/>
         </p:nvSpPr>
@@ -10412,7 +11884,7 @@
       </p:sp>
       <p:sp>
         <p:nvSpPr>
-          <p:cNvPr id="6" name="Text 4"/>
+          <p:cNvPr id="9" name="Text 7"/>
           <p:cNvSpPr txBox="1"/>
           <p:nvPr/>
         </p:nvSpPr>
@@ -10572,6 +12044,9 @@
   <p:clrMapOvr>
     <a:masterClrMapping/>
   </p:clrMapOvr>
+  <p:transition spd="med">
+    <p:fade/>
+  </p:transition>
 </p:sld>
 </file>
 
@@ -10594,7 +12069,55 @@
       </p:grpSpPr>
       <p:sp>
         <p:nvSpPr>
-          <p:cNvPr id="2" name="Text 0"/>
+          <p:cNvPr id="2" name="Shape 0"/>
+          <p:cNvSpPr/>
+          <p:nvPr/>
+        </p:nvSpPr>
+        <p:spPr>
+          <a:xfrm>
+            <a:off x="457200" y="411480"/>
+            <a:ext cx="109728" cy="548640"/>
+          </a:xfrm>
+          <a:prstGeom prst="rect">
+            <a:avLst/>
+          </a:prstGeom>
+          <a:solidFill>
+            <a:srgbClr val="2A8A4A"/>
+          </a:solidFill>
+          <a:ln w="12700">
+            <a:solidFill>
+              <a:srgbClr val="2A8A4A"/>
+            </a:solidFill>
+            <a:prstDash val="solid"/>
+          </a:ln>
+        </p:spPr>
+      </p:sp>
+      <p:sp>
+        <p:nvSpPr>
+          <p:cNvPr id="3" name="Shape 1"/>
+          <p:cNvSpPr/>
+          <p:nvPr/>
+        </p:nvSpPr>
+        <p:spPr>
+          <a:xfrm>
+            <a:off x="457200" y="1143000"/>
+            <a:ext cx="11247120" cy="0"/>
+          </a:xfrm>
+          <a:prstGeom prst="line">
+            <a:avLst/>
+          </a:prstGeom>
+          <a:noFill/>
+          <a:ln w="19050">
+            <a:solidFill>
+              <a:srgbClr val="EEF0EC"/>
+            </a:solidFill>
+            <a:prstDash val="solid"/>
+          </a:ln>
+        </p:spPr>
+      </p:sp>
+      <p:sp>
+        <p:nvSpPr>
+          <p:cNvPr id="4" name="Text 0"/>
           <p:cNvSpPr/>
           <p:nvPr>
             <p:ph idx="100" type="title" hasCustomPrompt="1"/>
@@ -10602,8 +12125,8 @@
         </p:nvSpPr>
         <p:spPr>
           <a:xfrm>
-            <a:off x="457200" y="320040"/>
-            <a:ext cx="11247120" cy="731520"/>
+            <a:off x="685800" y="320040"/>
+            <a:ext cx="11018520" cy="731520"/>
           </a:xfrm>
           <a:prstGeom prst="rect">
             <a:avLst/>
@@ -12648,7 +14171,7 @@
       </p:graphicFrame>
       <p:sp>
         <p:nvSpPr>
-          <p:cNvPr id="5" name="Shape 1"/>
+          <p:cNvPr id="7" name="Shape 3"/>
           <p:cNvSpPr/>
           <p:nvPr/>
         </p:nvSpPr>
@@ -12657,8 +14180,10 @@
             <a:off x="457200" y="4206240"/>
             <a:ext cx="5760720" cy="2011680"/>
           </a:xfrm>
-          <a:prstGeom prst="rect">
-            <a:avLst/>
+          <a:prstGeom prst="roundRect">
+            <a:avLst>
+              <a:gd name="adj" fmla="val 5455"/>
+            </a:avLst>
           </a:prstGeom>
           <a:solidFill>
             <a:srgbClr val="EEF0EC"/>
@@ -12669,20 +14194,27 @@
             </a:solidFill>
             <a:prstDash val="solid"/>
           </a:ln>
-        </p:spPr>
-      </p:sp>
-      <p:sp>
-        <p:nvSpPr>
-          <p:cNvPr id="6" name="Shape 2"/>
+          <a:effectLst>
+            <a:outerShdw sx="100000" sy="100000" kx="0" ky="0" algn="bl" rotWithShape="0" blurRad="4.0605140544611325e+33" dist="1.3535046848203775e+33" dir="1.0077695999999999e+40">
+              <a:srgbClr val="000000">
+                <a:alpha val="1.8e+39"/>
+              </a:srgbClr>
+            </a:outerShdw>
+          </a:effectLst>
+        </p:spPr>
+      </p:sp>
+      <p:sp>
+        <p:nvSpPr>
+          <p:cNvPr id="8" name="Shape 4"/>
           <p:cNvSpPr/>
           <p:nvPr/>
         </p:nvSpPr>
         <p:spPr>
           <a:xfrm>
-            <a:off x="640080" y="4389120"/>
-            <a:ext cx="384048" cy="384048"/>
-          </a:xfrm>
-          <a:prstGeom prst="ellipse">
+            <a:off x="457200" y="4434840"/>
+            <a:ext cx="64008" cy="1554480"/>
+          </a:xfrm>
+          <a:prstGeom prst="rect">
             <a:avLst/>
           </a:prstGeom>
           <a:solidFill>
@@ -12698,7 +14230,32 @@
       </p:sp>
       <p:sp>
         <p:nvSpPr>
-          <p:cNvPr id="7" name="Text 3"/>
+          <p:cNvPr id="9" name="Shape 5"/>
+          <p:cNvSpPr/>
+          <p:nvPr/>
+        </p:nvSpPr>
+        <p:spPr>
+          <a:xfrm>
+            <a:off x="640080" y="4389120"/>
+            <a:ext cx="384048" cy="384048"/>
+          </a:xfrm>
+          <a:prstGeom prst="ellipse">
+            <a:avLst/>
+          </a:prstGeom>
+          <a:solidFill>
+            <a:srgbClr val="1F5F8B"/>
+          </a:solidFill>
+          <a:ln w="12700">
+            <a:solidFill>
+              <a:srgbClr val="1F5F8B"/>
+            </a:solidFill>
+            <a:prstDash val="solid"/>
+          </a:ln>
+        </p:spPr>
+      </p:sp>
+      <p:sp>
+        <p:nvSpPr>
+          <p:cNvPr id="10" name="Text 6"/>
           <p:cNvSpPr txBox="1"/>
           <p:nvPr/>
         </p:nvSpPr>
@@ -12734,7 +14291,7 @@
       </p:sp>
       <p:sp>
         <p:nvSpPr>
-          <p:cNvPr id="8" name="Text 4"/>
+          <p:cNvPr id="11" name="Text 7"/>
           <p:cNvSpPr txBox="1"/>
           <p:nvPr/>
         </p:nvSpPr>
@@ -12770,7 +14327,7 @@
       </p:sp>
       <p:sp>
         <p:nvSpPr>
-          <p:cNvPr id="9" name="Shape 5"/>
+          <p:cNvPr id="12" name="Shape 8"/>
           <p:cNvSpPr/>
           <p:nvPr/>
         </p:nvSpPr>
@@ -12779,8 +14336,10 @@
             <a:off x="6400800" y="4206240"/>
             <a:ext cx="5303520" cy="2011680"/>
           </a:xfrm>
-          <a:prstGeom prst="rect">
-            <a:avLst/>
+          <a:prstGeom prst="roundRect">
+            <a:avLst>
+              <a:gd name="adj" fmla="val 5455"/>
+            </a:avLst>
           </a:prstGeom>
           <a:solidFill>
             <a:srgbClr val="EEF0EC"/>
@@ -12791,20 +14350,27 @@
             </a:solidFill>
             <a:prstDash val="solid"/>
           </a:ln>
-        </p:spPr>
-      </p:sp>
-      <p:sp>
-        <p:nvSpPr>
-          <p:cNvPr id="10" name="Shape 6"/>
+          <a:effectLst>
+            <a:outerShdw sx="100000" sy="100000" kx="0" ky="0" algn="bl" rotWithShape="0" blurRad="5.156852849165638e+37" dist="1.7189509497218795e+37" dir="6.046617599999999e+44">
+              <a:srgbClr val="000000">
+                <a:alpha val="1.8e+44"/>
+              </a:srgbClr>
+            </a:outerShdw>
+          </a:effectLst>
+        </p:spPr>
+      </p:sp>
+      <p:sp>
+        <p:nvSpPr>
+          <p:cNvPr id="13" name="Shape 9"/>
           <p:cNvSpPr/>
           <p:nvPr/>
         </p:nvSpPr>
         <p:spPr>
           <a:xfrm>
-            <a:off x="6583680" y="4389120"/>
-            <a:ext cx="384048" cy="384048"/>
-          </a:xfrm>
-          <a:prstGeom prst="ellipse">
+            <a:off x="6400800" y="4434840"/>
+            <a:ext cx="64008" cy="1554480"/>
+          </a:xfrm>
+          <a:prstGeom prst="rect">
             <a:avLst/>
           </a:prstGeom>
           <a:solidFill>
@@ -12820,7 +14386,32 @@
       </p:sp>
       <p:sp>
         <p:nvSpPr>
-          <p:cNvPr id="11" name="Text 7"/>
+          <p:cNvPr id="14" name="Shape 10"/>
+          <p:cNvSpPr/>
+          <p:nvPr/>
+        </p:nvSpPr>
+        <p:spPr>
+          <a:xfrm>
+            <a:off x="6583680" y="4389120"/>
+            <a:ext cx="384048" cy="384048"/>
+          </a:xfrm>
+          <a:prstGeom prst="ellipse">
+            <a:avLst/>
+          </a:prstGeom>
+          <a:solidFill>
+            <a:srgbClr val="2A8A4A"/>
+          </a:solidFill>
+          <a:ln w="12700">
+            <a:solidFill>
+              <a:srgbClr val="2A8A4A"/>
+            </a:solidFill>
+            <a:prstDash val="solid"/>
+          </a:ln>
+        </p:spPr>
+      </p:sp>
+      <p:sp>
+        <p:nvSpPr>
+          <p:cNvPr id="15" name="Text 11"/>
           <p:cNvSpPr txBox="1"/>
           <p:nvPr/>
         </p:nvSpPr>
@@ -12856,7 +14447,7 @@
       </p:sp>
       <p:sp>
         <p:nvSpPr>
-          <p:cNvPr id="12" name="Text 8"/>
+          <p:cNvPr id="16" name="Text 12"/>
           <p:cNvSpPr txBox="1"/>
           <p:nvPr/>
         </p:nvSpPr>
@@ -12940,6 +14531,9 @@
   <p:clrMapOvr>
     <a:masterClrMapping/>
   </p:clrMapOvr>
+  <p:transition spd="med">
+    <p:fade/>
+  </p:transition>
 </p:sld>
 </file>
 

</xml_diff>

<commit_message>
Deck: transparent cat GIF, PDF rendered with Caladea so titles keep Cambria metrics
Co-Authored-By: Claude Fable 5.1 <noreply@anthropic.com>
</commit_message>
<xml_diff>
--- a/deck/LoadSafetyGate_deck.pptx
+++ b/deck/LoadSafetyGate_deck.pptx
@@ -117,22 +117,22 @@
   <p:extLst>
     <p:ext uri="{521415D9-36F7-43E2-AB2F-B90AF26B5E84}">
       <p14:sectionLst xmlns:p14="http://schemas.microsoft.com/office/powerpoint/2010/main">
-        <p14:section name="Opening" id="{8426936e-308e-86f5-e3e6-46ecdd8cc8b8}">
+        <p14:section name="Opening" id="{35ded8ae-8e42-b2fa-b4e9-d73eb5c426e7}">
           <p14:sldIdLst>
             <p14:sldId id="256"/>
           </p14:sldIdLst>
         </p14:section>
-        <p14:section name="Problem" id="{392484ad-cceb-b466-f494-42f1ab00ff71}">
+        <p14:section name="Problem" id="{2f91ef71-4ff6-d7de-284a-041e6f066b1e}">
           <p14:sldIdLst>
             <p14:sldId id="257"/>
           </p14:sldIdLst>
         </p14:section>
-        <p14:section name="Demo" id="{33744c6a-54f8-a9c2-425e-78ee8cbf8e29}">
+        <p14:section name="Demo" id="{0ca2d9c2-0cdc-39a5-ef24-3032ab033894}">
           <p14:sldIdLst>
             <p14:sldId id="258"/>
           </p14:sldIdLst>
         </p14:section>
-        <p14:section name="Technology" id="{95512579-e881-5331-439e-6b55348fe19c}">
+        <p14:section name="Technology" id="{cfbc1857-ef51-f86a-0c72-920d6cc51239}">
           <p14:sldIdLst>
             <p14:sldId id="259"/>
             <p14:sldId id="260"/>
@@ -141,7 +141,7 @@
             <p14:sldId id="263"/>
           </p14:sldIdLst>
         </p14:section>
-        <p14:section name="Business" id="{27dddc89-fe20-2940-3a23-e6c5e59871da}">
+        <p14:section name="Business" id="{4adf1849-d75f-45b2-0da7-7fe66d75853d}">
           <p14:sldIdLst>
             <p14:sldId id="264"/>
             <p14:sldId id="265"/>

</xml_diff>

<commit_message>
Deck: redrawn dancing cat, 24 antialiased frames, generator script kept in deck/make_cat.py
Co-Authored-By: Claude Fable 5.1 <noreply@anthropic.com>
</commit_message>
<xml_diff>
--- a/deck/LoadSafetyGate_deck.pptx
+++ b/deck/LoadSafetyGate_deck.pptx
@@ -117,22 +117,22 @@
   <p:extLst>
     <p:ext uri="{521415D9-36F7-43E2-AB2F-B90AF26B5E84}">
       <p14:sectionLst xmlns:p14="http://schemas.microsoft.com/office/powerpoint/2010/main">
-        <p14:section name="Opening" id="{72715292-408a-c4fa-0ca3-d3ed759f93fd}">
+        <p14:section name="Opening" id="{350c43b9-e1ec-51f4-b738-d3b8bec0e05e}">
           <p14:sldIdLst>
             <p14:sldId id="256"/>
           </p14:sldIdLst>
         </p14:section>
-        <p14:section name="Problem" id="{7ff16dca-351d-53ac-9d38-8d9b69fdac67}">
+        <p14:section name="Problem" id="{b96a3707-14fc-0e8b-1c67-a300ca954942}">
           <p14:sldIdLst>
             <p14:sldId id="257"/>
           </p14:sldIdLst>
         </p14:section>
-        <p14:section name="Demo" id="{64ebb1cf-c33f-137e-c20c-ca5ae82d23eb}">
+        <p14:section name="Demo" id="{f994aefc-5caa-e284-db7b-ef2b64e6a14d}">
           <p14:sldIdLst>
             <p14:sldId id="258"/>
           </p14:sldIdLst>
         </p14:section>
-        <p14:section name="Technology" id="{e6502b5b-d6ca-7a17-c2e2-84b0028f7ee1}">
+        <p14:section name="Technology" id="{5ebd7493-2ce4-1c9a-9122-4fc347e40425}">
           <p14:sldIdLst>
             <p14:sldId id="259"/>
             <p14:sldId id="260"/>
@@ -141,7 +141,7 @@
             <p14:sldId id="263"/>
           </p14:sldIdLst>
         </p14:section>
-        <p14:section name="Business" id="{a524eb49-8317-2046-80f8-a495c5814e59}">
+        <p14:section name="Business" id="{3db94292-f941-46a1-98cb-9a90b45c9260}">
           <p14:sldIdLst>
             <p14:sldId id="264"/>
             <p14:sldId id="265"/>

</xml_diff>

<commit_message>
Oblique-view roll reading at fail level shown as WARN; carried vehicles count as cargo; flatbed wheel bound; over-height fp 3 -> 2, specificity 91%
Co-Authored-By: Claude Fable 5.1 <noreply@anthropic.com>
</commit_message>
<xml_diff>
--- a/deck/LoadSafetyGate_deck.pptx
+++ b/deck/LoadSafetyGate_deck.pptx
@@ -117,22 +117,22 @@
   <p:extLst>
     <p:ext uri="{521415D9-36F7-43E2-AB2F-B90AF26B5E84}">
       <p14:sectionLst xmlns:p14="http://schemas.microsoft.com/office/powerpoint/2010/main">
-        <p14:section name="Opening" id="{350c43b9-e1ec-51f4-b738-d3b8bec0e05e}">
+        <p14:section name="Opening" id="{d9e16fe3-5e9f-fb8c-93cf-438591674e78}">
           <p14:sldIdLst>
             <p14:sldId id="256"/>
           </p14:sldIdLst>
         </p14:section>
-        <p14:section name="Problem" id="{b96a3707-14fc-0e8b-1c67-a300ca954942}">
+        <p14:section name="Problem" id="{4cfb8eba-0723-bd3d-a334-c663f481d322}">
           <p14:sldIdLst>
             <p14:sldId id="257"/>
           </p14:sldIdLst>
         </p14:section>
-        <p14:section name="Demo" id="{f994aefc-5caa-e284-db7b-ef2b64e6a14d}">
+        <p14:section name="Demo" id="{3fd18838-dc0c-c104-5f12-2a58d973a5ed}">
           <p14:sldIdLst>
             <p14:sldId id="258"/>
           </p14:sldIdLst>
         </p14:section>
-        <p14:section name="Technology" id="{5ebd7493-2ce4-1c9a-9122-4fc347e40425}">
+        <p14:section name="Technology" id="{f9a44bd9-beb1-aa10-85db-abae303ce862}">
           <p14:sldIdLst>
             <p14:sldId id="259"/>
             <p14:sldId id="260"/>
@@ -141,7 +141,7 @@
             <p14:sldId id="263"/>
           </p14:sldIdLst>
         </p14:section>
-        <p14:section name="Business" id="{3db94292-f941-46a1-98cb-9a90b45c9260}">
+        <p14:section name="Business" id="{5fdf26c8-529a-286d-75a0-3fac376dac9c}">
           <p14:sldIdLst>
             <p14:sldId id="264"/>
             <p14:sldId id="265"/>
@@ -10363,7 +10363,7 @@
                             <a:schemeClr val="tx1"/>
                           </a:solidFill>
                         </a:rPr>
-                        <a:t>0.57</a:t>
+                        <a:t>0.67</a:t>
                       </a:r>
                       <a:endParaRPr lang="en-US" sz="1200" dirty="0"/>
                     </a:p>
@@ -10479,7 +10479,7 @@
                             <a:schemeClr val="tx1"/>
                           </a:solidFill>
                         </a:rPr>
-                        <a:t>4/3/13</a:t>
+                        <a:t>4/2/13</a:t>
                       </a:r>
                       <a:endParaRPr lang="en-US" sz="1200" dirty="0"/>
                     </a:p>
@@ -10597,7 +10597,7 @@
                             <a:schemeClr val="tx1"/>
                           </a:solidFill>
                         </a:rPr>
-                        <a:t>39 of 44</a:t>
+                        <a:t>40 of 44</a:t>
                       </a:r>
                       <a:endParaRPr lang="en-US" sz="1200" dirty="0"/>
                     </a:p>
@@ -10705,7 +10705,7 @@
                             <a:schemeClr val="tx1"/>
                           </a:solidFill>
                         </a:rPr>
-                        <a:t>89% specificity</a:t>
+                        <a:t>91% specificity</a:t>
                       </a:r>
                       <a:endParaRPr lang="en-US" sz="1200" dirty="0"/>
                     </a:p>
@@ -10784,7 +10784,7 @@
                   <a:schemeClr val="tx2"/>
                 </a:solidFill>
               </a:rPr>
-              <a:t>Against 101 team-labelled images, 61 of them three-quarter views. Honest result: the phone mode is conservative. 89% of clean trucks pass without a false alarm, but it caught only 6 of 41 labelled positives, mostly three-quarter views where no scale object is visible. The calibrated gate camera is the fix, not a bigger model.</a:t>
+              <a:t>Against 101 team-labelled images, 61 of them three-quarter views. Honest result: the phone mode is conservative. 91% of clean trucks pass without a false alarm, but it caught only 6 of 41 labelled positives, mostly three-quarter views where no scale object is visible. The calibrated gate camera is the fix, not a bigger model.</a:t>
             </a:r>
             <a:endParaRPr lang="en-US" sz="1000" dirty="0"/>
           </a:p>

</xml_diff>